<commit_message>
Align inbox UI with final product mockup
</commit_message>
<xml_diff>
--- a/06_demo/output/AI_Scroll_5_Minute_Presentation.pptx
+++ b/06_demo/output/AI_Scroll_5_Minute_Presentation.pptx
@@ -2,19 +2,19 @@
 <file path=ppt/presentation.xml><?xml version="1.0" encoding="utf-8"?>
 <p:presentation xmlns:p="http://schemas.openxmlformats.org/presentationml/2006/main">
   <p:sldMasterIdLst>
-    <p:sldMasterId xmlns:r="http://schemas.openxmlformats.org/officeDocument/2006/relationships" id="2147483648" r:id="R39930c1d4e734b25"/>
+    <p:sldMasterId xmlns:r="http://schemas.openxmlformats.org/officeDocument/2006/relationships" id="2147483648" r:id="Rff9d86f1dbff49fc"/>
   </p:sldMasterIdLst>
   <p:notesMasterIdLst>
-    <p:notesMasterId xmlns:r="http://schemas.openxmlformats.org/officeDocument/2006/relationships" r:id="R4ab56309349b4f9b"/>
+    <p:notesMasterId xmlns:r="http://schemas.openxmlformats.org/officeDocument/2006/relationships" r:id="R0da7708714734052"/>
   </p:notesMasterIdLst>
   <p:sldIdLst>
-    <p:sldId xmlns:r="http://schemas.openxmlformats.org/officeDocument/2006/relationships" id="256" r:id="R3d6dcc3555e34819"/>
-    <p:sldId xmlns:r="http://schemas.openxmlformats.org/officeDocument/2006/relationships" id="257" r:id="R8bf1ccd4b66a4254"/>
-    <p:sldId xmlns:r="http://schemas.openxmlformats.org/officeDocument/2006/relationships" id="258" r:id="Rc893502c4779404b"/>
-    <p:sldId xmlns:r="http://schemas.openxmlformats.org/officeDocument/2006/relationships" id="259" r:id="Rbfebf9fb8a8c4131"/>
-    <p:sldId xmlns:r="http://schemas.openxmlformats.org/officeDocument/2006/relationships" id="260" r:id="Rbe6ffbecb26c4684"/>
-    <p:sldId xmlns:r="http://schemas.openxmlformats.org/officeDocument/2006/relationships" id="261" r:id="Rc947a64121744fa2"/>
-    <p:sldId xmlns:r="http://schemas.openxmlformats.org/officeDocument/2006/relationships" id="262" r:id="R019606b8babd4d17"/>
+    <p:sldId xmlns:r="http://schemas.openxmlformats.org/officeDocument/2006/relationships" id="256" r:id="R8c5a586438ba413f"/>
+    <p:sldId xmlns:r="http://schemas.openxmlformats.org/officeDocument/2006/relationships" id="257" r:id="R22252bfa77f74dab"/>
+    <p:sldId xmlns:r="http://schemas.openxmlformats.org/officeDocument/2006/relationships" id="258" r:id="R70df10690c6a4620"/>
+    <p:sldId xmlns:r="http://schemas.openxmlformats.org/officeDocument/2006/relationships" id="259" r:id="R8a7022a284b041df"/>
+    <p:sldId xmlns:r="http://schemas.openxmlformats.org/officeDocument/2006/relationships" id="260" r:id="R433ee3764fb6460f"/>
+    <p:sldId xmlns:r="http://schemas.openxmlformats.org/officeDocument/2006/relationships" id="261" r:id="R65d02308a5ee4971"/>
+    <p:sldId xmlns:r="http://schemas.openxmlformats.org/officeDocument/2006/relationships" id="262" r:id="Rc092e31c81d74288"/>
   </p:sldIdLst>
   <p:sldSz cx="12192000" cy="6858000"/>
   <p:notesSz cx="6858000" cy="9144000"/>
@@ -936,7 +936,7 @@
   </p:cSld>
   <p:clrMap bg1="lt1" tx1="dk1" bg2="lt2" tx2="dk2" accent1="accent1" accent2="accent2" accent3="accent3" accent4="accent4" accent5="accent5" accent6="accent6" hlink="hlink" folHlink="folHlink"/>
   <p:sldLayoutIdLst>
-    <p:sldLayoutId xmlns:r="http://schemas.openxmlformats.org/officeDocument/2006/relationships" id="2147483649" r:id="R507d4e4f55ac4009"/>
+    <p:sldLayoutId xmlns:r="http://schemas.openxmlformats.org/officeDocument/2006/relationships" id="2147483649" r:id="Rffa18578b73e4143"/>
   </p:sldLayoutIdLst>
   <p:txStyles>
     <p:titleStyle>
@@ -1768,7 +1768,7 @@
           <p:nvPr/>
         </p:nvPicPr>
         <p:blipFill>
-          <a:blip xmlns:r="http://schemas.openxmlformats.org/officeDocument/2006/relationships" xmlns:a="http://schemas.openxmlformats.org/drawingml/2006/main" r:embed="R761176b7e017490b"/>
+          <a:blip xmlns:r="http://schemas.openxmlformats.org/officeDocument/2006/relationships" xmlns:a="http://schemas.openxmlformats.org/drawingml/2006/main" r:embed="R96205113f8a146ee"/>
           <a:srcRect xmlns:a="http://schemas.openxmlformats.org/drawingml/2006/main" l="0" t="27" r="0" b="27"/>
           <a:stretch xmlns:a="http://schemas.openxmlformats.org/drawingml/2006/main">
             <a:fillRect l="0" t="0" r="0" b="0"/>
@@ -1789,7 +1789,7 @@
           <p:cNvPr id="2" name="">
             <a:extLst xmlns:a="http://schemas.openxmlformats.org/drawingml/2006/main">
               <a:ext uri="{FF2B5EF4-FFF2-40B4-BE49-F238E27FC236}">
-                <a16:creationId xmlns:a16="http://schemas.microsoft.com/office/drawing/2014/main" id="{10C900E5-74C3-4499-BB61-8848298E4A2E}"/>
+                <a16:creationId xmlns:a16="http://schemas.microsoft.com/office/drawing/2014/main" id="{D829CFD0-1EE5-4968-88A4-237259FC656D}"/>
               </a:ext>
             </a:extLst>
           </p:cNvPr>
@@ -1819,7 +1819,7 @@
           <p:cNvPr id="3" name="">
             <a:extLst xmlns:a="http://schemas.openxmlformats.org/drawingml/2006/main">
               <a:ext uri="{FF2B5EF4-FFF2-40B4-BE49-F238E27FC236}">
-                <a16:creationId xmlns:a16="http://schemas.microsoft.com/office/drawing/2014/main" id="{E4FF72D5-0E83-44BE-8ED4-AB36CF384054}"/>
+                <a16:creationId xmlns:a16="http://schemas.microsoft.com/office/drawing/2014/main" id="{FEB7ADF4-35DE-464F-843E-A659836D5EE8}"/>
               </a:ext>
             </a:extLst>
           </p:cNvPr>
@@ -1880,7 +1880,7 @@
           <p:cNvPr id="4" name="">
             <a:extLst xmlns:a="http://schemas.openxmlformats.org/drawingml/2006/main">
               <a:ext uri="{FF2B5EF4-FFF2-40B4-BE49-F238E27FC236}">
-                <a16:creationId xmlns:a16="http://schemas.microsoft.com/office/drawing/2014/main" id="{91E8A334-CF12-4366-8EDD-C20BA99FA426}"/>
+                <a16:creationId xmlns:a16="http://schemas.microsoft.com/office/drawing/2014/main" id="{0424F514-1E55-437F-B38C-F9D357B93C18}"/>
               </a:ext>
             </a:extLst>
           </p:cNvPr>
@@ -1941,7 +1941,7 @@
           <p:cNvPr id="5" name="">
             <a:extLst xmlns:a="http://schemas.openxmlformats.org/drawingml/2006/main">
               <a:ext uri="{FF2B5EF4-FFF2-40B4-BE49-F238E27FC236}">
-                <a16:creationId xmlns:a16="http://schemas.microsoft.com/office/drawing/2014/main" id="{D05B9729-D2B8-43BD-BB5F-1930ADF89AD3}"/>
+                <a16:creationId xmlns:a16="http://schemas.microsoft.com/office/drawing/2014/main" id="{9BBFDD64-5574-4AF4-8DCD-1A524B870AD6}"/>
               </a:ext>
             </a:extLst>
           </p:cNvPr>
@@ -1971,7 +1971,7 @@
           <p:cNvPr id="6" name="">
             <a:extLst xmlns:a="http://schemas.openxmlformats.org/drawingml/2006/main">
               <a:ext uri="{FF2B5EF4-FFF2-40B4-BE49-F238E27FC236}">
-                <a16:creationId xmlns:a16="http://schemas.microsoft.com/office/drawing/2014/main" id="{673FEFDB-5E1F-4559-8B15-BBD5A5CA79E8}"/>
+                <a16:creationId xmlns:a16="http://schemas.microsoft.com/office/drawing/2014/main" id="{92969583-30BE-493C-A8DD-1523CEAD9AB2}"/>
               </a:ext>
             </a:extLst>
           </p:cNvPr>
@@ -2059,7 +2059,7 @@
           <p:cNvPr id="7" name="">
             <a:extLst xmlns:a="http://schemas.openxmlformats.org/drawingml/2006/main">
               <a:ext uri="{FF2B5EF4-FFF2-40B4-BE49-F238E27FC236}">
-                <a16:creationId xmlns:a16="http://schemas.microsoft.com/office/drawing/2014/main" id="{1927D707-305D-4A54-A7B1-2BAEC17E6D6A}"/>
+                <a16:creationId xmlns:a16="http://schemas.microsoft.com/office/drawing/2014/main" id="{53C22C3D-9D77-4D1D-AE3F-C049D9720605}"/>
               </a:ext>
             </a:extLst>
           </p:cNvPr>
@@ -2118,7 +2118,7 @@
     </p:spTree>
     <p:extLst>
       <p:ext uri="{BB962C8B-B14F-4D97-AF65-F5344CB8AC3E}">
-        <p14:creationId xmlns:p14="http://schemas.microsoft.com/office/powerpoint/2010/main" val="1367251193"/>
+        <p14:creationId xmlns:p14="http://schemas.microsoft.com/office/powerpoint/2010/main" val="680214161"/>
       </p:ext>
     </p:extLst>
   </p:cSld>
@@ -2149,7 +2149,7 @@
           <p:cNvPr id="33" name="">
             <a:extLst xmlns:a="http://schemas.openxmlformats.org/drawingml/2006/main">
               <a:ext uri="{FF2B5EF4-FFF2-40B4-BE49-F238E27FC236}">
-                <a16:creationId xmlns:a16="http://schemas.microsoft.com/office/drawing/2014/main" id="{6A6C90B7-48ED-43A2-AE09-0BDF1BC5E8EF}"/>
+                <a16:creationId xmlns:a16="http://schemas.microsoft.com/office/drawing/2014/main" id="{50A123D2-3B46-439E-94A0-89A4AEC5C03B}"/>
               </a:ext>
             </a:extLst>
           </p:cNvPr>
@@ -2210,7 +2210,7 @@
           <p:cNvPr id="2" name="">
             <a:extLst xmlns:a="http://schemas.openxmlformats.org/drawingml/2006/main">
               <a:ext uri="{FF2B5EF4-FFF2-40B4-BE49-F238E27FC236}">
-                <a16:creationId xmlns:a16="http://schemas.microsoft.com/office/drawing/2014/main" id="{5E5C3FA3-C551-486A-96F9-8A1411029D98}"/>
+                <a16:creationId xmlns:a16="http://schemas.microsoft.com/office/drawing/2014/main" id="{47A23232-3EF3-4A5F-8C95-EE2BCFE86ACA}"/>
               </a:ext>
             </a:extLst>
           </p:cNvPr>
@@ -2271,7 +2271,7 @@
           <p:cNvPr id="3" name="">
             <a:extLst xmlns:a="http://schemas.openxmlformats.org/drawingml/2006/main">
               <a:ext uri="{FF2B5EF4-FFF2-40B4-BE49-F238E27FC236}">
-                <a16:creationId xmlns:a16="http://schemas.microsoft.com/office/drawing/2014/main" id="{63F94563-3CE7-43A0-92A1-6C4D29254957}"/>
+                <a16:creationId xmlns:a16="http://schemas.microsoft.com/office/drawing/2014/main" id="{71017535-D24F-4183-BE64-5EAF20F150E7}"/>
               </a:ext>
             </a:extLst>
           </p:cNvPr>
@@ -2301,7 +2301,7 @@
           <p:cNvPr id="4" name="">
             <a:extLst xmlns:a="http://schemas.openxmlformats.org/drawingml/2006/main">
               <a:ext uri="{FF2B5EF4-FFF2-40B4-BE49-F238E27FC236}">
-                <a16:creationId xmlns:a16="http://schemas.microsoft.com/office/drawing/2014/main" id="{8CB11A26-7769-4A67-AC53-642C0F8D880A}"/>
+                <a16:creationId xmlns:a16="http://schemas.microsoft.com/office/drawing/2014/main" id="{5A577458-ECA6-498C-AF42-D0E372AB08B5}"/>
               </a:ext>
             </a:extLst>
           </p:cNvPr>
@@ -2362,7 +2362,7 @@
           <p:cNvPr id="5" name="">
             <a:extLst xmlns:a="http://schemas.openxmlformats.org/drawingml/2006/main">
               <a:ext uri="{FF2B5EF4-FFF2-40B4-BE49-F238E27FC236}">
-                <a16:creationId xmlns:a16="http://schemas.microsoft.com/office/drawing/2014/main" id="{DAA7AC44-5291-4712-8488-C95DB55D3B28}"/>
+                <a16:creationId xmlns:a16="http://schemas.microsoft.com/office/drawing/2014/main" id="{A3C9AF38-4746-4B0F-9EAE-3BC070AB39F4}"/>
               </a:ext>
             </a:extLst>
           </p:cNvPr>
@@ -2423,7 +2423,7 @@
           <p:cNvPr id="6" name="">
             <a:extLst xmlns:a="http://schemas.openxmlformats.org/drawingml/2006/main">
               <a:ext uri="{FF2B5EF4-FFF2-40B4-BE49-F238E27FC236}">
-                <a16:creationId xmlns:a16="http://schemas.microsoft.com/office/drawing/2014/main" id="{7BF8F38C-B9DA-4386-B373-502F8FD928B2}"/>
+                <a16:creationId xmlns:a16="http://schemas.microsoft.com/office/drawing/2014/main" id="{934BDE29-E9E0-4EC4-B439-1343FE525961}"/>
               </a:ext>
             </a:extLst>
           </p:cNvPr>
@@ -2484,7 +2484,7 @@
           <p:cNvPr id="7" name="">
             <a:extLst xmlns:a="http://schemas.openxmlformats.org/drawingml/2006/main">
               <a:ext uri="{FF2B5EF4-FFF2-40B4-BE49-F238E27FC236}">
-                <a16:creationId xmlns:a16="http://schemas.microsoft.com/office/drawing/2014/main" id="{2DF30023-057D-4EFD-B36C-C0F939A0DE5C}"/>
+                <a16:creationId xmlns:a16="http://schemas.microsoft.com/office/drawing/2014/main" id="{21C4EA60-3FA9-469D-8B2C-16508591044E}"/>
               </a:ext>
             </a:extLst>
           </p:cNvPr>
@@ -2515,7 +2515,7 @@
           <p:cNvPr id="8" name="">
             <a:extLst xmlns:a="http://schemas.openxmlformats.org/drawingml/2006/main">
               <a:ext uri="{FF2B5EF4-FFF2-40B4-BE49-F238E27FC236}">
-                <a16:creationId xmlns:a16="http://schemas.microsoft.com/office/drawing/2014/main" id="{38DCE320-09D4-4D39-A3BA-E7C21F7725B7}"/>
+                <a16:creationId xmlns:a16="http://schemas.microsoft.com/office/drawing/2014/main" id="{DECBFABA-53D7-40EE-83DA-D3C75ECE0489}"/>
               </a:ext>
             </a:extLst>
           </p:cNvPr>
@@ -2576,7 +2576,7 @@
           <p:cNvPr id="9" name="">
             <a:extLst xmlns:a="http://schemas.openxmlformats.org/drawingml/2006/main">
               <a:ext uri="{FF2B5EF4-FFF2-40B4-BE49-F238E27FC236}">
-                <a16:creationId xmlns:a16="http://schemas.microsoft.com/office/drawing/2014/main" id="{44213FA2-EC73-41EF-8287-5E96973F092D}"/>
+                <a16:creationId xmlns:a16="http://schemas.microsoft.com/office/drawing/2014/main" id="{A1A6EDF0-507C-4643-A1F9-46778DBA9366}"/>
               </a:ext>
             </a:extLst>
           </p:cNvPr>
@@ -2637,7 +2637,7 @@
           <p:cNvPr id="10" name="">
             <a:extLst xmlns:a="http://schemas.openxmlformats.org/drawingml/2006/main">
               <a:ext uri="{FF2B5EF4-FFF2-40B4-BE49-F238E27FC236}">
-                <a16:creationId xmlns:a16="http://schemas.microsoft.com/office/drawing/2014/main" id="{B0CB4D06-3D9C-499A-8AFA-5EB307556BF9}"/>
+                <a16:creationId xmlns:a16="http://schemas.microsoft.com/office/drawing/2014/main" id="{E5FA2E57-6389-4FCE-B44A-69279F65DC24}"/>
               </a:ext>
             </a:extLst>
           </p:cNvPr>
@@ -2698,7 +2698,7 @@
           <p:cNvPr id="11" name="">
             <a:extLst xmlns:a="http://schemas.openxmlformats.org/drawingml/2006/main">
               <a:ext uri="{FF2B5EF4-FFF2-40B4-BE49-F238E27FC236}">
-                <a16:creationId xmlns:a16="http://schemas.microsoft.com/office/drawing/2014/main" id="{6280F1B4-508D-44B4-873E-34E3C67E6916}"/>
+                <a16:creationId xmlns:a16="http://schemas.microsoft.com/office/drawing/2014/main" id="{91131EE1-1724-42AA-B9AF-18573B0D15A6}"/>
               </a:ext>
             </a:extLst>
           </p:cNvPr>
@@ -2729,7 +2729,7 @@
           <p:cNvPr id="12" name="">
             <a:extLst xmlns:a="http://schemas.openxmlformats.org/drawingml/2006/main">
               <a:ext uri="{FF2B5EF4-FFF2-40B4-BE49-F238E27FC236}">
-                <a16:creationId xmlns:a16="http://schemas.microsoft.com/office/drawing/2014/main" id="{D6393A81-FAF0-4EA1-9C34-F52216DF2048}"/>
+                <a16:creationId xmlns:a16="http://schemas.microsoft.com/office/drawing/2014/main" id="{41B8CBB8-16BD-4E24-B3A7-08F4245C2467}"/>
               </a:ext>
             </a:extLst>
           </p:cNvPr>
@@ -2790,7 +2790,7 @@
           <p:cNvPr id="13" name="">
             <a:extLst xmlns:a="http://schemas.openxmlformats.org/drawingml/2006/main">
               <a:ext uri="{FF2B5EF4-FFF2-40B4-BE49-F238E27FC236}">
-                <a16:creationId xmlns:a16="http://schemas.microsoft.com/office/drawing/2014/main" id="{163BB9F7-591F-453B-962B-0F54350BDE2B}"/>
+                <a16:creationId xmlns:a16="http://schemas.microsoft.com/office/drawing/2014/main" id="{E51B0DF0-4764-4726-9D21-7279C480439E}"/>
               </a:ext>
             </a:extLst>
           </p:cNvPr>
@@ -2851,7 +2851,7 @@
           <p:cNvPr id="14" name="">
             <a:extLst xmlns:a="http://schemas.openxmlformats.org/drawingml/2006/main">
               <a:ext uri="{FF2B5EF4-FFF2-40B4-BE49-F238E27FC236}">
-                <a16:creationId xmlns:a16="http://schemas.microsoft.com/office/drawing/2014/main" id="{C4AAE633-DCCF-4242-812F-3DC2D3CE0FF2}"/>
+                <a16:creationId xmlns:a16="http://schemas.microsoft.com/office/drawing/2014/main" id="{030FE1D3-7A21-4874-8A39-7641A037D56C}"/>
               </a:ext>
             </a:extLst>
           </p:cNvPr>
@@ -2912,7 +2912,7 @@
           <p:cNvPr id="15" name="">
             <a:extLst xmlns:a="http://schemas.openxmlformats.org/drawingml/2006/main">
               <a:ext uri="{FF2B5EF4-FFF2-40B4-BE49-F238E27FC236}">
-                <a16:creationId xmlns:a16="http://schemas.microsoft.com/office/drawing/2014/main" id="{52DA0F99-0548-4A08-8CB8-BB0798464F45}"/>
+                <a16:creationId xmlns:a16="http://schemas.microsoft.com/office/drawing/2014/main" id="{B7232F32-6BC5-4F42-A00C-2592A7D19C77}"/>
               </a:ext>
             </a:extLst>
           </p:cNvPr>
@@ -2943,7 +2943,7 @@
           <p:cNvPr id="16" name="">
             <a:extLst xmlns:a="http://schemas.openxmlformats.org/drawingml/2006/main">
               <a:ext uri="{FF2B5EF4-FFF2-40B4-BE49-F238E27FC236}">
-                <a16:creationId xmlns:a16="http://schemas.microsoft.com/office/drawing/2014/main" id="{807DC39E-A9D6-40B9-966B-6A44E0B14F6C}"/>
+                <a16:creationId xmlns:a16="http://schemas.microsoft.com/office/drawing/2014/main" id="{8E3541A9-25F6-4DAE-9F50-69180C59764E}"/>
               </a:ext>
             </a:extLst>
           </p:cNvPr>
@@ -2975,7 +2975,7 @@
           <p:cNvPr id="17" name="">
             <a:extLst xmlns:a="http://schemas.openxmlformats.org/drawingml/2006/main">
               <a:ext uri="{FF2B5EF4-FFF2-40B4-BE49-F238E27FC236}">
-                <a16:creationId xmlns:a16="http://schemas.microsoft.com/office/drawing/2014/main" id="{BC1C175C-4BE0-4D4B-A293-1934B6443820}"/>
+                <a16:creationId xmlns:a16="http://schemas.microsoft.com/office/drawing/2014/main" id="{59C8712A-8FEC-41B1-BE21-242C7896F250}"/>
               </a:ext>
             </a:extLst>
           </p:cNvPr>
@@ -3036,7 +3036,7 @@
           <p:cNvPr id="18" name="">
             <a:extLst xmlns:a="http://schemas.openxmlformats.org/drawingml/2006/main">
               <a:ext uri="{FF2B5EF4-FFF2-40B4-BE49-F238E27FC236}">
-                <a16:creationId xmlns:a16="http://schemas.microsoft.com/office/drawing/2014/main" id="{99EF028B-8C5A-4CA2-98A8-2B67EA1BCDD8}"/>
+                <a16:creationId xmlns:a16="http://schemas.microsoft.com/office/drawing/2014/main" id="{B2405609-6BB8-4824-A48B-62678D9E17EC}"/>
               </a:ext>
             </a:extLst>
           </p:cNvPr>
@@ -3068,7 +3068,7 @@
           <p:cNvPr id="19" name="">
             <a:extLst xmlns:a="http://schemas.openxmlformats.org/drawingml/2006/main">
               <a:ext uri="{FF2B5EF4-FFF2-40B4-BE49-F238E27FC236}">
-                <a16:creationId xmlns:a16="http://schemas.microsoft.com/office/drawing/2014/main" id="{269A779F-9B86-48DD-BA3A-F99F9FC690AC}"/>
+                <a16:creationId xmlns:a16="http://schemas.microsoft.com/office/drawing/2014/main" id="{79DA6CF8-F7C9-4F44-94CC-55C1D159BCB3}"/>
               </a:ext>
             </a:extLst>
           </p:cNvPr>
@@ -3129,7 +3129,7 @@
           <p:cNvPr id="20" name="">
             <a:extLst xmlns:a="http://schemas.openxmlformats.org/drawingml/2006/main">
               <a:ext uri="{FF2B5EF4-FFF2-40B4-BE49-F238E27FC236}">
-                <a16:creationId xmlns:a16="http://schemas.microsoft.com/office/drawing/2014/main" id="{27F363FD-79BA-4357-98A1-1E8C9BBC8C1D}"/>
+                <a16:creationId xmlns:a16="http://schemas.microsoft.com/office/drawing/2014/main" id="{478E6005-4EAD-40F4-A5E9-307FF69F0FDE}"/>
               </a:ext>
             </a:extLst>
           </p:cNvPr>
@@ -3190,7 +3190,7 @@
           <p:cNvPr id="21" name="">
             <a:extLst xmlns:a="http://schemas.openxmlformats.org/drawingml/2006/main">
               <a:ext uri="{FF2B5EF4-FFF2-40B4-BE49-F238E27FC236}">
-                <a16:creationId xmlns:a16="http://schemas.microsoft.com/office/drawing/2014/main" id="{62616397-4F5A-4C71-8C8A-D15E73A863D9}"/>
+                <a16:creationId xmlns:a16="http://schemas.microsoft.com/office/drawing/2014/main" id="{71903F73-FFA7-4DAC-975B-5153B0EB27E5}"/>
               </a:ext>
             </a:extLst>
           </p:cNvPr>
@@ -3222,7 +3222,7 @@
           <p:cNvPr id="22" name="">
             <a:extLst xmlns:a="http://schemas.openxmlformats.org/drawingml/2006/main">
               <a:ext uri="{FF2B5EF4-FFF2-40B4-BE49-F238E27FC236}">
-                <a16:creationId xmlns:a16="http://schemas.microsoft.com/office/drawing/2014/main" id="{B52E5D10-4EC3-44E1-943C-33BF6A236634}"/>
+                <a16:creationId xmlns:a16="http://schemas.microsoft.com/office/drawing/2014/main" id="{7FEDA5D5-7B96-41CF-A1D5-8F4E56405ECC}"/>
               </a:ext>
             </a:extLst>
           </p:cNvPr>
@@ -3283,7 +3283,7 @@
           <p:cNvPr id="23" name="">
             <a:extLst xmlns:a="http://schemas.openxmlformats.org/drawingml/2006/main">
               <a:ext uri="{FF2B5EF4-FFF2-40B4-BE49-F238E27FC236}">
-                <a16:creationId xmlns:a16="http://schemas.microsoft.com/office/drawing/2014/main" id="{43BC7F1A-3A09-48A8-B2C3-71E278E0E64F}"/>
+                <a16:creationId xmlns:a16="http://schemas.microsoft.com/office/drawing/2014/main" id="{BC3D7FB7-D623-4E81-ABA5-9D59B6301266}"/>
               </a:ext>
             </a:extLst>
           </p:cNvPr>
@@ -3344,7 +3344,7 @@
           <p:cNvPr id="24" name="">
             <a:extLst xmlns:a="http://schemas.openxmlformats.org/drawingml/2006/main">
               <a:ext uri="{FF2B5EF4-FFF2-40B4-BE49-F238E27FC236}">
-                <a16:creationId xmlns:a16="http://schemas.microsoft.com/office/drawing/2014/main" id="{AF91CEE8-0C66-4E8D-ACFA-ADC8260E54CF}"/>
+                <a16:creationId xmlns:a16="http://schemas.microsoft.com/office/drawing/2014/main" id="{D3477A51-582F-401E-9F1A-803490EC0B66}"/>
               </a:ext>
             </a:extLst>
           </p:cNvPr>
@@ -3376,7 +3376,7 @@
           <p:cNvPr id="25" name="">
             <a:extLst xmlns:a="http://schemas.openxmlformats.org/drawingml/2006/main">
               <a:ext uri="{FF2B5EF4-FFF2-40B4-BE49-F238E27FC236}">
-                <a16:creationId xmlns:a16="http://schemas.microsoft.com/office/drawing/2014/main" id="{3902C691-438B-4877-A9CC-25B001C84A02}"/>
+                <a16:creationId xmlns:a16="http://schemas.microsoft.com/office/drawing/2014/main" id="{FCD3F373-B3F2-46BE-B55A-F9FDC732B263}"/>
               </a:ext>
             </a:extLst>
           </p:cNvPr>
@@ -3437,7 +3437,7 @@
           <p:cNvPr id="26" name="">
             <a:extLst xmlns:a="http://schemas.openxmlformats.org/drawingml/2006/main">
               <a:ext uri="{FF2B5EF4-FFF2-40B4-BE49-F238E27FC236}">
-                <a16:creationId xmlns:a16="http://schemas.microsoft.com/office/drawing/2014/main" id="{9145CC73-9716-4CDB-B881-122131E48D9A}"/>
+                <a16:creationId xmlns:a16="http://schemas.microsoft.com/office/drawing/2014/main" id="{795BF41D-8425-4E18-B0BD-AEFD2C0F9E10}"/>
               </a:ext>
             </a:extLst>
           </p:cNvPr>
@@ -3498,7 +3498,7 @@
           <p:cNvPr id="27" name="">
             <a:extLst xmlns:a="http://schemas.openxmlformats.org/drawingml/2006/main">
               <a:ext uri="{FF2B5EF4-FFF2-40B4-BE49-F238E27FC236}">
-                <a16:creationId xmlns:a16="http://schemas.microsoft.com/office/drawing/2014/main" id="{D3BD3881-30A0-459A-ABA2-2D344336E8BA}"/>
+                <a16:creationId xmlns:a16="http://schemas.microsoft.com/office/drawing/2014/main" id="{F656CB80-D3F6-4E57-9A62-1E39D0295E4A}"/>
               </a:ext>
             </a:extLst>
           </p:cNvPr>
@@ -3530,7 +3530,7 @@
           <p:cNvPr id="28" name="">
             <a:extLst xmlns:a="http://schemas.openxmlformats.org/drawingml/2006/main">
               <a:ext uri="{FF2B5EF4-FFF2-40B4-BE49-F238E27FC236}">
-                <a16:creationId xmlns:a16="http://schemas.microsoft.com/office/drawing/2014/main" id="{65EF52E9-AE76-4D6B-AA10-C15861D3FD39}"/>
+                <a16:creationId xmlns:a16="http://schemas.microsoft.com/office/drawing/2014/main" id="{987833E7-8251-49DE-BBA7-C57A16BE1ACB}"/>
               </a:ext>
             </a:extLst>
           </p:cNvPr>
@@ -3591,7 +3591,7 @@
           <p:cNvPr id="29" name="">
             <a:extLst xmlns:a="http://schemas.openxmlformats.org/drawingml/2006/main">
               <a:ext uri="{FF2B5EF4-FFF2-40B4-BE49-F238E27FC236}">
-                <a16:creationId xmlns:a16="http://schemas.microsoft.com/office/drawing/2014/main" id="{2C3C8490-6F58-4E92-A2F2-32CA6CCA6570}"/>
+                <a16:creationId xmlns:a16="http://schemas.microsoft.com/office/drawing/2014/main" id="{809ECB0B-7EAA-4A2B-8E32-948843690892}"/>
               </a:ext>
             </a:extLst>
           </p:cNvPr>
@@ -3652,7 +3652,7 @@
           <p:cNvPr id="30" name="">
             <a:extLst xmlns:a="http://schemas.openxmlformats.org/drawingml/2006/main">
               <a:ext uri="{FF2B5EF4-FFF2-40B4-BE49-F238E27FC236}">
-                <a16:creationId xmlns:a16="http://schemas.microsoft.com/office/drawing/2014/main" id="{EEAB52A6-D609-443A-89AB-71FED2AD7F72}"/>
+                <a16:creationId xmlns:a16="http://schemas.microsoft.com/office/drawing/2014/main" id="{36E1A9C5-6326-42BD-A82A-523CD1449839}"/>
               </a:ext>
             </a:extLst>
           </p:cNvPr>
@@ -3713,7 +3713,7 @@
           <p:cNvPr id="31" name="">
             <a:extLst xmlns:a="http://schemas.openxmlformats.org/drawingml/2006/main">
               <a:ext uri="{FF2B5EF4-FFF2-40B4-BE49-F238E27FC236}">
-                <a16:creationId xmlns:a16="http://schemas.microsoft.com/office/drawing/2014/main" id="{61543EC7-E1A0-4112-BF1E-D704D3BC9CED}"/>
+                <a16:creationId xmlns:a16="http://schemas.microsoft.com/office/drawing/2014/main" id="{6747DFE8-26C9-4C98-B5FA-F5EB383A663D}"/>
               </a:ext>
             </a:extLst>
           </p:cNvPr>
@@ -3774,7 +3774,7 @@
           <p:cNvPr id="32" name="">
             <a:extLst xmlns:a="http://schemas.openxmlformats.org/drawingml/2006/main">
               <a:ext uri="{FF2B5EF4-FFF2-40B4-BE49-F238E27FC236}">
-                <a16:creationId xmlns:a16="http://schemas.microsoft.com/office/drawing/2014/main" id="{B59C7368-DBCB-4BCE-B0D7-07CC4DD8071E}"/>
+                <a16:creationId xmlns:a16="http://schemas.microsoft.com/office/drawing/2014/main" id="{A1F4D84B-0D1B-4D3F-B630-4BFAE8096248}"/>
               </a:ext>
             </a:extLst>
           </p:cNvPr>
@@ -3833,7 +3833,7 @@
     </p:spTree>
     <p:extLst>
       <p:ext uri="{BB962C8B-B14F-4D97-AF65-F5344CB8AC3E}">
-        <p14:creationId xmlns:p14="http://schemas.microsoft.com/office/powerpoint/2010/main" val="1911306384"/>
+        <p14:creationId xmlns:p14="http://schemas.microsoft.com/office/powerpoint/2010/main" val="1348802648"/>
       </p:ext>
     </p:extLst>
   </p:cSld>
@@ -3864,7 +3864,7 @@
           <p:cNvPr id="43" name="">
             <a:extLst xmlns:a="http://schemas.openxmlformats.org/drawingml/2006/main">
               <a:ext uri="{FF2B5EF4-FFF2-40B4-BE49-F238E27FC236}">
-                <a16:creationId xmlns:a16="http://schemas.microsoft.com/office/drawing/2014/main" id="{DBE27ECB-B9FE-470A-B650-0473DB77DB85}"/>
+                <a16:creationId xmlns:a16="http://schemas.microsoft.com/office/drawing/2014/main" id="{E2E90A51-FA38-492F-83DD-2BC3912C2260}"/>
               </a:ext>
             </a:extLst>
           </p:cNvPr>
@@ -3925,7 +3925,7 @@
           <p:cNvPr id="2" name="">
             <a:extLst xmlns:a="http://schemas.openxmlformats.org/drawingml/2006/main">
               <a:ext uri="{FF2B5EF4-FFF2-40B4-BE49-F238E27FC236}">
-                <a16:creationId xmlns:a16="http://schemas.microsoft.com/office/drawing/2014/main" id="{D49C7CA5-F7CE-4836-9694-ED1BF438F824}"/>
+                <a16:creationId xmlns:a16="http://schemas.microsoft.com/office/drawing/2014/main" id="{D5F8BE24-A988-4BC6-9C8E-47BDA48F8097}"/>
               </a:ext>
             </a:extLst>
           </p:cNvPr>
@@ -3986,7 +3986,7 @@
           <p:cNvPr id="3" name="">
             <a:extLst xmlns:a="http://schemas.openxmlformats.org/drawingml/2006/main">
               <a:ext uri="{FF2B5EF4-FFF2-40B4-BE49-F238E27FC236}">
-                <a16:creationId xmlns:a16="http://schemas.microsoft.com/office/drawing/2014/main" id="{1908CAFC-D408-4202-A2E0-3F1DEB0E943D}"/>
+                <a16:creationId xmlns:a16="http://schemas.microsoft.com/office/drawing/2014/main" id="{9D0FF8A8-119A-4167-A58D-29458BCBB8A1}"/>
               </a:ext>
             </a:extLst>
           </p:cNvPr>
@@ -4016,7 +4016,7 @@
           <p:cNvPr id="4" name="">
             <a:extLst xmlns:a="http://schemas.openxmlformats.org/drawingml/2006/main">
               <a:ext uri="{FF2B5EF4-FFF2-40B4-BE49-F238E27FC236}">
-                <a16:creationId xmlns:a16="http://schemas.microsoft.com/office/drawing/2014/main" id="{E643C56D-257C-46C1-AFA4-826EC8A96F24}"/>
+                <a16:creationId xmlns:a16="http://schemas.microsoft.com/office/drawing/2014/main" id="{8CFC08D4-930B-486B-9AC0-430CA7FAAB4F}"/>
               </a:ext>
             </a:extLst>
           </p:cNvPr>
@@ -4051,7 +4051,7 @@
           <p:cNvPr id="5" name="">
             <a:extLst xmlns:a="http://schemas.openxmlformats.org/drawingml/2006/main">
               <a:ext uri="{FF2B5EF4-FFF2-40B4-BE49-F238E27FC236}">
-                <a16:creationId xmlns:a16="http://schemas.microsoft.com/office/drawing/2014/main" id="{906025AC-EA61-4AC1-BEB8-2A8B95522208}"/>
+                <a16:creationId xmlns:a16="http://schemas.microsoft.com/office/drawing/2014/main" id="{75C56613-6D4B-4A35-896D-BF0E2BD2A91A}"/>
               </a:ext>
             </a:extLst>
           </p:cNvPr>
@@ -4081,7 +4081,7 @@
           <p:cNvPr id="6" name="">
             <a:extLst xmlns:a="http://schemas.openxmlformats.org/drawingml/2006/main">
               <a:ext uri="{FF2B5EF4-FFF2-40B4-BE49-F238E27FC236}">
-                <a16:creationId xmlns:a16="http://schemas.microsoft.com/office/drawing/2014/main" id="{D076179E-1C0E-4334-A63F-49C8DC4506FD}"/>
+                <a16:creationId xmlns:a16="http://schemas.microsoft.com/office/drawing/2014/main" id="{5383C99C-6BF0-4B9F-BD9B-02FF5AB830F9}"/>
               </a:ext>
             </a:extLst>
           </p:cNvPr>
@@ -4142,7 +4142,7 @@
           <p:cNvPr id="7" name="">
             <a:extLst xmlns:a="http://schemas.openxmlformats.org/drawingml/2006/main">
               <a:ext uri="{FF2B5EF4-FFF2-40B4-BE49-F238E27FC236}">
-                <a16:creationId xmlns:a16="http://schemas.microsoft.com/office/drawing/2014/main" id="{E028D7BB-A467-4593-9D0E-192E6563FFF5}"/>
+                <a16:creationId xmlns:a16="http://schemas.microsoft.com/office/drawing/2014/main" id="{D16A7454-FFE4-4207-A77B-4EC91763270D}"/>
               </a:ext>
             </a:extLst>
           </p:cNvPr>
@@ -4203,7 +4203,7 @@
           <p:cNvPr id="8" name="">
             <a:extLst xmlns:a="http://schemas.openxmlformats.org/drawingml/2006/main">
               <a:ext uri="{FF2B5EF4-FFF2-40B4-BE49-F238E27FC236}">
-                <a16:creationId xmlns:a16="http://schemas.microsoft.com/office/drawing/2014/main" id="{9B170B67-EFD5-41F7-8DA7-89157EF0E123}"/>
+                <a16:creationId xmlns:a16="http://schemas.microsoft.com/office/drawing/2014/main" id="{2761ECEB-5658-432D-AC06-809832BD770C}"/>
               </a:ext>
             </a:extLst>
           </p:cNvPr>
@@ -4264,7 +4264,7 @@
           <p:cNvPr id="9" name="">
             <a:extLst xmlns:a="http://schemas.openxmlformats.org/drawingml/2006/main">
               <a:ext uri="{FF2B5EF4-FFF2-40B4-BE49-F238E27FC236}">
-                <a16:creationId xmlns:a16="http://schemas.microsoft.com/office/drawing/2014/main" id="{7A2CE001-E00C-49E9-A833-FD3C0EE78C49}"/>
+                <a16:creationId xmlns:a16="http://schemas.microsoft.com/office/drawing/2014/main" id="{71E9FE41-9981-4BD2-B44D-85ACAF6B79AC}"/>
               </a:ext>
             </a:extLst>
           </p:cNvPr>
@@ -4299,7 +4299,7 @@
           <p:cNvPr id="10" name="">
             <a:extLst xmlns:a="http://schemas.openxmlformats.org/drawingml/2006/main">
               <a:ext uri="{FF2B5EF4-FFF2-40B4-BE49-F238E27FC236}">
-                <a16:creationId xmlns:a16="http://schemas.microsoft.com/office/drawing/2014/main" id="{2BD4F487-E580-4CBC-A5ED-30AD6F6FE7F3}"/>
+                <a16:creationId xmlns:a16="http://schemas.microsoft.com/office/drawing/2014/main" id="{E0E102DA-B711-4CC0-BA20-F26CEC5EE5AE}"/>
               </a:ext>
             </a:extLst>
           </p:cNvPr>
@@ -4329,7 +4329,7 @@
           <p:cNvPr id="11" name="">
             <a:extLst xmlns:a="http://schemas.openxmlformats.org/drawingml/2006/main">
               <a:ext uri="{FF2B5EF4-FFF2-40B4-BE49-F238E27FC236}">
-                <a16:creationId xmlns:a16="http://schemas.microsoft.com/office/drawing/2014/main" id="{F175A357-56D2-4288-BF9C-E1400CB22D8B}"/>
+                <a16:creationId xmlns:a16="http://schemas.microsoft.com/office/drawing/2014/main" id="{C6DFB42D-1380-451B-8795-525C6668BE0A}"/>
               </a:ext>
             </a:extLst>
           </p:cNvPr>
@@ -4390,7 +4390,7 @@
           <p:cNvPr id="12" name="">
             <a:extLst xmlns:a="http://schemas.openxmlformats.org/drawingml/2006/main">
               <a:ext uri="{FF2B5EF4-FFF2-40B4-BE49-F238E27FC236}">
-                <a16:creationId xmlns:a16="http://schemas.microsoft.com/office/drawing/2014/main" id="{DAD38F6D-D18B-4FD8-A22D-A5EEF7384C52}"/>
+                <a16:creationId xmlns:a16="http://schemas.microsoft.com/office/drawing/2014/main" id="{F90E7FC4-F72C-45BF-9A7F-12382FE9AE4C}"/>
               </a:ext>
             </a:extLst>
           </p:cNvPr>
@@ -4451,7 +4451,7 @@
           <p:cNvPr id="13" name="">
             <a:extLst xmlns:a="http://schemas.openxmlformats.org/drawingml/2006/main">
               <a:ext uri="{FF2B5EF4-FFF2-40B4-BE49-F238E27FC236}">
-                <a16:creationId xmlns:a16="http://schemas.microsoft.com/office/drawing/2014/main" id="{0F59DF8C-2C9C-4AC8-B7DC-8706792BC0CE}"/>
+                <a16:creationId xmlns:a16="http://schemas.microsoft.com/office/drawing/2014/main" id="{CA206355-9268-461D-872D-2EE19EF97E7B}"/>
               </a:ext>
             </a:extLst>
           </p:cNvPr>
@@ -4512,7 +4512,7 @@
           <p:cNvPr id="14" name="">
             <a:extLst xmlns:a="http://schemas.openxmlformats.org/drawingml/2006/main">
               <a:ext uri="{FF2B5EF4-FFF2-40B4-BE49-F238E27FC236}">
-                <a16:creationId xmlns:a16="http://schemas.microsoft.com/office/drawing/2014/main" id="{63ED57AB-0CCD-485E-AF40-2047FB4CD703}"/>
+                <a16:creationId xmlns:a16="http://schemas.microsoft.com/office/drawing/2014/main" id="{FC64A2A7-0E21-4F20-B639-AF12E94F773D}"/>
               </a:ext>
             </a:extLst>
           </p:cNvPr>
@@ -4547,7 +4547,7 @@
           <p:cNvPr id="15" name="">
             <a:extLst xmlns:a="http://schemas.openxmlformats.org/drawingml/2006/main">
               <a:ext uri="{FF2B5EF4-FFF2-40B4-BE49-F238E27FC236}">
-                <a16:creationId xmlns:a16="http://schemas.microsoft.com/office/drawing/2014/main" id="{C88E7AC2-BC9F-46E0-9C87-7C23C4D6E72C}"/>
+                <a16:creationId xmlns:a16="http://schemas.microsoft.com/office/drawing/2014/main" id="{35D8CBE5-3D59-4256-B17C-AF09A0757BFE}"/>
               </a:ext>
             </a:extLst>
           </p:cNvPr>
@@ -4577,7 +4577,7 @@
           <p:cNvPr id="16" name="">
             <a:extLst xmlns:a="http://schemas.openxmlformats.org/drawingml/2006/main">
               <a:ext uri="{FF2B5EF4-FFF2-40B4-BE49-F238E27FC236}">
-                <a16:creationId xmlns:a16="http://schemas.microsoft.com/office/drawing/2014/main" id="{BA31BE72-C6BB-4353-B6D1-A88A2236CAFA}"/>
+                <a16:creationId xmlns:a16="http://schemas.microsoft.com/office/drawing/2014/main" id="{2C111602-40EF-4825-9862-B47557AD14B6}"/>
               </a:ext>
             </a:extLst>
           </p:cNvPr>
@@ -4638,7 +4638,7 @@
           <p:cNvPr id="17" name="">
             <a:extLst xmlns:a="http://schemas.openxmlformats.org/drawingml/2006/main">
               <a:ext uri="{FF2B5EF4-FFF2-40B4-BE49-F238E27FC236}">
-                <a16:creationId xmlns:a16="http://schemas.microsoft.com/office/drawing/2014/main" id="{334A0E2C-08D8-4E92-871D-AB9B9D737B8D}"/>
+                <a16:creationId xmlns:a16="http://schemas.microsoft.com/office/drawing/2014/main" id="{1147C121-A8BC-480E-A38F-681E3BA45235}"/>
               </a:ext>
             </a:extLst>
           </p:cNvPr>
@@ -4699,7 +4699,7 @@
           <p:cNvPr id="18" name="">
             <a:extLst xmlns:a="http://schemas.openxmlformats.org/drawingml/2006/main">
               <a:ext uri="{FF2B5EF4-FFF2-40B4-BE49-F238E27FC236}">
-                <a16:creationId xmlns:a16="http://schemas.microsoft.com/office/drawing/2014/main" id="{543BD57F-A642-45C8-8EBE-9B3F9D4B6AB5}"/>
+                <a16:creationId xmlns:a16="http://schemas.microsoft.com/office/drawing/2014/main" id="{8F122F22-A9CA-41F3-9BA3-9B4304FD841A}"/>
               </a:ext>
             </a:extLst>
           </p:cNvPr>
@@ -4760,7 +4760,7 @@
           <p:cNvPr id="19" name="">
             <a:extLst xmlns:a="http://schemas.openxmlformats.org/drawingml/2006/main">
               <a:ext uri="{FF2B5EF4-FFF2-40B4-BE49-F238E27FC236}">
-                <a16:creationId xmlns:a16="http://schemas.microsoft.com/office/drawing/2014/main" id="{69A6CF60-4175-4267-BE9A-C04E145200BE}"/>
+                <a16:creationId xmlns:a16="http://schemas.microsoft.com/office/drawing/2014/main" id="{79460DC2-6C36-4A0D-BD53-351758C58913}"/>
               </a:ext>
             </a:extLst>
           </p:cNvPr>
@@ -4795,7 +4795,7 @@
           <p:cNvPr id="20" name="">
             <a:extLst xmlns:a="http://schemas.openxmlformats.org/drawingml/2006/main">
               <a:ext uri="{FF2B5EF4-FFF2-40B4-BE49-F238E27FC236}">
-                <a16:creationId xmlns:a16="http://schemas.microsoft.com/office/drawing/2014/main" id="{988A7A9C-5132-4AC4-9C55-3ACB0ED45222}"/>
+                <a16:creationId xmlns:a16="http://schemas.microsoft.com/office/drawing/2014/main" id="{DFFECC06-77DE-4B50-ACDA-16A93C2032F3}"/>
               </a:ext>
             </a:extLst>
           </p:cNvPr>
@@ -4825,7 +4825,7 @@
           <p:cNvPr id="21" name="">
             <a:extLst xmlns:a="http://schemas.openxmlformats.org/drawingml/2006/main">
               <a:ext uri="{FF2B5EF4-FFF2-40B4-BE49-F238E27FC236}">
-                <a16:creationId xmlns:a16="http://schemas.microsoft.com/office/drawing/2014/main" id="{FD156CAF-D867-4B15-A801-EA4727029662}"/>
+                <a16:creationId xmlns:a16="http://schemas.microsoft.com/office/drawing/2014/main" id="{03CFDF96-BA2E-47D7-A4FA-129D0CDA8A69}"/>
               </a:ext>
             </a:extLst>
           </p:cNvPr>
@@ -4886,7 +4886,7 @@
           <p:cNvPr id="22" name="">
             <a:extLst xmlns:a="http://schemas.openxmlformats.org/drawingml/2006/main">
               <a:ext uri="{FF2B5EF4-FFF2-40B4-BE49-F238E27FC236}">
-                <a16:creationId xmlns:a16="http://schemas.microsoft.com/office/drawing/2014/main" id="{22F8E162-9C76-435F-BD31-ABEB82DD6DE8}"/>
+                <a16:creationId xmlns:a16="http://schemas.microsoft.com/office/drawing/2014/main" id="{F1532E30-CE88-41DC-84B2-809374A2AEE4}"/>
               </a:ext>
             </a:extLst>
           </p:cNvPr>
@@ -4947,7 +4947,7 @@
           <p:cNvPr id="23" name="">
             <a:extLst xmlns:a="http://schemas.openxmlformats.org/drawingml/2006/main">
               <a:ext uri="{FF2B5EF4-FFF2-40B4-BE49-F238E27FC236}">
-                <a16:creationId xmlns:a16="http://schemas.microsoft.com/office/drawing/2014/main" id="{DC881B1A-1BE4-42E7-B5AA-05F2D242BA2D}"/>
+                <a16:creationId xmlns:a16="http://schemas.microsoft.com/office/drawing/2014/main" id="{8AF3D994-AD95-4A02-9723-2EB1AA98B636}"/>
               </a:ext>
             </a:extLst>
           </p:cNvPr>
@@ -5008,7 +5008,7 @@
           <p:cNvPr id="24" name="">
             <a:extLst xmlns:a="http://schemas.openxmlformats.org/drawingml/2006/main">
               <a:ext uri="{FF2B5EF4-FFF2-40B4-BE49-F238E27FC236}">
-                <a16:creationId xmlns:a16="http://schemas.microsoft.com/office/drawing/2014/main" id="{2C18A45B-2A8A-46CA-94AA-896CA07CCAC3}"/>
+                <a16:creationId xmlns:a16="http://schemas.microsoft.com/office/drawing/2014/main" id="{EF3AD3EE-EB08-440C-8D27-6C8843DB20DC}"/>
               </a:ext>
             </a:extLst>
           </p:cNvPr>
@@ -5043,7 +5043,7 @@
           <p:cNvPr id="25" name="">
             <a:extLst xmlns:a="http://schemas.openxmlformats.org/drawingml/2006/main">
               <a:ext uri="{FF2B5EF4-FFF2-40B4-BE49-F238E27FC236}">
-                <a16:creationId xmlns:a16="http://schemas.microsoft.com/office/drawing/2014/main" id="{51A2F581-CF66-41AF-AC17-8F8468342FAA}"/>
+                <a16:creationId xmlns:a16="http://schemas.microsoft.com/office/drawing/2014/main" id="{A2A6253A-39D7-4706-9684-BD021BFE0E9D}"/>
               </a:ext>
             </a:extLst>
           </p:cNvPr>
@@ -5073,7 +5073,7 @@
           <p:cNvPr id="26" name="">
             <a:extLst xmlns:a="http://schemas.openxmlformats.org/drawingml/2006/main">
               <a:ext uri="{FF2B5EF4-FFF2-40B4-BE49-F238E27FC236}">
-                <a16:creationId xmlns:a16="http://schemas.microsoft.com/office/drawing/2014/main" id="{6B009F4F-3541-4D6D-89F9-06E4FA08AE68}"/>
+                <a16:creationId xmlns:a16="http://schemas.microsoft.com/office/drawing/2014/main" id="{145FA76B-5DB1-4B79-A1F6-B1811C2C9843}"/>
               </a:ext>
             </a:extLst>
           </p:cNvPr>
@@ -5134,7 +5134,7 @@
           <p:cNvPr id="27" name="">
             <a:extLst xmlns:a="http://schemas.openxmlformats.org/drawingml/2006/main">
               <a:ext uri="{FF2B5EF4-FFF2-40B4-BE49-F238E27FC236}">
-                <a16:creationId xmlns:a16="http://schemas.microsoft.com/office/drawing/2014/main" id="{62CD98F9-5A68-4A81-BC04-81132721B7E9}"/>
+                <a16:creationId xmlns:a16="http://schemas.microsoft.com/office/drawing/2014/main" id="{4B751E79-420D-43D7-AFF2-20C901D1ADC8}"/>
               </a:ext>
             </a:extLst>
           </p:cNvPr>
@@ -5195,7 +5195,7 @@
           <p:cNvPr id="28" name="">
             <a:extLst xmlns:a="http://schemas.openxmlformats.org/drawingml/2006/main">
               <a:ext uri="{FF2B5EF4-FFF2-40B4-BE49-F238E27FC236}">
-                <a16:creationId xmlns:a16="http://schemas.microsoft.com/office/drawing/2014/main" id="{B1A8108B-ACAE-4BEF-B55C-B8B83B7438C4}"/>
+                <a16:creationId xmlns:a16="http://schemas.microsoft.com/office/drawing/2014/main" id="{B2001ED6-B5C8-4C44-B43C-BD0D4BB1FE05}"/>
               </a:ext>
             </a:extLst>
           </p:cNvPr>
@@ -5256,7 +5256,7 @@
           <p:cNvPr id="29" name="">
             <a:extLst xmlns:a="http://schemas.openxmlformats.org/drawingml/2006/main">
               <a:ext uri="{FF2B5EF4-FFF2-40B4-BE49-F238E27FC236}">
-                <a16:creationId xmlns:a16="http://schemas.microsoft.com/office/drawing/2014/main" id="{5B7FFDC4-9ED6-455B-8A7E-92DF1EB5B159}"/>
+                <a16:creationId xmlns:a16="http://schemas.microsoft.com/office/drawing/2014/main" id="{F556FF41-1588-4862-AEF2-EE27B823EAAD}"/>
               </a:ext>
             </a:extLst>
           </p:cNvPr>
@@ -5291,7 +5291,7 @@
           <p:cNvPr id="30" name="">
             <a:extLst xmlns:a="http://schemas.openxmlformats.org/drawingml/2006/main">
               <a:ext uri="{FF2B5EF4-FFF2-40B4-BE49-F238E27FC236}">
-                <a16:creationId xmlns:a16="http://schemas.microsoft.com/office/drawing/2014/main" id="{974BF2FD-A7C3-457A-90EB-84DD09F69AB2}"/>
+                <a16:creationId xmlns:a16="http://schemas.microsoft.com/office/drawing/2014/main" id="{C34976CE-DF51-4775-81C8-4719D47B65BA}"/>
               </a:ext>
             </a:extLst>
           </p:cNvPr>
@@ -5321,7 +5321,7 @@
           <p:cNvPr id="31" name="">
             <a:extLst xmlns:a="http://schemas.openxmlformats.org/drawingml/2006/main">
               <a:ext uri="{FF2B5EF4-FFF2-40B4-BE49-F238E27FC236}">
-                <a16:creationId xmlns:a16="http://schemas.microsoft.com/office/drawing/2014/main" id="{3A8366EB-C04B-47B8-8394-6B48F1C74D8F}"/>
+                <a16:creationId xmlns:a16="http://schemas.microsoft.com/office/drawing/2014/main" id="{E4B7C176-39BD-4B41-B9E2-46CFDF7CBEDB}"/>
               </a:ext>
             </a:extLst>
           </p:cNvPr>
@@ -5382,7 +5382,7 @@
           <p:cNvPr id="32" name="">
             <a:extLst xmlns:a="http://schemas.openxmlformats.org/drawingml/2006/main">
               <a:ext uri="{FF2B5EF4-FFF2-40B4-BE49-F238E27FC236}">
-                <a16:creationId xmlns:a16="http://schemas.microsoft.com/office/drawing/2014/main" id="{30C43ADF-4149-4DE5-851B-A1AA1A705438}"/>
+                <a16:creationId xmlns:a16="http://schemas.microsoft.com/office/drawing/2014/main" id="{5E8E230E-29B6-41F8-9085-3F8FEA7F3C03}"/>
               </a:ext>
             </a:extLst>
           </p:cNvPr>
@@ -5443,7 +5443,7 @@
           <p:cNvPr id="33" name="">
             <a:extLst xmlns:a="http://schemas.openxmlformats.org/drawingml/2006/main">
               <a:ext uri="{FF2B5EF4-FFF2-40B4-BE49-F238E27FC236}">
-                <a16:creationId xmlns:a16="http://schemas.microsoft.com/office/drawing/2014/main" id="{669F99F2-773F-45F8-AAC8-13F8CB007788}"/>
+                <a16:creationId xmlns:a16="http://schemas.microsoft.com/office/drawing/2014/main" id="{91B77664-4351-47DD-8D4D-ABB668AA333B}"/>
               </a:ext>
             </a:extLst>
           </p:cNvPr>
@@ -5504,7 +5504,7 @@
           <p:cNvPr id="34" name="">
             <a:extLst xmlns:a="http://schemas.openxmlformats.org/drawingml/2006/main">
               <a:ext uri="{FF2B5EF4-FFF2-40B4-BE49-F238E27FC236}">
-                <a16:creationId xmlns:a16="http://schemas.microsoft.com/office/drawing/2014/main" id="{7B07642F-D165-4E69-A0D1-BBD22642A545}"/>
+                <a16:creationId xmlns:a16="http://schemas.microsoft.com/office/drawing/2014/main" id="{38FD2E1C-0BC0-438F-9F42-386327DBFD32}"/>
               </a:ext>
             </a:extLst>
           </p:cNvPr>
@@ -5565,7 +5565,7 @@
           <p:cNvPr id="35" name="">
             <a:extLst xmlns:a="http://schemas.openxmlformats.org/drawingml/2006/main">
               <a:ext uri="{FF2B5EF4-FFF2-40B4-BE49-F238E27FC236}">
-                <a16:creationId xmlns:a16="http://schemas.microsoft.com/office/drawing/2014/main" id="{AD63312D-A2E2-47CD-9D93-F0E7048D7A3E}"/>
+                <a16:creationId xmlns:a16="http://schemas.microsoft.com/office/drawing/2014/main" id="{654F1694-922E-4421-87CB-7BD18BA44305}"/>
               </a:ext>
             </a:extLst>
           </p:cNvPr>
@@ -5626,7 +5626,7 @@
           <p:cNvPr id="36" name="">
             <a:extLst xmlns:a="http://schemas.openxmlformats.org/drawingml/2006/main">
               <a:ext uri="{FF2B5EF4-FFF2-40B4-BE49-F238E27FC236}">
-                <a16:creationId xmlns:a16="http://schemas.microsoft.com/office/drawing/2014/main" id="{04174643-DFD3-4532-B902-E7C624FB0A85}"/>
+                <a16:creationId xmlns:a16="http://schemas.microsoft.com/office/drawing/2014/main" id="{9D103BF4-B5C8-4761-B551-5D819EEB263C}"/>
               </a:ext>
             </a:extLst>
           </p:cNvPr>
@@ -5687,7 +5687,7 @@
           <p:cNvPr id="37" name="">
             <a:extLst xmlns:a="http://schemas.openxmlformats.org/drawingml/2006/main">
               <a:ext uri="{FF2B5EF4-FFF2-40B4-BE49-F238E27FC236}">
-                <a16:creationId xmlns:a16="http://schemas.microsoft.com/office/drawing/2014/main" id="{F71525EB-C3F7-47F6-B1C3-76278D873B20}"/>
+                <a16:creationId xmlns:a16="http://schemas.microsoft.com/office/drawing/2014/main" id="{727D9F13-5AC8-453F-A3E0-2D24BB348D77}"/>
               </a:ext>
             </a:extLst>
           </p:cNvPr>
@@ -5748,7 +5748,7 @@
           <p:cNvPr id="38" name="">
             <a:extLst xmlns:a="http://schemas.openxmlformats.org/drawingml/2006/main">
               <a:ext uri="{FF2B5EF4-FFF2-40B4-BE49-F238E27FC236}">
-                <a16:creationId xmlns:a16="http://schemas.microsoft.com/office/drawing/2014/main" id="{AB2A357C-B52A-4B54-8D29-4D8EE49A6AB7}"/>
+                <a16:creationId xmlns:a16="http://schemas.microsoft.com/office/drawing/2014/main" id="{0EABB8C4-EB83-4CD6-AC88-356F0C1E432E}"/>
               </a:ext>
             </a:extLst>
           </p:cNvPr>
@@ -5809,7 +5809,7 @@
           <p:cNvPr id="39" name="">
             <a:extLst xmlns:a="http://schemas.openxmlformats.org/drawingml/2006/main">
               <a:ext uri="{FF2B5EF4-FFF2-40B4-BE49-F238E27FC236}">
-                <a16:creationId xmlns:a16="http://schemas.microsoft.com/office/drawing/2014/main" id="{A663F56B-78D3-4AF7-A1C3-7C905F889376}"/>
+                <a16:creationId xmlns:a16="http://schemas.microsoft.com/office/drawing/2014/main" id="{1279DAB9-C51E-44A1-9AC3-82D285C1E390}"/>
               </a:ext>
             </a:extLst>
           </p:cNvPr>
@@ -5870,7 +5870,7 @@
           <p:cNvPr id="40" name="">
             <a:extLst xmlns:a="http://schemas.openxmlformats.org/drawingml/2006/main">
               <a:ext uri="{FF2B5EF4-FFF2-40B4-BE49-F238E27FC236}">
-                <a16:creationId xmlns:a16="http://schemas.microsoft.com/office/drawing/2014/main" id="{EB5366BF-FEF5-4FD9-9165-8D7CC05E5FE7}"/>
+                <a16:creationId xmlns:a16="http://schemas.microsoft.com/office/drawing/2014/main" id="{3DCC9753-62AA-4367-95B7-12BA343F1DAC}"/>
               </a:ext>
             </a:extLst>
           </p:cNvPr>
@@ -5931,7 +5931,7 @@
           <p:cNvPr id="41" name="">
             <a:extLst xmlns:a="http://schemas.openxmlformats.org/drawingml/2006/main">
               <a:ext uri="{FF2B5EF4-FFF2-40B4-BE49-F238E27FC236}">
-                <a16:creationId xmlns:a16="http://schemas.microsoft.com/office/drawing/2014/main" id="{0B4F5901-D75F-4665-84E8-09EB2575E8C3}"/>
+                <a16:creationId xmlns:a16="http://schemas.microsoft.com/office/drawing/2014/main" id="{74CB95FF-A2D4-44DD-8C96-43F42FD5D53A}"/>
               </a:ext>
             </a:extLst>
           </p:cNvPr>
@@ -5992,7 +5992,7 @@
           <p:cNvPr id="42" name="">
             <a:extLst xmlns:a="http://schemas.openxmlformats.org/drawingml/2006/main">
               <a:ext uri="{FF2B5EF4-FFF2-40B4-BE49-F238E27FC236}">
-                <a16:creationId xmlns:a16="http://schemas.microsoft.com/office/drawing/2014/main" id="{7AB08B6D-C765-4E81-AD98-F4D79D6DAF74}"/>
+                <a16:creationId xmlns:a16="http://schemas.microsoft.com/office/drawing/2014/main" id="{D0D735EA-B745-478F-8EDC-0303E8996F05}"/>
               </a:ext>
             </a:extLst>
           </p:cNvPr>
@@ -6051,7 +6051,7 @@
     </p:spTree>
     <p:extLst>
       <p:ext uri="{BB962C8B-B14F-4D97-AF65-F5344CB8AC3E}">
-        <p14:creationId xmlns:p14="http://schemas.microsoft.com/office/powerpoint/2010/main" val="2121641916"/>
+        <p14:creationId xmlns:p14="http://schemas.microsoft.com/office/powerpoint/2010/main" val="1352557904"/>
       </p:ext>
     </p:extLst>
   </p:cSld>
@@ -6082,7 +6082,7 @@
           <p:cNvPr id="41" name="">
             <a:extLst xmlns:a="http://schemas.openxmlformats.org/drawingml/2006/main">
               <a:ext uri="{FF2B5EF4-FFF2-40B4-BE49-F238E27FC236}">
-                <a16:creationId xmlns:a16="http://schemas.microsoft.com/office/drawing/2014/main" id="{4FF9AC13-D695-4078-BF28-ABB242FFED79}"/>
+                <a16:creationId xmlns:a16="http://schemas.microsoft.com/office/drawing/2014/main" id="{7519BACA-074C-4CE9-9230-EC8B7A1B79E3}"/>
               </a:ext>
             </a:extLst>
           </p:cNvPr>
@@ -6143,7 +6143,7 @@
           <p:cNvPr id="2" name="">
             <a:extLst xmlns:a="http://schemas.openxmlformats.org/drawingml/2006/main">
               <a:ext uri="{FF2B5EF4-FFF2-40B4-BE49-F238E27FC236}">
-                <a16:creationId xmlns:a16="http://schemas.microsoft.com/office/drawing/2014/main" id="{D2CACEC3-8A05-4392-B25C-0478D8252A03}"/>
+                <a16:creationId xmlns:a16="http://schemas.microsoft.com/office/drawing/2014/main" id="{A95A4211-8F4C-4E3F-8321-6A44161A6ECF}"/>
               </a:ext>
             </a:extLst>
           </p:cNvPr>
@@ -6204,7 +6204,7 @@
           <p:cNvPr id="3" name="">
             <a:extLst xmlns:a="http://schemas.openxmlformats.org/drawingml/2006/main">
               <a:ext uri="{FF2B5EF4-FFF2-40B4-BE49-F238E27FC236}">
-                <a16:creationId xmlns:a16="http://schemas.microsoft.com/office/drawing/2014/main" id="{A2611762-7A8C-48CF-9686-8EAAB402C4D3}"/>
+                <a16:creationId xmlns:a16="http://schemas.microsoft.com/office/drawing/2014/main" id="{A852DF04-A992-4B97-91BF-9D37887923B0}"/>
               </a:ext>
             </a:extLst>
           </p:cNvPr>
@@ -6234,7 +6234,7 @@
           <p:cNvPr id="4" name="">
             <a:extLst xmlns:a="http://schemas.openxmlformats.org/drawingml/2006/main">
               <a:ext uri="{FF2B5EF4-FFF2-40B4-BE49-F238E27FC236}">
-                <a16:creationId xmlns:a16="http://schemas.microsoft.com/office/drawing/2014/main" id="{3A4B1BB0-FB6B-4FFD-A137-BFA04E69FB14}"/>
+                <a16:creationId xmlns:a16="http://schemas.microsoft.com/office/drawing/2014/main" id="{37540C3A-76D9-402E-AEFA-B8444BFA886F}"/>
               </a:ext>
             </a:extLst>
           </p:cNvPr>
@@ -6267,7 +6267,7 @@
           <p:cNvPr id="5" name="">
             <a:extLst xmlns:a="http://schemas.openxmlformats.org/drawingml/2006/main">
               <a:ext uri="{FF2B5EF4-FFF2-40B4-BE49-F238E27FC236}">
-                <a16:creationId xmlns:a16="http://schemas.microsoft.com/office/drawing/2014/main" id="{88E0A6E4-2E0E-4090-B7ED-A5907EA8E8EA}"/>
+                <a16:creationId xmlns:a16="http://schemas.microsoft.com/office/drawing/2014/main" id="{33E6515B-8FD4-43BF-9EB3-ADE8B09A864A}"/>
               </a:ext>
             </a:extLst>
           </p:cNvPr>
@@ -6300,7 +6300,7 @@
           <p:cNvPr id="6" name="">
             <a:extLst xmlns:a="http://schemas.openxmlformats.org/drawingml/2006/main">
               <a:ext uri="{FF2B5EF4-FFF2-40B4-BE49-F238E27FC236}">
-                <a16:creationId xmlns:a16="http://schemas.microsoft.com/office/drawing/2014/main" id="{3E3B177C-D511-4275-B2B8-C6877EAF4B13}"/>
+                <a16:creationId xmlns:a16="http://schemas.microsoft.com/office/drawing/2014/main" id="{BBE90E0A-E8CE-4738-A951-75D53806956F}"/>
               </a:ext>
             </a:extLst>
           </p:cNvPr>
@@ -6333,7 +6333,7 @@
           <p:cNvPr id="7" name="">
             <a:extLst xmlns:a="http://schemas.openxmlformats.org/drawingml/2006/main">
               <a:ext uri="{FF2B5EF4-FFF2-40B4-BE49-F238E27FC236}">
-                <a16:creationId xmlns:a16="http://schemas.microsoft.com/office/drawing/2014/main" id="{C8DCA0BF-F4B0-4519-8E21-AE95C8C4B156}"/>
+                <a16:creationId xmlns:a16="http://schemas.microsoft.com/office/drawing/2014/main" id="{C309596C-6B0B-47BC-A631-554FDA6547FC}"/>
               </a:ext>
             </a:extLst>
           </p:cNvPr>
@@ -6394,7 +6394,7 @@
           <p:cNvPr id="8" name="">
             <a:extLst xmlns:a="http://schemas.openxmlformats.org/drawingml/2006/main">
               <a:ext uri="{FF2B5EF4-FFF2-40B4-BE49-F238E27FC236}">
-                <a16:creationId xmlns:a16="http://schemas.microsoft.com/office/drawing/2014/main" id="{6D5432A2-E3BA-4FBF-A342-B0BDB47E8193}"/>
+                <a16:creationId xmlns:a16="http://schemas.microsoft.com/office/drawing/2014/main" id="{CD425C59-3C06-40EA-B7C9-890EBDFD8D0F}"/>
               </a:ext>
             </a:extLst>
           </p:cNvPr>
@@ -6482,7 +6482,7 @@
           <p:cNvPr id="9" name="">
             <a:extLst xmlns:a="http://schemas.openxmlformats.org/drawingml/2006/main">
               <a:ext uri="{FF2B5EF4-FFF2-40B4-BE49-F238E27FC236}">
-                <a16:creationId xmlns:a16="http://schemas.microsoft.com/office/drawing/2014/main" id="{9EF2B035-CBEF-4F6F-97BB-B19062399344}"/>
+                <a16:creationId xmlns:a16="http://schemas.microsoft.com/office/drawing/2014/main" id="{A814C15C-2883-4CB2-94E7-F1EEFD9E1A3E}"/>
               </a:ext>
             </a:extLst>
           </p:cNvPr>
@@ -6543,7 +6543,7 @@
           <p:cNvPr id="10" name="">
             <a:extLst xmlns:a="http://schemas.openxmlformats.org/drawingml/2006/main">
               <a:ext uri="{FF2B5EF4-FFF2-40B4-BE49-F238E27FC236}">
-                <a16:creationId xmlns:a16="http://schemas.microsoft.com/office/drawing/2014/main" id="{C3832993-C5E7-43C2-B165-141F2583B8E1}"/>
+                <a16:creationId xmlns:a16="http://schemas.microsoft.com/office/drawing/2014/main" id="{443DB65E-715D-4274-A05F-C9B0F549D257}"/>
               </a:ext>
             </a:extLst>
           </p:cNvPr>
@@ -6631,7 +6631,7 @@
           <p:cNvPr id="11" name="">
             <a:extLst xmlns:a="http://schemas.openxmlformats.org/drawingml/2006/main">
               <a:ext uri="{FF2B5EF4-FFF2-40B4-BE49-F238E27FC236}">
-                <a16:creationId xmlns:a16="http://schemas.microsoft.com/office/drawing/2014/main" id="{7578AA51-D766-43AF-9DC4-FC1649F0FC93}"/>
+                <a16:creationId xmlns:a16="http://schemas.microsoft.com/office/drawing/2014/main" id="{07C8ABC7-1B71-43FA-B3D9-C54325E0E900}"/>
               </a:ext>
             </a:extLst>
           </p:cNvPr>
@@ -6692,7 +6692,7 @@
           <p:cNvPr id="12" name="">
             <a:extLst xmlns:a="http://schemas.openxmlformats.org/drawingml/2006/main">
               <a:ext uri="{FF2B5EF4-FFF2-40B4-BE49-F238E27FC236}">
-                <a16:creationId xmlns:a16="http://schemas.microsoft.com/office/drawing/2014/main" id="{58CB52A7-69DA-4A35-A698-3748CB31FAC9}"/>
+                <a16:creationId xmlns:a16="http://schemas.microsoft.com/office/drawing/2014/main" id="{ED358B4C-C5FB-4C4B-91AD-3CA0F0B85A46}"/>
               </a:ext>
             </a:extLst>
           </p:cNvPr>
@@ -6780,7 +6780,7 @@
           <p:cNvPr id="13" name="">
             <a:extLst xmlns:a="http://schemas.openxmlformats.org/drawingml/2006/main">
               <a:ext uri="{FF2B5EF4-FFF2-40B4-BE49-F238E27FC236}">
-                <a16:creationId xmlns:a16="http://schemas.microsoft.com/office/drawing/2014/main" id="{74AE8D6B-E8A3-4417-9E56-D6BC3BC3F812}"/>
+                <a16:creationId xmlns:a16="http://schemas.microsoft.com/office/drawing/2014/main" id="{B29E8180-6107-4D87-ABCD-C8CAB8CCE743}"/>
               </a:ext>
             </a:extLst>
           </p:cNvPr>
@@ -6841,7 +6841,7 @@
           <p:cNvPr id="14" name="">
             <a:extLst xmlns:a="http://schemas.openxmlformats.org/drawingml/2006/main">
               <a:ext uri="{FF2B5EF4-FFF2-40B4-BE49-F238E27FC236}">
-                <a16:creationId xmlns:a16="http://schemas.microsoft.com/office/drawing/2014/main" id="{D4104042-2122-4A06-80BB-D1A4696B45AC}"/>
+                <a16:creationId xmlns:a16="http://schemas.microsoft.com/office/drawing/2014/main" id="{EE72D269-2800-401B-8019-5A8CB56E22EF}"/>
               </a:ext>
             </a:extLst>
           </p:cNvPr>
@@ -6902,7 +6902,7 @@
           <p:cNvPr id="15" name="">
             <a:extLst xmlns:a="http://schemas.openxmlformats.org/drawingml/2006/main">
               <a:ext uri="{FF2B5EF4-FFF2-40B4-BE49-F238E27FC236}">
-                <a16:creationId xmlns:a16="http://schemas.microsoft.com/office/drawing/2014/main" id="{280A2F86-633F-4E12-A2B7-02DC8398C9DE}"/>
+                <a16:creationId xmlns:a16="http://schemas.microsoft.com/office/drawing/2014/main" id="{E9BF58B2-0EF4-4CFE-B21B-28881765698C}"/>
               </a:ext>
             </a:extLst>
           </p:cNvPr>
@@ -6934,7 +6934,7 @@
           <p:cNvPr id="16" name="">
             <a:extLst xmlns:a="http://schemas.openxmlformats.org/drawingml/2006/main">
               <a:ext uri="{FF2B5EF4-FFF2-40B4-BE49-F238E27FC236}">
-                <a16:creationId xmlns:a16="http://schemas.microsoft.com/office/drawing/2014/main" id="{381DC35E-310C-42ED-9E59-8F4A06BA459E}"/>
+                <a16:creationId xmlns:a16="http://schemas.microsoft.com/office/drawing/2014/main" id="{A1192435-178E-48B5-831E-FC58D135D2C4}"/>
               </a:ext>
             </a:extLst>
           </p:cNvPr>
@@ -6995,7 +6995,7 @@
           <p:cNvPr id="17" name="">
             <a:extLst xmlns:a="http://schemas.openxmlformats.org/drawingml/2006/main">
               <a:ext uri="{FF2B5EF4-FFF2-40B4-BE49-F238E27FC236}">
-                <a16:creationId xmlns:a16="http://schemas.microsoft.com/office/drawing/2014/main" id="{19892C72-DB60-4BB5-A3F9-00F586DE5D99}"/>
+                <a16:creationId xmlns:a16="http://schemas.microsoft.com/office/drawing/2014/main" id="{12104B9F-0CE3-420B-A56E-4725C6C8A89B}"/>
               </a:ext>
             </a:extLst>
           </p:cNvPr>
@@ -7025,7 +7025,7 @@
           <p:cNvPr id="18" name="">
             <a:extLst xmlns:a="http://schemas.openxmlformats.org/drawingml/2006/main">
               <a:ext uri="{FF2B5EF4-FFF2-40B4-BE49-F238E27FC236}">
-                <a16:creationId xmlns:a16="http://schemas.microsoft.com/office/drawing/2014/main" id="{1920121A-6036-4340-AB6C-247D3CE758E5}"/>
+                <a16:creationId xmlns:a16="http://schemas.microsoft.com/office/drawing/2014/main" id="{FBA59E89-6561-45F1-A9BC-7EC87C5C2252}"/>
               </a:ext>
             </a:extLst>
           </p:cNvPr>
@@ -7086,7 +7086,7 @@
           <p:cNvPr id="19" name="">
             <a:extLst xmlns:a="http://schemas.openxmlformats.org/drawingml/2006/main">
               <a:ext uri="{FF2B5EF4-FFF2-40B4-BE49-F238E27FC236}">
-                <a16:creationId xmlns:a16="http://schemas.microsoft.com/office/drawing/2014/main" id="{0581B861-B8F9-4142-974D-814AB90C0426}"/>
+                <a16:creationId xmlns:a16="http://schemas.microsoft.com/office/drawing/2014/main" id="{45B76DF0-CD97-4766-9DF0-1922B630EA46}"/>
               </a:ext>
             </a:extLst>
           </p:cNvPr>
@@ -7147,7 +7147,7 @@
           <p:cNvPr id="20" name="">
             <a:extLst xmlns:a="http://schemas.openxmlformats.org/drawingml/2006/main">
               <a:ext uri="{FF2B5EF4-FFF2-40B4-BE49-F238E27FC236}">
-                <a16:creationId xmlns:a16="http://schemas.microsoft.com/office/drawing/2014/main" id="{4D6EE9A6-D9BC-4C9C-BE67-8CCC3077D836}"/>
+                <a16:creationId xmlns:a16="http://schemas.microsoft.com/office/drawing/2014/main" id="{AD1F75C4-E43F-4710-95C0-33ED3A28D93C}"/>
               </a:ext>
             </a:extLst>
           </p:cNvPr>
@@ -7208,7 +7208,7 @@
           <p:cNvPr id="21" name="">
             <a:extLst xmlns:a="http://schemas.openxmlformats.org/drawingml/2006/main">
               <a:ext uri="{FF2B5EF4-FFF2-40B4-BE49-F238E27FC236}">
-                <a16:creationId xmlns:a16="http://schemas.microsoft.com/office/drawing/2014/main" id="{AA979CFC-7042-4F33-B4DA-EB21537DB151}"/>
+                <a16:creationId xmlns:a16="http://schemas.microsoft.com/office/drawing/2014/main" id="{72DB632D-2523-40A8-8B06-4DBA50DA5187}"/>
               </a:ext>
             </a:extLst>
           </p:cNvPr>
@@ -7238,7 +7238,7 @@
           <p:cNvPr id="22" name="">
             <a:extLst xmlns:a="http://schemas.openxmlformats.org/drawingml/2006/main">
               <a:ext uri="{FF2B5EF4-FFF2-40B4-BE49-F238E27FC236}">
-                <a16:creationId xmlns:a16="http://schemas.microsoft.com/office/drawing/2014/main" id="{B297BD65-A503-42D0-941B-627A4C9F2CF8}"/>
+                <a16:creationId xmlns:a16="http://schemas.microsoft.com/office/drawing/2014/main" id="{A3F7F4B7-7172-40DC-9F75-658B2140BE8D}"/>
               </a:ext>
             </a:extLst>
           </p:cNvPr>
@@ -7299,7 +7299,7 @@
           <p:cNvPr id="23" name="">
             <a:extLst xmlns:a="http://schemas.openxmlformats.org/drawingml/2006/main">
               <a:ext uri="{FF2B5EF4-FFF2-40B4-BE49-F238E27FC236}">
-                <a16:creationId xmlns:a16="http://schemas.microsoft.com/office/drawing/2014/main" id="{D6E62BAB-2A39-4DF0-8F7E-790F506AE9A0}"/>
+                <a16:creationId xmlns:a16="http://schemas.microsoft.com/office/drawing/2014/main" id="{681A4845-B2E5-496C-95B4-3BEC6500C095}"/>
               </a:ext>
             </a:extLst>
           </p:cNvPr>
@@ -7360,7 +7360,7 @@
           <p:cNvPr id="24" name="">
             <a:extLst xmlns:a="http://schemas.openxmlformats.org/drawingml/2006/main">
               <a:ext uri="{FF2B5EF4-FFF2-40B4-BE49-F238E27FC236}">
-                <a16:creationId xmlns:a16="http://schemas.microsoft.com/office/drawing/2014/main" id="{F2912C5F-9BAD-4C50-B491-EC1B3F63F847}"/>
+                <a16:creationId xmlns:a16="http://schemas.microsoft.com/office/drawing/2014/main" id="{F5AE6343-D062-4F2A-B23E-0AA442D952EC}"/>
               </a:ext>
             </a:extLst>
           </p:cNvPr>
@@ -7421,7 +7421,7 @@
           <p:cNvPr id="25" name="">
             <a:extLst xmlns:a="http://schemas.openxmlformats.org/drawingml/2006/main">
               <a:ext uri="{FF2B5EF4-FFF2-40B4-BE49-F238E27FC236}">
-                <a16:creationId xmlns:a16="http://schemas.microsoft.com/office/drawing/2014/main" id="{F8C037C4-F70A-4772-B7BE-3D795477BDFD}"/>
+                <a16:creationId xmlns:a16="http://schemas.microsoft.com/office/drawing/2014/main" id="{6AB4F9B0-DB45-4B46-8C0E-9F759F890CD4}"/>
               </a:ext>
             </a:extLst>
           </p:cNvPr>
@@ -7451,7 +7451,7 @@
           <p:cNvPr id="26" name="">
             <a:extLst xmlns:a="http://schemas.openxmlformats.org/drawingml/2006/main">
               <a:ext uri="{FF2B5EF4-FFF2-40B4-BE49-F238E27FC236}">
-                <a16:creationId xmlns:a16="http://schemas.microsoft.com/office/drawing/2014/main" id="{86BE8C59-34BE-408C-A251-B504DAB75F40}"/>
+                <a16:creationId xmlns:a16="http://schemas.microsoft.com/office/drawing/2014/main" id="{BFA49175-B190-4E05-8842-E1B8719B6615}"/>
               </a:ext>
             </a:extLst>
           </p:cNvPr>
@@ -7512,7 +7512,7 @@
           <p:cNvPr id="27" name="">
             <a:extLst xmlns:a="http://schemas.openxmlformats.org/drawingml/2006/main">
               <a:ext uri="{FF2B5EF4-FFF2-40B4-BE49-F238E27FC236}">
-                <a16:creationId xmlns:a16="http://schemas.microsoft.com/office/drawing/2014/main" id="{3630A85A-6238-4611-852E-644D2E2E81B9}"/>
+                <a16:creationId xmlns:a16="http://schemas.microsoft.com/office/drawing/2014/main" id="{E4CB203A-E1B9-4877-B796-208A6AD42AE5}"/>
               </a:ext>
             </a:extLst>
           </p:cNvPr>
@@ -7573,7 +7573,7 @@
           <p:cNvPr id="28" name="">
             <a:extLst xmlns:a="http://schemas.openxmlformats.org/drawingml/2006/main">
               <a:ext uri="{FF2B5EF4-FFF2-40B4-BE49-F238E27FC236}">
-                <a16:creationId xmlns:a16="http://schemas.microsoft.com/office/drawing/2014/main" id="{0AEFEAB0-0F21-4DE9-87D6-09B84CD82EFA}"/>
+                <a16:creationId xmlns:a16="http://schemas.microsoft.com/office/drawing/2014/main" id="{A2DA7169-08BF-4EC4-995F-BA0D06656448}"/>
               </a:ext>
             </a:extLst>
           </p:cNvPr>
@@ -7634,7 +7634,7 @@
           <p:cNvPr id="29" name="">
             <a:extLst xmlns:a="http://schemas.openxmlformats.org/drawingml/2006/main">
               <a:ext uri="{FF2B5EF4-FFF2-40B4-BE49-F238E27FC236}">
-                <a16:creationId xmlns:a16="http://schemas.microsoft.com/office/drawing/2014/main" id="{6F28967F-C6AC-475A-9F3D-B8D6B362A723}"/>
+                <a16:creationId xmlns:a16="http://schemas.microsoft.com/office/drawing/2014/main" id="{A7DEA0F3-622F-478D-A927-E010A6EE7CAC}"/>
               </a:ext>
             </a:extLst>
           </p:cNvPr>
@@ -7664,7 +7664,7 @@
           <p:cNvPr id="30" name="">
             <a:extLst xmlns:a="http://schemas.openxmlformats.org/drawingml/2006/main">
               <a:ext uri="{FF2B5EF4-FFF2-40B4-BE49-F238E27FC236}">
-                <a16:creationId xmlns:a16="http://schemas.microsoft.com/office/drawing/2014/main" id="{8360D387-961B-4617-BDB6-77C7FCABB14B}"/>
+                <a16:creationId xmlns:a16="http://schemas.microsoft.com/office/drawing/2014/main" id="{8B980F57-A91B-464A-BBB5-41A1046C7E6E}"/>
               </a:ext>
             </a:extLst>
           </p:cNvPr>
@@ -7725,7 +7725,7 @@
           <p:cNvPr id="31" name="">
             <a:extLst xmlns:a="http://schemas.openxmlformats.org/drawingml/2006/main">
               <a:ext uri="{FF2B5EF4-FFF2-40B4-BE49-F238E27FC236}">
-                <a16:creationId xmlns:a16="http://schemas.microsoft.com/office/drawing/2014/main" id="{39FF7863-F81A-4EA9-A4EA-53DFA6E4A226}"/>
+                <a16:creationId xmlns:a16="http://schemas.microsoft.com/office/drawing/2014/main" id="{B85A69E1-CF18-4F6F-A26C-9920D730F966}"/>
               </a:ext>
             </a:extLst>
           </p:cNvPr>
@@ -7786,7 +7786,7 @@
           <p:cNvPr id="32" name="">
             <a:extLst xmlns:a="http://schemas.openxmlformats.org/drawingml/2006/main">
               <a:ext uri="{FF2B5EF4-FFF2-40B4-BE49-F238E27FC236}">
-                <a16:creationId xmlns:a16="http://schemas.microsoft.com/office/drawing/2014/main" id="{9EBE6BBB-ABB0-4E23-9934-D3C9A2C8C6EB}"/>
+                <a16:creationId xmlns:a16="http://schemas.microsoft.com/office/drawing/2014/main" id="{61C24330-BDC6-4438-9DE3-78E95D554BB0}"/>
               </a:ext>
             </a:extLst>
           </p:cNvPr>
@@ -7847,7 +7847,7 @@
           <p:cNvPr id="33" name="">
             <a:extLst xmlns:a="http://schemas.openxmlformats.org/drawingml/2006/main">
               <a:ext uri="{FF2B5EF4-FFF2-40B4-BE49-F238E27FC236}">
-                <a16:creationId xmlns:a16="http://schemas.microsoft.com/office/drawing/2014/main" id="{F69E1710-A1DD-4EB5-92F0-D736A91E2057}"/>
+                <a16:creationId xmlns:a16="http://schemas.microsoft.com/office/drawing/2014/main" id="{ABD61345-4065-44A2-A4C7-F60ECB4CED54}"/>
               </a:ext>
             </a:extLst>
           </p:cNvPr>
@@ -7877,7 +7877,7 @@
           <p:cNvPr id="34" name="">
             <a:extLst xmlns:a="http://schemas.openxmlformats.org/drawingml/2006/main">
               <a:ext uri="{FF2B5EF4-FFF2-40B4-BE49-F238E27FC236}">
-                <a16:creationId xmlns:a16="http://schemas.microsoft.com/office/drawing/2014/main" id="{E08C9055-6CCB-4187-A3F2-AA4BF7F4F2AF}"/>
+                <a16:creationId xmlns:a16="http://schemas.microsoft.com/office/drawing/2014/main" id="{94706B9C-C2E3-40BE-A021-1EE8093C7185}"/>
               </a:ext>
             </a:extLst>
           </p:cNvPr>
@@ -7938,7 +7938,7 @@
           <p:cNvPr id="35" name="">
             <a:extLst xmlns:a="http://schemas.openxmlformats.org/drawingml/2006/main">
               <a:ext uri="{FF2B5EF4-FFF2-40B4-BE49-F238E27FC236}">
-                <a16:creationId xmlns:a16="http://schemas.microsoft.com/office/drawing/2014/main" id="{A73CE67F-6456-475A-8F4E-2DACD4AC65EB}"/>
+                <a16:creationId xmlns:a16="http://schemas.microsoft.com/office/drawing/2014/main" id="{43AF08C1-8272-400A-A9AD-6448061D1833}"/>
               </a:ext>
             </a:extLst>
           </p:cNvPr>
@@ -7999,7 +7999,7 @@
           <p:cNvPr id="36" name="">
             <a:extLst xmlns:a="http://schemas.openxmlformats.org/drawingml/2006/main">
               <a:ext uri="{FF2B5EF4-FFF2-40B4-BE49-F238E27FC236}">
-                <a16:creationId xmlns:a16="http://schemas.microsoft.com/office/drawing/2014/main" id="{3804D119-9A6D-4378-9500-88CC460A7535}"/>
+                <a16:creationId xmlns:a16="http://schemas.microsoft.com/office/drawing/2014/main" id="{958CB4AA-42A8-4F8D-A9C4-8D702CF9717C}"/>
               </a:ext>
             </a:extLst>
           </p:cNvPr>
@@ -8060,7 +8060,7 @@
           <p:cNvPr id="37" name="">
             <a:extLst xmlns:a="http://schemas.openxmlformats.org/drawingml/2006/main">
               <a:ext uri="{FF2B5EF4-FFF2-40B4-BE49-F238E27FC236}">
-                <a16:creationId xmlns:a16="http://schemas.microsoft.com/office/drawing/2014/main" id="{1A299C24-4B37-4434-95CD-B942D41E221F}"/>
+                <a16:creationId xmlns:a16="http://schemas.microsoft.com/office/drawing/2014/main" id="{46A0958D-C4B6-44F8-B090-42EE5ECAB0F4}"/>
               </a:ext>
             </a:extLst>
           </p:cNvPr>
@@ -8121,7 +8121,7 @@
           <p:cNvPr id="38" name="">
             <a:extLst xmlns:a="http://schemas.openxmlformats.org/drawingml/2006/main">
               <a:ext uri="{FF2B5EF4-FFF2-40B4-BE49-F238E27FC236}">
-                <a16:creationId xmlns:a16="http://schemas.microsoft.com/office/drawing/2014/main" id="{E54747A6-5898-4189-8DFD-CBAE800BC0DC}"/>
+                <a16:creationId xmlns:a16="http://schemas.microsoft.com/office/drawing/2014/main" id="{37C027E9-F9A0-450F-A18A-C1CA68C129C1}"/>
               </a:ext>
             </a:extLst>
           </p:cNvPr>
@@ -8182,7 +8182,7 @@
           <p:cNvPr id="39" name="">
             <a:extLst xmlns:a="http://schemas.openxmlformats.org/drawingml/2006/main">
               <a:ext uri="{FF2B5EF4-FFF2-40B4-BE49-F238E27FC236}">
-                <a16:creationId xmlns:a16="http://schemas.microsoft.com/office/drawing/2014/main" id="{723414D9-6984-48B1-9A1F-2BF41529C7D8}"/>
+                <a16:creationId xmlns:a16="http://schemas.microsoft.com/office/drawing/2014/main" id="{67D87B5E-A731-41E7-A353-F61B6B049D7C}"/>
               </a:ext>
             </a:extLst>
           </p:cNvPr>
@@ -8243,7 +8243,7 @@
           <p:cNvPr id="40" name="">
             <a:extLst xmlns:a="http://schemas.openxmlformats.org/drawingml/2006/main">
               <a:ext uri="{FF2B5EF4-FFF2-40B4-BE49-F238E27FC236}">
-                <a16:creationId xmlns:a16="http://schemas.microsoft.com/office/drawing/2014/main" id="{B966269F-9F5F-4C1A-B4D1-1177CF2B28D6}"/>
+                <a16:creationId xmlns:a16="http://schemas.microsoft.com/office/drawing/2014/main" id="{DAAD264A-81EB-41B5-9F17-2122AEE96B55}"/>
               </a:ext>
             </a:extLst>
           </p:cNvPr>
@@ -8302,7 +8302,7 @@
     </p:spTree>
     <p:extLst>
       <p:ext uri="{BB962C8B-B14F-4D97-AF65-F5344CB8AC3E}">
-        <p14:creationId xmlns:p14="http://schemas.microsoft.com/office/powerpoint/2010/main" val="918840178"/>
+        <p14:creationId xmlns:p14="http://schemas.microsoft.com/office/powerpoint/2010/main" val="1066145918"/>
       </p:ext>
     </p:extLst>
   </p:cSld>
@@ -8333,7 +8333,7 @@
           <p:cNvPr id="18" name="">
             <a:extLst xmlns:a="http://schemas.openxmlformats.org/drawingml/2006/main">
               <a:ext uri="{FF2B5EF4-FFF2-40B4-BE49-F238E27FC236}">
-                <a16:creationId xmlns:a16="http://schemas.microsoft.com/office/drawing/2014/main" id="{3134FA2B-0386-4191-A53C-58F468DDEB4B}"/>
+                <a16:creationId xmlns:a16="http://schemas.microsoft.com/office/drawing/2014/main" id="{28C6315A-A278-4462-98AE-6D1D8C08341F}"/>
               </a:ext>
             </a:extLst>
           </p:cNvPr>
@@ -8394,7 +8394,7 @@
           <p:cNvPr id="2" name="">
             <a:extLst xmlns:a="http://schemas.openxmlformats.org/drawingml/2006/main">
               <a:ext uri="{FF2B5EF4-FFF2-40B4-BE49-F238E27FC236}">
-                <a16:creationId xmlns:a16="http://schemas.microsoft.com/office/drawing/2014/main" id="{D619E528-63BE-4BD2-8BC9-3D6CBF8E24EF}"/>
+                <a16:creationId xmlns:a16="http://schemas.microsoft.com/office/drawing/2014/main" id="{FA19AFE6-C541-43DC-9381-20FC8C4F375C}"/>
               </a:ext>
             </a:extLst>
           </p:cNvPr>
@@ -8455,7 +8455,7 @@
           <p:cNvPr id="3" name="">
             <a:extLst xmlns:a="http://schemas.openxmlformats.org/drawingml/2006/main">
               <a:ext uri="{FF2B5EF4-FFF2-40B4-BE49-F238E27FC236}">
-                <a16:creationId xmlns:a16="http://schemas.microsoft.com/office/drawing/2014/main" id="{80EEE93E-C9E3-43F4-91E2-CD63C8E071E8}"/>
+                <a16:creationId xmlns:a16="http://schemas.microsoft.com/office/drawing/2014/main" id="{A9167E12-3CD4-4646-B423-3DAD9BC9793E}"/>
               </a:ext>
             </a:extLst>
           </p:cNvPr>
@@ -8485,7 +8485,7 @@
           <p:cNvPr id="4" name="">
             <a:extLst xmlns:a="http://schemas.openxmlformats.org/drawingml/2006/main">
               <a:ext uri="{FF2B5EF4-FFF2-40B4-BE49-F238E27FC236}">
-                <a16:creationId xmlns:a16="http://schemas.microsoft.com/office/drawing/2014/main" id="{C644B795-278E-4862-9D8A-FEE961D344F8}"/>
+                <a16:creationId xmlns:a16="http://schemas.microsoft.com/office/drawing/2014/main" id="{F9A0AC57-3C7D-448C-8BAC-1C9C8EA27A62}"/>
               </a:ext>
             </a:extLst>
           </p:cNvPr>
@@ -8520,7 +8520,7 @@
           <p:cNvPr id="5" name="">
             <a:extLst xmlns:a="http://schemas.openxmlformats.org/drawingml/2006/main">
               <a:ext uri="{FF2B5EF4-FFF2-40B4-BE49-F238E27FC236}">
-                <a16:creationId xmlns:a16="http://schemas.microsoft.com/office/drawing/2014/main" id="{4CAAD03A-821A-4386-BB8C-893C11B4EFAF}"/>
+                <a16:creationId xmlns:a16="http://schemas.microsoft.com/office/drawing/2014/main" id="{6E62C056-DAAD-491F-B429-12AE7F936BD9}"/>
               </a:ext>
             </a:extLst>
           </p:cNvPr>
@@ -8555,7 +8555,7 @@
           <p:cNvPr id="6" name="">
             <a:extLst xmlns:a="http://schemas.openxmlformats.org/drawingml/2006/main">
               <a:ext uri="{FF2B5EF4-FFF2-40B4-BE49-F238E27FC236}">
-                <a16:creationId xmlns:a16="http://schemas.microsoft.com/office/drawing/2014/main" id="{EFCE3383-6C1A-4368-9AFD-BAD719BFF9D8}"/>
+                <a16:creationId xmlns:a16="http://schemas.microsoft.com/office/drawing/2014/main" id="{E3FBEE6D-6ACF-4546-8A2A-763BD5CB1B07}"/>
               </a:ext>
             </a:extLst>
           </p:cNvPr>
@@ -8616,7 +8616,7 @@
           <p:cNvPr id="7" name="">
             <a:extLst xmlns:a="http://schemas.openxmlformats.org/drawingml/2006/main">
               <a:ext uri="{FF2B5EF4-FFF2-40B4-BE49-F238E27FC236}">
-                <a16:creationId xmlns:a16="http://schemas.microsoft.com/office/drawing/2014/main" id="{7DA8C83A-8D2B-40FA-B9D7-646214EA4FF3}"/>
+                <a16:creationId xmlns:a16="http://schemas.microsoft.com/office/drawing/2014/main" id="{5B7D411F-15B7-4575-87E3-5B2FB37F7D05}"/>
               </a:ext>
             </a:extLst>
           </p:cNvPr>
@@ -8677,7 +8677,7 @@
           <p:cNvPr id="8" name="">
             <a:extLst xmlns:a="http://schemas.openxmlformats.org/drawingml/2006/main">
               <a:ext uri="{FF2B5EF4-FFF2-40B4-BE49-F238E27FC236}">
-                <a16:creationId xmlns:a16="http://schemas.microsoft.com/office/drawing/2014/main" id="{D433CA70-0D24-42BB-BCB0-18C8EC49E77A}"/>
+                <a16:creationId xmlns:a16="http://schemas.microsoft.com/office/drawing/2014/main" id="{4B44A8D8-8277-4EFF-A0FC-9DAA0566D64A}"/>
               </a:ext>
             </a:extLst>
           </p:cNvPr>
@@ -8792,7 +8792,7 @@
           <p:cNvPr id="9" name="">
             <a:extLst xmlns:a="http://schemas.openxmlformats.org/drawingml/2006/main">
               <a:ext uri="{FF2B5EF4-FFF2-40B4-BE49-F238E27FC236}">
-                <a16:creationId xmlns:a16="http://schemas.microsoft.com/office/drawing/2014/main" id="{903B1FA9-DEEA-453A-815C-BCD9CD133518}"/>
+                <a16:creationId xmlns:a16="http://schemas.microsoft.com/office/drawing/2014/main" id="{D62B0140-059F-4F4F-B254-9DD469A89A78}"/>
               </a:ext>
             </a:extLst>
           </p:cNvPr>
@@ -8853,7 +8853,7 @@
           <p:cNvPr id="10" name="">
             <a:extLst xmlns:a="http://schemas.openxmlformats.org/drawingml/2006/main">
               <a:ext uri="{FF2B5EF4-FFF2-40B4-BE49-F238E27FC236}">
-                <a16:creationId xmlns:a16="http://schemas.microsoft.com/office/drawing/2014/main" id="{D060580C-8AD0-4E88-8B3E-4714B6C6D173}"/>
+                <a16:creationId xmlns:a16="http://schemas.microsoft.com/office/drawing/2014/main" id="{0A0A3FB9-55F2-492D-BE68-84EB7233E6C3}"/>
               </a:ext>
             </a:extLst>
           </p:cNvPr>
@@ -8914,7 +8914,7 @@
           <p:cNvPr id="11" name="">
             <a:extLst xmlns:a="http://schemas.openxmlformats.org/drawingml/2006/main">
               <a:ext uri="{FF2B5EF4-FFF2-40B4-BE49-F238E27FC236}">
-                <a16:creationId xmlns:a16="http://schemas.microsoft.com/office/drawing/2014/main" id="{7CD08701-DAE4-4355-9990-AFAB9F73285B}"/>
+                <a16:creationId xmlns:a16="http://schemas.microsoft.com/office/drawing/2014/main" id="{54EE1389-DB63-4DDE-A769-9DD3CCE8EF19}"/>
               </a:ext>
             </a:extLst>
           </p:cNvPr>
@@ -9029,7 +9029,7 @@
           <p:cNvPr id="12" name="">
             <a:extLst xmlns:a="http://schemas.openxmlformats.org/drawingml/2006/main">
               <a:ext uri="{FF2B5EF4-FFF2-40B4-BE49-F238E27FC236}">
-                <a16:creationId xmlns:a16="http://schemas.microsoft.com/office/drawing/2014/main" id="{B2A7B5BD-FDE0-4A7D-B4C7-85AF64DFB8F0}"/>
+                <a16:creationId xmlns:a16="http://schemas.microsoft.com/office/drawing/2014/main" id="{E3D50231-DB48-4CA3-B377-6A679220273B}"/>
               </a:ext>
             </a:extLst>
           </p:cNvPr>
@@ -9090,7 +9090,7 @@
           <p:cNvPr id="13" name="">
             <a:extLst xmlns:a="http://schemas.openxmlformats.org/drawingml/2006/main">
               <a:ext uri="{FF2B5EF4-FFF2-40B4-BE49-F238E27FC236}">
-                <a16:creationId xmlns:a16="http://schemas.microsoft.com/office/drawing/2014/main" id="{DEC00ADA-46B2-44BD-B588-5A031536207E}"/>
+                <a16:creationId xmlns:a16="http://schemas.microsoft.com/office/drawing/2014/main" id="{7DE9DC8F-374B-47B4-A2A5-1E7D1520EA97}"/>
               </a:ext>
             </a:extLst>
           </p:cNvPr>
@@ -9151,7 +9151,7 @@
           <p:cNvPr id="14" name="">
             <a:extLst xmlns:a="http://schemas.openxmlformats.org/drawingml/2006/main">
               <a:ext uri="{FF2B5EF4-FFF2-40B4-BE49-F238E27FC236}">
-                <a16:creationId xmlns:a16="http://schemas.microsoft.com/office/drawing/2014/main" id="{863C794D-B753-4E7C-9473-776B87030AD1}"/>
+                <a16:creationId xmlns:a16="http://schemas.microsoft.com/office/drawing/2014/main" id="{A6CE81EC-27C3-4CB2-B5A8-2785BBC5CA3E}"/>
               </a:ext>
             </a:extLst>
           </p:cNvPr>
@@ -9212,7 +9212,7 @@
           <p:cNvPr id="15" name="">
             <a:extLst xmlns:a="http://schemas.openxmlformats.org/drawingml/2006/main">
               <a:ext uri="{FF2B5EF4-FFF2-40B4-BE49-F238E27FC236}">
-                <a16:creationId xmlns:a16="http://schemas.microsoft.com/office/drawing/2014/main" id="{D5B23A58-AC3F-4565-BB50-3C4A54A4C829}"/>
+                <a16:creationId xmlns:a16="http://schemas.microsoft.com/office/drawing/2014/main" id="{837E6330-ACD6-47D9-8713-3F23B547D3D0}"/>
               </a:ext>
             </a:extLst>
           </p:cNvPr>
@@ -9273,7 +9273,7 @@
           <p:cNvPr id="16" name="">
             <a:extLst xmlns:a="http://schemas.openxmlformats.org/drawingml/2006/main">
               <a:ext uri="{FF2B5EF4-FFF2-40B4-BE49-F238E27FC236}">
-                <a16:creationId xmlns:a16="http://schemas.microsoft.com/office/drawing/2014/main" id="{476229F9-0A61-40CD-AC10-25D1BF4633CE}"/>
+                <a16:creationId xmlns:a16="http://schemas.microsoft.com/office/drawing/2014/main" id="{E6DD2049-695E-46AB-8872-2471B78C2A1C}"/>
               </a:ext>
             </a:extLst>
           </p:cNvPr>
@@ -9334,7 +9334,7 @@
           <p:cNvPr id="17" name="">
             <a:extLst xmlns:a="http://schemas.openxmlformats.org/drawingml/2006/main">
               <a:ext uri="{FF2B5EF4-FFF2-40B4-BE49-F238E27FC236}">
-                <a16:creationId xmlns:a16="http://schemas.microsoft.com/office/drawing/2014/main" id="{19B68A92-0A26-4F37-9E2C-0BF0FFE20CB8}"/>
+                <a16:creationId xmlns:a16="http://schemas.microsoft.com/office/drawing/2014/main" id="{D313D173-78E2-47D5-975D-7CAD1FADD03C}"/>
               </a:ext>
             </a:extLst>
           </p:cNvPr>
@@ -9393,7 +9393,7 @@
     </p:spTree>
     <p:extLst>
       <p:ext uri="{BB962C8B-B14F-4D97-AF65-F5344CB8AC3E}">
-        <p14:creationId xmlns:p14="http://schemas.microsoft.com/office/powerpoint/2010/main" val="1913073268"/>
+        <p14:creationId xmlns:p14="http://schemas.microsoft.com/office/powerpoint/2010/main" val="1453488498"/>
       </p:ext>
     </p:extLst>
   </p:cSld>
@@ -9424,7 +9424,7 @@
           <p:cNvPr id="11" name="">
             <a:extLst xmlns:a="http://schemas.openxmlformats.org/drawingml/2006/main">
               <a:ext uri="{FF2B5EF4-FFF2-40B4-BE49-F238E27FC236}">
-                <a16:creationId xmlns:a16="http://schemas.microsoft.com/office/drawing/2014/main" id="{2CD30BF4-E8A7-4770-8019-0AB6C8847153}"/>
+                <a16:creationId xmlns:a16="http://schemas.microsoft.com/office/drawing/2014/main" id="{59947790-5D2A-487F-801A-155F0D0D7231}"/>
               </a:ext>
             </a:extLst>
           </p:cNvPr>
@@ -9485,7 +9485,7 @@
           <p:cNvPr id="2" name="">
             <a:extLst xmlns:a="http://schemas.openxmlformats.org/drawingml/2006/main">
               <a:ext uri="{FF2B5EF4-FFF2-40B4-BE49-F238E27FC236}">
-                <a16:creationId xmlns:a16="http://schemas.microsoft.com/office/drawing/2014/main" id="{8081AEA0-9DD4-4D88-BA2D-73B61BB17C87}"/>
+                <a16:creationId xmlns:a16="http://schemas.microsoft.com/office/drawing/2014/main" id="{DABABDBB-A72E-4DC1-8B82-1E453811C75E}"/>
               </a:ext>
             </a:extLst>
           </p:cNvPr>
@@ -9546,7 +9546,7 @@
           <p:cNvPr id="3" name="">
             <a:extLst xmlns:a="http://schemas.openxmlformats.org/drawingml/2006/main">
               <a:ext uri="{FF2B5EF4-FFF2-40B4-BE49-F238E27FC236}">
-                <a16:creationId xmlns:a16="http://schemas.microsoft.com/office/drawing/2014/main" id="{2E398F8D-1A64-465E-A545-4BCE70B222C6}"/>
+                <a16:creationId xmlns:a16="http://schemas.microsoft.com/office/drawing/2014/main" id="{57B43A4C-38BF-4580-9947-AB1B2B6E2BC0}"/>
               </a:ext>
             </a:extLst>
           </p:cNvPr>
@@ -9580,13 +9580,13 @@
           <p:nvPr/>
         </p:nvPicPr>
         <p:blipFill>
-          <a:blip xmlns:r="http://schemas.openxmlformats.org/officeDocument/2006/relationships" xmlns:a="http://schemas.openxmlformats.org/drawingml/2006/main" r:embed="R80fe31b6c2e24c56"/>
+          <a:blip xmlns:r="http://schemas.openxmlformats.org/officeDocument/2006/relationships" xmlns:a="http://schemas.openxmlformats.org/drawingml/2006/main" r:embed="R56704a3da11a490d"/>
           <a:stretch xmlns:a="http://schemas.openxmlformats.org/drawingml/2006/main"/>
         </p:blipFill>
         <p:spPr>
           <a:xfrm xmlns:a="http://schemas.openxmlformats.org/drawingml/2006/main">
-            <a:off x="1924151" y="1571625"/>
-            <a:ext cx="8343698" cy="4695825"/>
+            <a:off x="1975174" y="1571625"/>
+            <a:ext cx="8241652" cy="4695825"/>
           </a:xfrm>
           <a:prstGeom xmlns:a="http://schemas.openxmlformats.org/drawingml/2006/main" prst="roundRect">
             <a:avLst>
@@ -9600,7 +9600,7 @@
           <p:cNvPr id="5" name="">
             <a:extLst xmlns:a="http://schemas.openxmlformats.org/drawingml/2006/main">
               <a:ext uri="{FF2B5EF4-FFF2-40B4-BE49-F238E27FC236}">
-                <a16:creationId xmlns:a16="http://schemas.microsoft.com/office/drawing/2014/main" id="{B911CFB4-34F5-4B5D-B6AC-A949EF154609}"/>
+                <a16:creationId xmlns:a16="http://schemas.microsoft.com/office/drawing/2014/main" id="{38E24B52-05F8-4D56-B315-FA6AF342061E}"/>
               </a:ext>
             </a:extLst>
           </p:cNvPr>
@@ -9632,7 +9632,7 @@
           <p:cNvPr id="6" name="">
             <a:extLst xmlns:a="http://schemas.openxmlformats.org/drawingml/2006/main">
               <a:ext uri="{FF2B5EF4-FFF2-40B4-BE49-F238E27FC236}">
-                <a16:creationId xmlns:a16="http://schemas.microsoft.com/office/drawing/2014/main" id="{D6530455-FAF3-4DC3-AC82-2BD1C0374E0A}"/>
+                <a16:creationId xmlns:a16="http://schemas.microsoft.com/office/drawing/2014/main" id="{73EC8428-B33B-4E2B-B96E-42BFC22C92D6}"/>
               </a:ext>
             </a:extLst>
           </p:cNvPr>
@@ -9693,7 +9693,7 @@
           <p:cNvPr id="7" name="">
             <a:extLst xmlns:a="http://schemas.openxmlformats.org/drawingml/2006/main">
               <a:ext uri="{FF2B5EF4-FFF2-40B4-BE49-F238E27FC236}">
-                <a16:creationId xmlns:a16="http://schemas.microsoft.com/office/drawing/2014/main" id="{8D5F7A7C-B3B5-4A44-B821-4EA7BFDE744A}"/>
+                <a16:creationId xmlns:a16="http://schemas.microsoft.com/office/drawing/2014/main" id="{43661B85-8547-4F10-801C-B21A1783B30E}"/>
               </a:ext>
             </a:extLst>
           </p:cNvPr>
@@ -9725,7 +9725,7 @@
           <p:cNvPr id="8" name="">
             <a:extLst xmlns:a="http://schemas.openxmlformats.org/drawingml/2006/main">
               <a:ext uri="{FF2B5EF4-FFF2-40B4-BE49-F238E27FC236}">
-                <a16:creationId xmlns:a16="http://schemas.microsoft.com/office/drawing/2014/main" id="{84469CA3-A700-4378-9126-8FA89BC8E0E3}"/>
+                <a16:creationId xmlns:a16="http://schemas.microsoft.com/office/drawing/2014/main" id="{2DAA11C1-A84C-4DDE-8725-58CE27D6CCFB}"/>
               </a:ext>
             </a:extLst>
           </p:cNvPr>
@@ -9786,7 +9786,7 @@
           <p:cNvPr id="9" name="">
             <a:extLst xmlns:a="http://schemas.openxmlformats.org/drawingml/2006/main">
               <a:ext uri="{FF2B5EF4-FFF2-40B4-BE49-F238E27FC236}">
-                <a16:creationId xmlns:a16="http://schemas.microsoft.com/office/drawing/2014/main" id="{02BB6936-C086-441D-9DFB-27BAA6C19B18}"/>
+                <a16:creationId xmlns:a16="http://schemas.microsoft.com/office/drawing/2014/main" id="{0D022EB6-B72B-470F-B8D3-401352DC8906}"/>
               </a:ext>
             </a:extLst>
           </p:cNvPr>
@@ -9847,7 +9847,7 @@
           <p:cNvPr id="10" name="">
             <a:extLst xmlns:a="http://schemas.openxmlformats.org/drawingml/2006/main">
               <a:ext uri="{FF2B5EF4-FFF2-40B4-BE49-F238E27FC236}">
-                <a16:creationId xmlns:a16="http://schemas.microsoft.com/office/drawing/2014/main" id="{4C629C7D-CC70-4230-94BA-F160F61AC722}"/>
+                <a16:creationId xmlns:a16="http://schemas.microsoft.com/office/drawing/2014/main" id="{8DC3AE64-3099-4CFD-960F-073359C91C27}"/>
               </a:ext>
             </a:extLst>
           </p:cNvPr>
@@ -9906,7 +9906,7 @@
     </p:spTree>
     <p:extLst>
       <p:ext uri="{BB962C8B-B14F-4D97-AF65-F5344CB8AC3E}">
-        <p14:creationId xmlns:p14="http://schemas.microsoft.com/office/powerpoint/2010/main" val="1944158573"/>
+        <p14:creationId xmlns:p14="http://schemas.microsoft.com/office/powerpoint/2010/main" val="987156391"/>
       </p:ext>
     </p:extLst>
   </p:cSld>
@@ -9937,7 +9937,7 @@
           <p:cNvPr id="18" name="">
             <a:extLst xmlns:a="http://schemas.openxmlformats.org/drawingml/2006/main">
               <a:ext uri="{FF2B5EF4-FFF2-40B4-BE49-F238E27FC236}">
-                <a16:creationId xmlns:a16="http://schemas.microsoft.com/office/drawing/2014/main" id="{082F6F5C-27C2-4630-AAAC-D0B8F3E8B588}"/>
+                <a16:creationId xmlns:a16="http://schemas.microsoft.com/office/drawing/2014/main" id="{89A52C70-BE10-4C5A-B751-C5A5E3D1FA87}"/>
               </a:ext>
             </a:extLst>
           </p:cNvPr>
@@ -9998,7 +9998,7 @@
           <p:cNvPr id="2" name="">
             <a:extLst xmlns:a="http://schemas.openxmlformats.org/drawingml/2006/main">
               <a:ext uri="{FF2B5EF4-FFF2-40B4-BE49-F238E27FC236}">
-                <a16:creationId xmlns:a16="http://schemas.microsoft.com/office/drawing/2014/main" id="{59C2D077-661C-41D5-AA49-8A3903125364}"/>
+                <a16:creationId xmlns:a16="http://schemas.microsoft.com/office/drawing/2014/main" id="{67B6799D-FE0C-4048-B1C0-124A3199ACC8}"/>
               </a:ext>
             </a:extLst>
           </p:cNvPr>
@@ -10059,7 +10059,7 @@
           <p:cNvPr id="3" name="">
             <a:extLst xmlns:a="http://schemas.openxmlformats.org/drawingml/2006/main">
               <a:ext uri="{FF2B5EF4-FFF2-40B4-BE49-F238E27FC236}">
-                <a16:creationId xmlns:a16="http://schemas.microsoft.com/office/drawing/2014/main" id="{E31B4F66-1802-4566-8754-018E51861590}"/>
+                <a16:creationId xmlns:a16="http://schemas.microsoft.com/office/drawing/2014/main" id="{BE8437DD-0C6B-41F7-9BAB-01F15B8E8058}"/>
               </a:ext>
             </a:extLst>
           </p:cNvPr>
@@ -10096,7 +10096,7 @@
         </p:xfrm>
         <a:graphic xmlns:a="http://schemas.openxmlformats.org/drawingml/2006/main">
           <a:graphicData uri="http://schemas.openxmlformats.org/drawingml/2006/chart">
-            <c:chart xmlns:r="http://schemas.openxmlformats.org/officeDocument/2006/relationships" xmlns:c="http://schemas.openxmlformats.org/drawingml/2006/chart" r:id="Ra21082a75c6943b9"/>
+            <c:chart xmlns:r="http://schemas.openxmlformats.org/officeDocument/2006/relationships" xmlns:c="http://schemas.openxmlformats.org/drawingml/2006/chart" r:id="R220173e118864889"/>
           </a:graphicData>
         </a:graphic>
       </p:graphicFrame>
@@ -10105,7 +10105,7 @@
           <p:cNvPr id="5" name="">
             <a:extLst xmlns:a="http://schemas.openxmlformats.org/drawingml/2006/main">
               <a:ext uri="{FF2B5EF4-FFF2-40B4-BE49-F238E27FC236}">
-                <a16:creationId xmlns:a16="http://schemas.microsoft.com/office/drawing/2014/main" id="{1635035F-FE72-4AB9-BD71-7A965421A99E}"/>
+                <a16:creationId xmlns:a16="http://schemas.microsoft.com/office/drawing/2014/main" id="{68CC15BA-3B1E-4E5B-9876-F44933FDE350}"/>
               </a:ext>
             </a:extLst>
           </p:cNvPr>
@@ -10140,7 +10140,7 @@
           <p:cNvPr id="6" name="">
             <a:extLst xmlns:a="http://schemas.openxmlformats.org/drawingml/2006/main">
               <a:ext uri="{FF2B5EF4-FFF2-40B4-BE49-F238E27FC236}">
-                <a16:creationId xmlns:a16="http://schemas.microsoft.com/office/drawing/2014/main" id="{69E04583-0187-4634-9CC7-4C30B7E64038}"/>
+                <a16:creationId xmlns:a16="http://schemas.microsoft.com/office/drawing/2014/main" id="{E4EEBB24-F909-47B7-9FA5-087F73295424}"/>
               </a:ext>
             </a:extLst>
           </p:cNvPr>
@@ -10201,7 +10201,7 @@
           <p:cNvPr id="7" name="">
             <a:extLst xmlns:a="http://schemas.openxmlformats.org/drawingml/2006/main">
               <a:ext uri="{FF2B5EF4-FFF2-40B4-BE49-F238E27FC236}">
-                <a16:creationId xmlns:a16="http://schemas.microsoft.com/office/drawing/2014/main" id="{56E7CEA4-2AD8-487A-934D-711A0EDD7239}"/>
+                <a16:creationId xmlns:a16="http://schemas.microsoft.com/office/drawing/2014/main" id="{C3C2A2BB-A709-4A8A-A554-C16EA4BF3DA0}"/>
               </a:ext>
             </a:extLst>
           </p:cNvPr>
@@ -10262,7 +10262,7 @@
           <p:cNvPr id="8" name="">
             <a:extLst xmlns:a="http://schemas.openxmlformats.org/drawingml/2006/main">
               <a:ext uri="{FF2B5EF4-FFF2-40B4-BE49-F238E27FC236}">
-                <a16:creationId xmlns:a16="http://schemas.microsoft.com/office/drawing/2014/main" id="{21E40B8C-55AD-4D54-9707-AC23A3CE062E}"/>
+                <a16:creationId xmlns:a16="http://schemas.microsoft.com/office/drawing/2014/main" id="{6B4D76BA-8F66-41D0-AE11-4FC1D56FA1B6}"/>
               </a:ext>
             </a:extLst>
           </p:cNvPr>
@@ -10297,7 +10297,7 @@
           <p:cNvPr id="9" name="">
             <a:extLst xmlns:a="http://schemas.openxmlformats.org/drawingml/2006/main">
               <a:ext uri="{FF2B5EF4-FFF2-40B4-BE49-F238E27FC236}">
-                <a16:creationId xmlns:a16="http://schemas.microsoft.com/office/drawing/2014/main" id="{E07B8CDF-5197-495E-91A7-4584E6591B83}"/>
+                <a16:creationId xmlns:a16="http://schemas.microsoft.com/office/drawing/2014/main" id="{F69EC58E-F6FF-4474-8709-D3CD0B676573}"/>
               </a:ext>
             </a:extLst>
           </p:cNvPr>
@@ -10358,7 +10358,7 @@
           <p:cNvPr id="10" name="">
             <a:extLst xmlns:a="http://schemas.openxmlformats.org/drawingml/2006/main">
               <a:ext uri="{FF2B5EF4-FFF2-40B4-BE49-F238E27FC236}">
-                <a16:creationId xmlns:a16="http://schemas.microsoft.com/office/drawing/2014/main" id="{34FD6730-7A65-46A2-8895-4E93FF277388}"/>
+                <a16:creationId xmlns:a16="http://schemas.microsoft.com/office/drawing/2014/main" id="{7C3353AB-0D5B-444E-943D-4922E2F745D1}"/>
               </a:ext>
             </a:extLst>
           </p:cNvPr>
@@ -10419,7 +10419,7 @@
           <p:cNvPr id="11" name="">
             <a:extLst xmlns:a="http://schemas.openxmlformats.org/drawingml/2006/main">
               <a:ext uri="{FF2B5EF4-FFF2-40B4-BE49-F238E27FC236}">
-                <a16:creationId xmlns:a16="http://schemas.microsoft.com/office/drawing/2014/main" id="{02DB2602-55A6-4802-A533-755FC02B0C2E}"/>
+                <a16:creationId xmlns:a16="http://schemas.microsoft.com/office/drawing/2014/main" id="{04368B35-B5C0-4F52-9418-BB0316AF8540}"/>
               </a:ext>
             </a:extLst>
           </p:cNvPr>
@@ -10454,7 +10454,7 @@
           <p:cNvPr id="12" name="">
             <a:extLst xmlns:a="http://schemas.openxmlformats.org/drawingml/2006/main">
               <a:ext uri="{FF2B5EF4-FFF2-40B4-BE49-F238E27FC236}">
-                <a16:creationId xmlns:a16="http://schemas.microsoft.com/office/drawing/2014/main" id="{D37A20E1-BE5A-468C-915D-3125E441DDCD}"/>
+                <a16:creationId xmlns:a16="http://schemas.microsoft.com/office/drawing/2014/main" id="{E3C22475-ECA9-482A-A7FF-37596693361F}"/>
               </a:ext>
             </a:extLst>
           </p:cNvPr>
@@ -10515,7 +10515,7 @@
           <p:cNvPr id="13" name="">
             <a:extLst xmlns:a="http://schemas.openxmlformats.org/drawingml/2006/main">
               <a:ext uri="{FF2B5EF4-FFF2-40B4-BE49-F238E27FC236}">
-                <a16:creationId xmlns:a16="http://schemas.microsoft.com/office/drawing/2014/main" id="{53024204-9B60-4584-8914-FC095F7199D8}"/>
+                <a16:creationId xmlns:a16="http://schemas.microsoft.com/office/drawing/2014/main" id="{568AB57A-DE81-4873-ACBE-5C9A7CE5B6F9}"/>
               </a:ext>
             </a:extLst>
           </p:cNvPr>
@@ -10576,7 +10576,7 @@
           <p:cNvPr id="14" name="">
             <a:extLst xmlns:a="http://schemas.openxmlformats.org/drawingml/2006/main">
               <a:ext uri="{FF2B5EF4-FFF2-40B4-BE49-F238E27FC236}">
-                <a16:creationId xmlns:a16="http://schemas.microsoft.com/office/drawing/2014/main" id="{2D77F0C6-D8EE-4BA6-9CAA-5BFAC293533F}"/>
+                <a16:creationId xmlns:a16="http://schemas.microsoft.com/office/drawing/2014/main" id="{BFD6A084-E400-4193-90C1-B80D83EBB95E}"/>
               </a:ext>
             </a:extLst>
           </p:cNvPr>
@@ -10637,7 +10637,7 @@
           <p:cNvPr id="15" name="">
             <a:extLst xmlns:a="http://schemas.openxmlformats.org/drawingml/2006/main">
               <a:ext uri="{FF2B5EF4-FFF2-40B4-BE49-F238E27FC236}">
-                <a16:creationId xmlns:a16="http://schemas.microsoft.com/office/drawing/2014/main" id="{9F7326A6-64F9-48D6-A845-F34291F9D057}"/>
+                <a16:creationId xmlns:a16="http://schemas.microsoft.com/office/drawing/2014/main" id="{79E4693B-3D02-41D1-8A16-CE8B16CC7A3F}"/>
               </a:ext>
             </a:extLst>
           </p:cNvPr>
@@ -10698,7 +10698,7 @@
           <p:cNvPr id="16" name="">
             <a:extLst xmlns:a="http://schemas.openxmlformats.org/drawingml/2006/main">
               <a:ext uri="{FF2B5EF4-FFF2-40B4-BE49-F238E27FC236}">
-                <a16:creationId xmlns:a16="http://schemas.microsoft.com/office/drawing/2014/main" id="{5E776875-7C59-4089-9043-51B4538E50D7}"/>
+                <a16:creationId xmlns:a16="http://schemas.microsoft.com/office/drawing/2014/main" id="{A3DDF405-F2EB-424A-8B00-8F2E89379F25}"/>
               </a:ext>
             </a:extLst>
           </p:cNvPr>
@@ -10759,7 +10759,7 @@
           <p:cNvPr id="17" name="">
             <a:extLst xmlns:a="http://schemas.openxmlformats.org/drawingml/2006/main">
               <a:ext uri="{FF2B5EF4-FFF2-40B4-BE49-F238E27FC236}">
-                <a16:creationId xmlns:a16="http://schemas.microsoft.com/office/drawing/2014/main" id="{FCC8A681-1DD8-45C0-A349-DFE28EF387BB}"/>
+                <a16:creationId xmlns:a16="http://schemas.microsoft.com/office/drawing/2014/main" id="{FEAE8263-A84A-4E33-9B3B-2E96D58536C4}"/>
               </a:ext>
             </a:extLst>
           </p:cNvPr>
@@ -10818,7 +10818,7 @@
     </p:spTree>
     <p:extLst>
       <p:ext uri="{BB962C8B-B14F-4D97-AF65-F5344CB8AC3E}">
-        <p14:creationId xmlns:p14="http://schemas.microsoft.com/office/powerpoint/2010/main" val="4459011"/>
+        <p14:creationId xmlns:p14="http://schemas.microsoft.com/office/powerpoint/2010/main" val="318843134"/>
       </p:ext>
     </p:extLst>
   </p:cSld>

</xml_diff>

<commit_message>
Expand final presentation with trade-off analysis
</commit_message>
<xml_diff>
--- a/06_demo/output/AI_Scroll_5_Minute_Presentation.pptx
+++ b/06_demo/output/AI_Scroll_5_Minute_Presentation.pptx
@@ -2,19 +2,20 @@
 <file path=ppt/presentation.xml><?xml version="1.0" encoding="utf-8"?>
 <p:presentation xmlns:p="http://schemas.openxmlformats.org/presentationml/2006/main">
   <p:sldMasterIdLst>
-    <p:sldMasterId xmlns:r="http://schemas.openxmlformats.org/officeDocument/2006/relationships" id="2147483648" r:id="R6c9f6e1dfa3b473e"/>
+    <p:sldMasterId xmlns:r="http://schemas.openxmlformats.org/officeDocument/2006/relationships" id="2147483648" r:id="Rdf6f0c6efbdb45d8"/>
   </p:sldMasterIdLst>
   <p:notesMasterIdLst>
-    <p:notesMasterId xmlns:r="http://schemas.openxmlformats.org/officeDocument/2006/relationships" r:id="Reacb402043f84d23"/>
+    <p:notesMasterId xmlns:r="http://schemas.openxmlformats.org/officeDocument/2006/relationships" r:id="R1bdd279fff904bdb"/>
   </p:notesMasterIdLst>
   <p:sldIdLst>
-    <p:sldId xmlns:r="http://schemas.openxmlformats.org/officeDocument/2006/relationships" id="256" r:id="Ra07e5c516f854b73"/>
-    <p:sldId xmlns:r="http://schemas.openxmlformats.org/officeDocument/2006/relationships" id="257" r:id="Rd90752f5034142d3"/>
-    <p:sldId xmlns:r="http://schemas.openxmlformats.org/officeDocument/2006/relationships" id="258" r:id="R694848a105ad439f"/>
-    <p:sldId xmlns:r="http://schemas.openxmlformats.org/officeDocument/2006/relationships" id="259" r:id="R57ef0d781b5e4d33"/>
-    <p:sldId xmlns:r="http://schemas.openxmlformats.org/officeDocument/2006/relationships" id="260" r:id="R5fa8790bad2a4bf7"/>
-    <p:sldId xmlns:r="http://schemas.openxmlformats.org/officeDocument/2006/relationships" id="261" r:id="R61f2aa5bec5c4438"/>
-    <p:sldId xmlns:r="http://schemas.openxmlformats.org/officeDocument/2006/relationships" id="262" r:id="Rc1638b34fb0a499e"/>
+    <p:sldId xmlns:r="http://schemas.openxmlformats.org/officeDocument/2006/relationships" id="256" r:id="R718a3c1c80674e37"/>
+    <p:sldId xmlns:r="http://schemas.openxmlformats.org/officeDocument/2006/relationships" id="257" r:id="R96ac532ef8d04e78"/>
+    <p:sldId xmlns:r="http://schemas.openxmlformats.org/officeDocument/2006/relationships" id="258" r:id="Raca938527f7a4713"/>
+    <p:sldId xmlns:r="http://schemas.openxmlformats.org/officeDocument/2006/relationships" id="259" r:id="R7ee02b4624a14a9f"/>
+    <p:sldId xmlns:r="http://schemas.openxmlformats.org/officeDocument/2006/relationships" id="260" r:id="R26ae84d303204eb0"/>
+    <p:sldId xmlns:r="http://schemas.openxmlformats.org/officeDocument/2006/relationships" id="261" r:id="R894e585b89c64405"/>
+    <p:sldId xmlns:r="http://schemas.openxmlformats.org/officeDocument/2006/relationships" id="262" r:id="R70bfa76bb6a44227"/>
+    <p:sldId xmlns:r="http://schemas.openxmlformats.org/officeDocument/2006/relationships" id="263" r:id="Ra35426b33b7b402c"/>
   </p:sldIdLst>
   <p:sldSz cx="12192000" cy="6858000"/>
   <p:notesSz cx="6858000" cy="9144000"/>
@@ -798,7 +799,7 @@
           <a:lstStyle xmlns:a="http://schemas.openxmlformats.org/drawingml/2006/main"/>
           <a:p xmlns:a="http://schemas.openxmlformats.org/drawingml/2006/main">
             <a:r>
-              <a:t>This is the current product experience. The left side behaves like an academic inbox. The middle panel keeps the selected email visible, including the exact sentence that created or changed the deadline. The right panel turns the message into a five step action plan. It shows the final deadline, the planned stages and the evidence used by the Agent. The scan button refreshes the interface using the actual mailbox pipeline. Settings stay in a collapsed sidebar, so the main screen remains simple. The user then opens Calendar Review, checks the proposal and confirms it. Without that confirmation, the system performs no calendar write.</a:t>
+              <a:t>The main operating decision is to build the workflow and safety controls while renting the language model and external APIs. Narrow OAuth connectors remove manual copy and paste, but authorization depends on provider and tenant policy. The inbox is checked cheaply using identifiers and course scope, and the model runs only for new or changed messages. The calendar remains preview first and approval gated. In the current live check, six cases cost about 1.1 cents in total.</a:t>
             </a:r>
           </a:p>
         </p:txBody>
@@ -829,6 +830,76 @@
 </file>
 
 <file path=ppt/notesSlides/notesSlide7.xml><?xml version="1.0" encoding="utf-8"?>
+<p:notes xmlns:p="http://schemas.openxmlformats.org/presentationml/2006/main">
+  <p:cSld>
+    <p:spTree>
+      <p:nvGrpSpPr>
+        <p:cNvPr id="1" name=""/>
+        <p:cNvGrpSpPr/>
+        <p:nvPr/>
+      </p:nvGrpSpPr>
+      <p:grpSpPr>
+        <a:xfrm xmlns:a="http://schemas.openxmlformats.org/drawingml/2006/main"/>
+      </p:grpSpPr>
+      <p:sp>
+        <p:nvSpPr>
+          <p:cNvPr id="2" name="Slide Image Placeholder 1"/>
+          <p:cNvSpPr>
+            <a:spLocks xmlns:a="http://schemas.openxmlformats.org/drawingml/2006/main" noGrp="1"/>
+          </p:cNvSpPr>
+          <p:nvPr>
+            <p:ph type="sldImg" idx="0"/>
+          </p:nvPr>
+        </p:nvSpPr>
+        <p:spPr/>
+      </p:sp>
+      <p:sp>
+        <p:nvSpPr>
+          <p:cNvPr id="3" name="Notes Placeholder 2"/>
+          <p:cNvSpPr>
+            <a:spLocks xmlns:a="http://schemas.openxmlformats.org/drawingml/2006/main" noGrp="1"/>
+          </p:cNvSpPr>
+          <p:nvPr>
+            <p:ph type="body" idx="1"/>
+          </p:nvPr>
+        </p:nvSpPr>
+        <p:spPr/>
+        <p:txBody>
+          <a:bodyPr xmlns:a="http://schemas.openxmlformats.org/drawingml/2006/main"/>
+          <a:lstStyle xmlns:a="http://schemas.openxmlformats.org/drawingml/2006/main"/>
+          <a:p xmlns:a="http://schemas.openxmlformats.org/drawingml/2006/main">
+            <a:r>
+              <a:t>This is the current product experience. The left side behaves like an academic inbox. The middle panel keeps the selected email visible, including the exact sentence that created or changed the deadline. The right panel turns the message into a five step action plan. It shows the final deadline, the planned stages and the evidence used by the Agent. The scan button refreshes the interface using the actual mailbox pipeline. Settings stay in a collapsed sidebar, so the main screen remains simple. The user then opens Calendar Review, checks the proposal and confirms it. Without that confirmation, the system performs no calendar write.</a:t>
+            </a:r>
+          </a:p>
+        </p:txBody>
+      </p:sp>
+      <p:sp>
+        <p:nvSpPr>
+          <p:cNvPr id="4" name="Slide Number Placeholder 3"/>
+          <p:cNvSpPr>
+            <a:spLocks xmlns:a="http://schemas.openxmlformats.org/drawingml/2006/main" noGrp="1"/>
+          </p:cNvSpPr>
+          <p:nvPr>
+            <p:ph type="sldNum" idx="5"/>
+          </p:nvPr>
+        </p:nvSpPr>
+        <p:spPr/>
+        <p:txBody>
+          <a:bodyPr xmlns:a="http://schemas.openxmlformats.org/drawingml/2006/main"/>
+          <a:lstStyle xmlns:a="http://schemas.openxmlformats.org/drawingml/2006/main"/>
+          <a:p xmlns:a="http://schemas.openxmlformats.org/drawingml/2006/main"/>
+        </p:txBody>
+      </p:sp>
+    </p:spTree>
+  </p:cSld>
+  <p:clrMapOvr>
+    <a:masterClrMapping xmlns:a="http://schemas.openxmlformats.org/drawingml/2006/main"/>
+  </p:clrMapOvr>
+</p:notes>
+</file>
+
+<file path=ppt/notesSlides/notesSlide8.xml><?xml version="1.0" encoding="utf-8"?>
 <p:notes xmlns:p="http://schemas.openxmlformats.org/presentationml/2006/main">
   <p:cSld>
     <p:spTree>
@@ -936,7 +1007,7 @@
   </p:cSld>
   <p:clrMap bg1="lt1" tx1="dk1" bg2="lt2" tx2="dk2" accent1="accent1" accent2="accent2" accent3="accent3" accent4="accent4" accent5="accent5" accent6="accent6" hlink="hlink" folHlink="folHlink"/>
   <p:sldLayoutIdLst>
-    <p:sldLayoutId xmlns:r="http://schemas.openxmlformats.org/officeDocument/2006/relationships" id="2147483649" r:id="R80c6de40935d4230"/>
+    <p:sldLayoutId xmlns:r="http://schemas.openxmlformats.org/officeDocument/2006/relationships" id="2147483649" r:id="R068bfc19e77c4c5b"/>
   </p:sldLayoutIdLst>
   <p:txStyles>
     <p:titleStyle>
@@ -1768,7 +1839,7 @@
           <p:nvPr/>
         </p:nvPicPr>
         <p:blipFill>
-          <a:blip r:embed="R0a0ca25c0b364db2"/>
+          <a:blip r:embed="R6c21cdc4425443e7"/>
           <a:srcRect l="0" t="27" r="0" b="27"/>
           <a:stretch>
             <a:fillRect l="0" t="0" r="0" b="0"/>
@@ -1789,7 +1860,7 @@
           <p:cNvPr id="2" name="">
             <a:extLst>
               <a:ext uri="{FF2B5EF4-FFF2-40B4-BE49-F238E27FC236}">
-                <ns3:creationId id="{C1BE1BE6-A6A7-4B29-9BE6-E841F64CA886}"/>
+                <ns3:creationId id="{A5500345-4522-45DC-996D-07696AF6E559}"/>
               </a:ext>
             </a:extLst>
           </p:cNvPr>
@@ -1819,7 +1890,7 @@
           <p:cNvPr id="3" name="">
             <a:extLst>
               <a:ext uri="{FF2B5EF4-FFF2-40B4-BE49-F238E27FC236}">
-                <ns3:creationId id="{033574CC-934F-480C-9957-21631D5C9A1D}"/>
+                <ns3:creationId id="{7D7630DA-19CA-48F2-8B58-913DDFAF2885}"/>
               </a:ext>
             </a:extLst>
           </p:cNvPr>
@@ -1880,7 +1951,7 @@
           <p:cNvPr id="4" name="">
             <a:extLst>
               <a:ext uri="{FF2B5EF4-FFF2-40B4-BE49-F238E27FC236}">
-                <ns3:creationId id="{F509286E-5146-4720-9735-32B77F536FF5}"/>
+                <ns3:creationId id="{1C1AE9D8-B12B-4C0B-B542-0C747CCA8F9C}"/>
               </a:ext>
             </a:extLst>
           </p:cNvPr>
@@ -1941,7 +2012,7 @@
           <p:cNvPr id="5" name="">
             <a:extLst>
               <a:ext uri="{FF2B5EF4-FFF2-40B4-BE49-F238E27FC236}">
-                <ns3:creationId id="{4021DFAB-61F1-45F3-B900-1CE4EA862970}"/>
+                <ns3:creationId id="{2587C5A6-9E31-4E45-BC4C-6C2467FAB471}"/>
               </a:ext>
             </a:extLst>
           </p:cNvPr>
@@ -1971,7 +2042,7 @@
           <p:cNvPr id="6" name="">
             <a:extLst>
               <a:ext uri="{FF2B5EF4-FFF2-40B4-BE49-F238E27FC236}">
-                <ns3:creationId id="{E2774A93-ED61-4A62-ADF9-750B0F2E81C5}"/>
+                <ns3:creationId id="{BADA5D7E-DC50-42DA-9708-582F1D3E7498}"/>
               </a:ext>
             </a:extLst>
           </p:cNvPr>
@@ -2059,7 +2130,7 @@
           <p:cNvPr id="7" name="">
             <a:extLst>
               <a:ext uri="{FF2B5EF4-FFF2-40B4-BE49-F238E27FC236}">
-                <ns3:creationId id="{DD36DDC3-3E88-4FDD-8787-B9395BE52623}"/>
+                <ns3:creationId id="{8FCAA29E-DD70-4585-9070-7F6BF1210184}"/>
               </a:ext>
             </a:extLst>
           </p:cNvPr>
@@ -2118,7 +2189,7 @@
     </p:spTree>
     <p:extLst>
       <p:ext uri="{BB962C8B-B14F-4D97-AF65-F5344CB8AC3E}">
-        <ns4:creationId val="1805601852"/>
+        <ns4:creationId val="1836287088"/>
       </p:ext>
     </p:extLst>
   </p:cSld>
@@ -2152,7 +2223,7 @@
           <p:cNvPr id="33" name="">
             <a:extLst>
               <a:ext uri="{FF2B5EF4-FFF2-40B4-BE49-F238E27FC236}">
-                <ns2:creationId id="{8B0B8347-521F-4CA0-9D6F-86AEEC36F336}"/>
+                <ns2:creationId id="{60A1E841-966F-4349-81C5-8FFF0D57AD6B}"/>
               </a:ext>
             </a:extLst>
           </p:cNvPr>
@@ -2213,7 +2284,7 @@
           <p:cNvPr id="2" name="">
             <a:extLst>
               <a:ext uri="{FF2B5EF4-FFF2-40B4-BE49-F238E27FC236}">
-                <ns2:creationId id="{00B74DB2-1335-41C1-915A-134A96819236}"/>
+                <ns2:creationId id="{E03E84C7-75D8-4890-B319-E5D0567E09DC}"/>
               </a:ext>
             </a:extLst>
           </p:cNvPr>
@@ -2274,7 +2345,7 @@
           <p:cNvPr id="3" name="">
             <a:extLst>
               <a:ext uri="{FF2B5EF4-FFF2-40B4-BE49-F238E27FC236}">
-                <ns2:creationId id="{BD3C9CDE-2EAD-4777-BA7E-E265CD27D8D7}"/>
+                <ns2:creationId id="{4AB20B51-89A9-41F8-93EC-57386C66A38B}"/>
               </a:ext>
             </a:extLst>
           </p:cNvPr>
@@ -2304,7 +2375,7 @@
           <p:cNvPr id="4" name="">
             <a:extLst>
               <a:ext uri="{FF2B5EF4-FFF2-40B4-BE49-F238E27FC236}">
-                <ns2:creationId id="{7B0B1375-EAF6-4A7A-AB82-2B641929A0DC}"/>
+                <ns2:creationId id="{C7606308-E777-46FB-85FB-D5FDDEEEB019}"/>
               </a:ext>
             </a:extLst>
           </p:cNvPr>
@@ -2365,7 +2436,7 @@
           <p:cNvPr id="5" name="">
             <a:extLst>
               <a:ext uri="{FF2B5EF4-FFF2-40B4-BE49-F238E27FC236}">
-                <ns2:creationId id="{3F3BB965-31C9-47FE-ABA6-FB66F70DF64B}"/>
+                <ns2:creationId id="{F49ADD1E-1D82-4831-8C46-0A7A8E118DA7}"/>
               </a:ext>
             </a:extLst>
           </p:cNvPr>
@@ -2426,7 +2497,7 @@
           <p:cNvPr id="6" name="">
             <a:extLst>
               <a:ext uri="{FF2B5EF4-FFF2-40B4-BE49-F238E27FC236}">
-                <ns2:creationId id="{30E4D130-AC32-4E09-9E3D-0F71D351C5B5}"/>
+                <ns2:creationId id="{D22BB845-8D44-4EF7-B0E3-B259BFB7C2FF}"/>
               </a:ext>
             </a:extLst>
           </p:cNvPr>
@@ -2487,7 +2558,7 @@
           <p:cNvPr id="7" name="">
             <a:extLst>
               <a:ext uri="{FF2B5EF4-FFF2-40B4-BE49-F238E27FC236}">
-                <ns2:creationId id="{44475ABD-738C-4F34-9BBC-E103F48D5886}"/>
+                <ns2:creationId id="{E80B92D2-1C9C-4478-A769-753D60E8F2FB}"/>
               </a:ext>
             </a:extLst>
           </p:cNvPr>
@@ -2518,7 +2589,7 @@
           <p:cNvPr id="8" name="">
             <a:extLst>
               <a:ext uri="{FF2B5EF4-FFF2-40B4-BE49-F238E27FC236}">
-                <ns2:creationId id="{B7C97C10-7EC1-4E17-96E9-AB9039269439}"/>
+                <ns2:creationId id="{0828645E-FB49-4A16-81E5-9CA1C52188BE}"/>
               </a:ext>
             </a:extLst>
           </p:cNvPr>
@@ -2579,7 +2650,7 @@
           <p:cNvPr id="9" name="">
             <a:extLst>
               <a:ext uri="{FF2B5EF4-FFF2-40B4-BE49-F238E27FC236}">
-                <ns2:creationId id="{ABF3F38F-98F6-4EED-8FEF-2027DC8344BC}"/>
+                <ns2:creationId id="{7ABD217B-097C-4F10-A8EC-3F902D759DA3}"/>
               </a:ext>
             </a:extLst>
           </p:cNvPr>
@@ -2640,7 +2711,7 @@
           <p:cNvPr id="10" name="">
             <a:extLst>
               <a:ext uri="{FF2B5EF4-FFF2-40B4-BE49-F238E27FC236}">
-                <ns2:creationId id="{68756BC6-D0DC-4E52-B69C-5EC714642CFA}"/>
+                <ns2:creationId id="{1F5AD422-3AEF-4B9C-A821-15550602CFAA}"/>
               </a:ext>
             </a:extLst>
           </p:cNvPr>
@@ -2701,7 +2772,7 @@
           <p:cNvPr id="11" name="">
             <a:extLst>
               <a:ext uri="{FF2B5EF4-FFF2-40B4-BE49-F238E27FC236}">
-                <ns2:creationId id="{3D3C863B-D925-44E1-8EBC-6F95960B1D83}"/>
+                <ns2:creationId id="{87CD2DFC-88A3-49F6-8C2B-D00C455EE01B}"/>
               </a:ext>
             </a:extLst>
           </p:cNvPr>
@@ -2732,7 +2803,7 @@
           <p:cNvPr id="12" name="">
             <a:extLst>
               <a:ext uri="{FF2B5EF4-FFF2-40B4-BE49-F238E27FC236}">
-                <ns2:creationId id="{9D918F0D-EC44-402B-A366-641058905F1D}"/>
+                <ns2:creationId id="{474DB69E-6037-479B-BCDB-C6AEF09B662F}"/>
               </a:ext>
             </a:extLst>
           </p:cNvPr>
@@ -2793,7 +2864,7 @@
           <p:cNvPr id="13" name="">
             <a:extLst>
               <a:ext uri="{FF2B5EF4-FFF2-40B4-BE49-F238E27FC236}">
-                <ns2:creationId id="{42E680DE-1D96-46C9-9755-67ABD5884ADF}"/>
+                <ns2:creationId id="{FD88077C-7CF2-4B36-9027-8C0C293A69A7}"/>
               </a:ext>
             </a:extLst>
           </p:cNvPr>
@@ -2854,7 +2925,7 @@
           <p:cNvPr id="14" name="">
             <a:extLst>
               <a:ext uri="{FF2B5EF4-FFF2-40B4-BE49-F238E27FC236}">
-                <ns2:creationId id="{871FF8BD-E40C-4965-BD8B-973F5E54F229}"/>
+                <ns2:creationId id="{6202969F-BC8D-4528-BA46-1413329E6AAD}"/>
               </a:ext>
             </a:extLst>
           </p:cNvPr>
@@ -2915,7 +2986,7 @@
           <p:cNvPr id="15" name="">
             <a:extLst>
               <a:ext uri="{FF2B5EF4-FFF2-40B4-BE49-F238E27FC236}">
-                <ns2:creationId id="{993E2524-7FCE-4262-B9C3-DB190C2B7017}"/>
+                <ns2:creationId id="{8DA70995-FFF6-4E22-9A42-A7D720B7C144}"/>
               </a:ext>
             </a:extLst>
           </p:cNvPr>
@@ -2946,7 +3017,7 @@
           <p:cNvPr id="16" name="">
             <a:extLst>
               <a:ext uri="{FF2B5EF4-FFF2-40B4-BE49-F238E27FC236}">
-                <ns2:creationId id="{A81365F9-C4D5-451B-85AD-235B09419411}"/>
+                <ns2:creationId id="{1234AE42-EB9C-472E-9DCF-6595184B35B1}"/>
               </a:ext>
             </a:extLst>
           </p:cNvPr>
@@ -2978,7 +3049,7 @@
           <p:cNvPr id="17" name="">
             <a:extLst>
               <a:ext uri="{FF2B5EF4-FFF2-40B4-BE49-F238E27FC236}">
-                <ns2:creationId id="{CB61ABDF-6B51-450F-8225-242B503E6CD1}"/>
+                <ns2:creationId id="{FCACB6E9-CF67-4629-B922-9A2FFB1E31FC}"/>
               </a:ext>
             </a:extLst>
           </p:cNvPr>
@@ -3039,7 +3110,7 @@
           <p:cNvPr id="18" name="">
             <a:extLst>
               <a:ext uri="{FF2B5EF4-FFF2-40B4-BE49-F238E27FC236}">
-                <ns2:creationId id="{1BFAF58C-58CB-47A7-9836-6F6D278D52F2}"/>
+                <ns2:creationId id="{DCFE4601-DEAE-4679-8386-29BDFE3246F6}"/>
               </a:ext>
             </a:extLst>
           </p:cNvPr>
@@ -3071,7 +3142,7 @@
           <p:cNvPr id="19" name="">
             <a:extLst>
               <a:ext uri="{FF2B5EF4-FFF2-40B4-BE49-F238E27FC236}">
-                <ns2:creationId id="{AE348F1D-BDF7-493E-8043-65DE537952E1}"/>
+                <ns2:creationId id="{2CF431F5-DE7D-4BBE-8B03-F7558F0C037B}"/>
               </a:ext>
             </a:extLst>
           </p:cNvPr>
@@ -3132,7 +3203,7 @@
           <p:cNvPr id="20" name="">
             <a:extLst>
               <a:ext uri="{FF2B5EF4-FFF2-40B4-BE49-F238E27FC236}">
-                <ns2:creationId id="{2D237B43-F33C-4E9F-B27B-1704DCD4F836}"/>
+                <ns2:creationId id="{9F7E3E13-BCAE-4485-906D-B5734463CCC2}"/>
               </a:ext>
             </a:extLst>
           </p:cNvPr>
@@ -3193,7 +3264,7 @@
           <p:cNvPr id="21" name="">
             <a:extLst>
               <a:ext uri="{FF2B5EF4-FFF2-40B4-BE49-F238E27FC236}">
-                <ns2:creationId id="{3B1F32EC-14F5-40EB-975B-34331D343922}"/>
+                <ns2:creationId id="{FCE47844-70A1-499A-8A00-55FCD93A04E7}"/>
               </a:ext>
             </a:extLst>
           </p:cNvPr>
@@ -3225,7 +3296,7 @@
           <p:cNvPr id="22" name="">
             <a:extLst>
               <a:ext uri="{FF2B5EF4-FFF2-40B4-BE49-F238E27FC236}">
-                <ns2:creationId id="{32CC2A23-A4FA-4CC3-875A-7C5C427334D0}"/>
+                <ns2:creationId id="{AADE6EC3-4D23-49E3-B434-486FCF9A62A7}"/>
               </a:ext>
             </a:extLst>
           </p:cNvPr>
@@ -3286,7 +3357,7 @@
           <p:cNvPr id="23" name="">
             <a:extLst>
               <a:ext uri="{FF2B5EF4-FFF2-40B4-BE49-F238E27FC236}">
-                <ns2:creationId id="{2827C2DB-1E56-443B-81CF-D0BB53748D3C}"/>
+                <ns2:creationId id="{9472733C-EA24-4F03-9D46-1F08A0593C03}"/>
               </a:ext>
             </a:extLst>
           </p:cNvPr>
@@ -3347,7 +3418,7 @@
           <p:cNvPr id="24" name="">
             <a:extLst>
               <a:ext uri="{FF2B5EF4-FFF2-40B4-BE49-F238E27FC236}">
-                <ns2:creationId id="{60A6FFF9-9BF7-4F24-B610-62E334458950}"/>
+                <ns2:creationId id="{DD8F367A-F19F-4A84-BFA6-F46E39C6B028}"/>
               </a:ext>
             </a:extLst>
           </p:cNvPr>
@@ -3379,7 +3450,7 @@
           <p:cNvPr id="25" name="">
             <a:extLst>
               <a:ext uri="{FF2B5EF4-FFF2-40B4-BE49-F238E27FC236}">
-                <ns2:creationId id="{474A34D3-3710-4701-94C6-6B77A5EC3188}"/>
+                <ns2:creationId id="{51F8DF3F-B7B9-4CA0-A50C-AEFC2CD0316A}"/>
               </a:ext>
             </a:extLst>
           </p:cNvPr>
@@ -3440,7 +3511,7 @@
           <p:cNvPr id="26" name="">
             <a:extLst>
               <a:ext uri="{FF2B5EF4-FFF2-40B4-BE49-F238E27FC236}">
-                <ns2:creationId id="{6B1CE1EE-D00F-4D9C-9811-6D7AB9C8FD04}"/>
+                <ns2:creationId id="{E7BC5CCA-E8F6-4474-8E29-A1A803939053}"/>
               </a:ext>
             </a:extLst>
           </p:cNvPr>
@@ -3501,7 +3572,7 @@
           <p:cNvPr id="27" name="">
             <a:extLst>
               <a:ext uri="{FF2B5EF4-FFF2-40B4-BE49-F238E27FC236}">
-                <ns2:creationId id="{1485F143-3D31-47F3-B705-F997CDB755F8}"/>
+                <ns2:creationId id="{79E16D21-DFAE-402D-A27D-0DAF48BB16EB}"/>
               </a:ext>
             </a:extLst>
           </p:cNvPr>
@@ -3533,7 +3604,7 @@
           <p:cNvPr id="28" name="">
             <a:extLst>
               <a:ext uri="{FF2B5EF4-FFF2-40B4-BE49-F238E27FC236}">
-                <ns2:creationId id="{5A8E2D1E-BA99-4A29-884F-15C46896B145}"/>
+                <ns2:creationId id="{8619461E-64E2-49EA-8B5E-0F765AE519A6}"/>
               </a:ext>
             </a:extLst>
           </p:cNvPr>
@@ -3594,7 +3665,7 @@
           <p:cNvPr id="29" name="">
             <a:extLst>
               <a:ext uri="{FF2B5EF4-FFF2-40B4-BE49-F238E27FC236}">
-                <ns2:creationId id="{15CBEDBF-2149-46D1-8401-9AE255C519EE}"/>
+                <ns2:creationId id="{A83A1B89-08E4-40BA-A345-7B173DF7779E}"/>
               </a:ext>
             </a:extLst>
           </p:cNvPr>
@@ -3655,7 +3726,7 @@
           <p:cNvPr id="30" name="">
             <a:extLst>
               <a:ext uri="{FF2B5EF4-FFF2-40B4-BE49-F238E27FC236}">
-                <ns2:creationId id="{027C7102-81F9-4552-A3D2-570B8C78319A}"/>
+                <ns2:creationId id="{6377725F-433C-4EBC-9281-21C6F189553D}"/>
               </a:ext>
             </a:extLst>
           </p:cNvPr>
@@ -3716,7 +3787,7 @@
           <p:cNvPr id="31" name="">
             <a:extLst>
               <a:ext uri="{FF2B5EF4-FFF2-40B4-BE49-F238E27FC236}">
-                <ns2:creationId id="{95C46CEC-114F-4CC6-BA35-65A148DD0C96}"/>
+                <ns2:creationId id="{22550D8D-3A0A-442F-8384-C66CE11AC506}"/>
               </a:ext>
             </a:extLst>
           </p:cNvPr>
@@ -3777,7 +3848,7 @@
           <p:cNvPr id="32" name="">
             <a:extLst>
               <a:ext uri="{FF2B5EF4-FFF2-40B4-BE49-F238E27FC236}">
-                <ns2:creationId id="{E9429823-F465-4042-BF45-3101BAA75B4A}"/>
+                <ns2:creationId id="{70219343-7AC4-4A06-A39B-C5DDE1DB8D9A}"/>
               </a:ext>
             </a:extLst>
           </p:cNvPr>
@@ -3836,7 +3907,7 @@
     </p:spTree>
     <p:extLst>
       <p:ext uri="{BB962C8B-B14F-4D97-AF65-F5344CB8AC3E}">
-        <ns3:creationId val="364658770"/>
+        <ns3:creationId val="790714379"/>
       </p:ext>
     </p:extLst>
   </p:cSld>
@@ -3870,7 +3941,7 @@
           <p:cNvPr id="43" name="">
             <a:extLst>
               <a:ext uri="{FF2B5EF4-FFF2-40B4-BE49-F238E27FC236}">
-                <ns2:creationId id="{BBDE4012-1DD5-465A-934F-7D3AD1FB7269}"/>
+                <ns2:creationId id="{C82FAD84-6205-42EE-9AEC-0D2FEF3E5B9A}"/>
               </a:ext>
             </a:extLst>
           </p:cNvPr>
@@ -3931,7 +4002,7 @@
           <p:cNvPr id="2" name="">
             <a:extLst>
               <a:ext uri="{FF2B5EF4-FFF2-40B4-BE49-F238E27FC236}">
-                <ns2:creationId id="{3C1AC24C-A7CD-43D3-83D5-8C44BB55909C}"/>
+                <ns2:creationId id="{61B739BF-6BA6-4B62-8080-63B521F61998}"/>
               </a:ext>
             </a:extLst>
           </p:cNvPr>
@@ -3992,7 +4063,7 @@
           <p:cNvPr id="3" name="">
             <a:extLst>
               <a:ext uri="{FF2B5EF4-FFF2-40B4-BE49-F238E27FC236}">
-                <ns2:creationId id="{A19AF36A-F092-4EC4-9F96-CD382143A1E5}"/>
+                <ns2:creationId id="{18425FDB-143E-47E8-AA79-7F6A18FA1F27}"/>
               </a:ext>
             </a:extLst>
           </p:cNvPr>
@@ -4022,7 +4093,7 @@
           <p:cNvPr id="4" name="">
             <a:extLst>
               <a:ext uri="{FF2B5EF4-FFF2-40B4-BE49-F238E27FC236}">
-                <ns2:creationId id="{2F09FB89-9CD4-446A-8C00-6D9AB9B8CCBA}"/>
+                <ns2:creationId id="{52B3010D-C1B1-43EC-A0E8-278CD2E654FC}"/>
               </a:ext>
             </a:extLst>
           </p:cNvPr>
@@ -4057,7 +4128,7 @@
           <p:cNvPr id="5" name="">
             <a:extLst>
               <a:ext uri="{FF2B5EF4-FFF2-40B4-BE49-F238E27FC236}">
-                <ns2:creationId id="{65276EF1-BF61-42F1-8E81-8E53A6C2782F}"/>
+                <ns2:creationId id="{EF5C07DD-C51C-4B95-81AE-A80F5E93F933}"/>
               </a:ext>
             </a:extLst>
           </p:cNvPr>
@@ -4087,7 +4158,7 @@
           <p:cNvPr id="6" name="">
             <a:extLst>
               <a:ext uri="{FF2B5EF4-FFF2-40B4-BE49-F238E27FC236}">
-                <ns2:creationId id="{90819F1F-840A-46D9-A3B6-D1443CE99815}"/>
+                <ns2:creationId id="{12F627DE-4E5C-4523-AED2-3ACD23616AD3}"/>
               </a:ext>
             </a:extLst>
           </p:cNvPr>
@@ -4148,7 +4219,7 @@
           <p:cNvPr id="7" name="">
             <a:extLst>
               <a:ext uri="{FF2B5EF4-FFF2-40B4-BE49-F238E27FC236}">
-                <ns2:creationId id="{ADD3AA0F-3EAC-4EA3-BB24-75B812C33B72}"/>
+                <ns2:creationId id="{65BD8136-5A79-4556-A09E-756EC78B6CDC}"/>
               </a:ext>
             </a:extLst>
           </p:cNvPr>
@@ -4209,7 +4280,7 @@
           <p:cNvPr id="8" name="">
             <a:extLst>
               <a:ext uri="{FF2B5EF4-FFF2-40B4-BE49-F238E27FC236}">
-                <ns2:creationId id="{4370CC97-40BC-405C-B93F-7A81145452DF}"/>
+                <ns2:creationId id="{77EBA3B9-7526-4735-9FA1-75C93E0354D0}"/>
               </a:ext>
             </a:extLst>
           </p:cNvPr>
@@ -4270,7 +4341,7 @@
           <p:cNvPr id="9" name="">
             <a:extLst>
               <a:ext uri="{FF2B5EF4-FFF2-40B4-BE49-F238E27FC236}">
-                <ns2:creationId id="{E20CD406-DC9F-4739-8FFD-BCD4200F91B2}"/>
+                <ns2:creationId id="{A2416BC3-B188-4E5F-9347-8BEC28DFA251}"/>
               </a:ext>
             </a:extLst>
           </p:cNvPr>
@@ -4305,7 +4376,7 @@
           <p:cNvPr id="10" name="">
             <a:extLst>
               <a:ext uri="{FF2B5EF4-FFF2-40B4-BE49-F238E27FC236}">
-                <ns2:creationId id="{84A9B7AE-5013-413A-B6A1-FD45E0FD1706}"/>
+                <ns2:creationId id="{437D06CA-3DC5-4F14-A94F-85644CE8E246}"/>
               </a:ext>
             </a:extLst>
           </p:cNvPr>
@@ -4335,7 +4406,7 @@
           <p:cNvPr id="11" name="">
             <a:extLst>
               <a:ext uri="{FF2B5EF4-FFF2-40B4-BE49-F238E27FC236}">
-                <ns2:creationId id="{ACA069D0-066F-446A-800B-7A7F0CB50385}"/>
+                <ns2:creationId id="{446AEEEA-8661-4A24-8BBE-B4D8B58C1997}"/>
               </a:ext>
             </a:extLst>
           </p:cNvPr>
@@ -4396,7 +4467,7 @@
           <p:cNvPr id="12" name="">
             <a:extLst>
               <a:ext uri="{FF2B5EF4-FFF2-40B4-BE49-F238E27FC236}">
-                <ns2:creationId id="{7E8EE78C-14CB-4291-9377-CDDD67768F9E}"/>
+                <ns2:creationId id="{BDF56792-029A-405D-97F9-54DF3456DAEB}"/>
               </a:ext>
             </a:extLst>
           </p:cNvPr>
@@ -4457,7 +4528,7 @@
           <p:cNvPr id="13" name="">
             <a:extLst>
               <a:ext uri="{FF2B5EF4-FFF2-40B4-BE49-F238E27FC236}">
-                <ns2:creationId id="{080020EF-FC17-40A8-AFA5-85E28493A6A1}"/>
+                <ns2:creationId id="{DAA8E86C-B882-4D2D-A0F2-D4215C29AA62}"/>
               </a:ext>
             </a:extLst>
           </p:cNvPr>
@@ -4518,7 +4589,7 @@
           <p:cNvPr id="14" name="">
             <a:extLst>
               <a:ext uri="{FF2B5EF4-FFF2-40B4-BE49-F238E27FC236}">
-                <ns2:creationId id="{AE3040A6-7536-4D23-BF30-DD5390DDAF04}"/>
+                <ns2:creationId id="{15E0D422-439C-410A-A20C-9587A53813CC}"/>
               </a:ext>
             </a:extLst>
           </p:cNvPr>
@@ -4553,7 +4624,7 @@
           <p:cNvPr id="15" name="">
             <a:extLst>
               <a:ext uri="{FF2B5EF4-FFF2-40B4-BE49-F238E27FC236}">
-                <ns2:creationId id="{7A4D6A49-16CD-424E-BA70-03B00B9AF790}"/>
+                <ns2:creationId id="{1191A9C2-6DAC-477B-A510-666B47CF00BE}"/>
               </a:ext>
             </a:extLst>
           </p:cNvPr>
@@ -4583,7 +4654,7 @@
           <p:cNvPr id="16" name="">
             <a:extLst>
               <a:ext uri="{FF2B5EF4-FFF2-40B4-BE49-F238E27FC236}">
-                <ns2:creationId id="{71975686-2628-4652-B760-7EA27E043E33}"/>
+                <ns2:creationId id="{4DBFEDAF-1C81-4BBD-B102-FA9FBB8FF62B}"/>
               </a:ext>
             </a:extLst>
           </p:cNvPr>
@@ -4644,7 +4715,7 @@
           <p:cNvPr id="17" name="">
             <a:extLst>
               <a:ext uri="{FF2B5EF4-FFF2-40B4-BE49-F238E27FC236}">
-                <ns2:creationId id="{9FD05449-3AE2-42F3-A09C-7F5167DF7043}"/>
+                <ns2:creationId id="{FDCFED7F-432C-4CD1-B205-652E10F37106}"/>
               </a:ext>
             </a:extLst>
           </p:cNvPr>
@@ -4705,7 +4776,7 @@
           <p:cNvPr id="18" name="">
             <a:extLst>
               <a:ext uri="{FF2B5EF4-FFF2-40B4-BE49-F238E27FC236}">
-                <ns2:creationId id="{F4429DE1-A453-4056-B0BA-5E5855E3B906}"/>
+                <ns2:creationId id="{A4037BF1-7BE3-4B9C-BD2F-FBE8C971C547}"/>
               </a:ext>
             </a:extLst>
           </p:cNvPr>
@@ -4766,7 +4837,7 @@
           <p:cNvPr id="19" name="">
             <a:extLst>
               <a:ext uri="{FF2B5EF4-FFF2-40B4-BE49-F238E27FC236}">
-                <ns2:creationId id="{2B7350AD-B8C2-4B8C-A1A8-036075310C8D}"/>
+                <ns2:creationId id="{E37EB0B2-677D-4DF6-8B8E-2F6B6FFF3601}"/>
               </a:ext>
             </a:extLst>
           </p:cNvPr>
@@ -4801,7 +4872,7 @@
           <p:cNvPr id="20" name="">
             <a:extLst>
               <a:ext uri="{FF2B5EF4-FFF2-40B4-BE49-F238E27FC236}">
-                <ns2:creationId id="{A127EF18-89AF-4982-8EE2-F3EDD7112022}"/>
+                <ns2:creationId id="{2F08339C-B7D3-4D74-9E61-B5FFF9AE2D65}"/>
               </a:ext>
             </a:extLst>
           </p:cNvPr>
@@ -4831,7 +4902,7 @@
           <p:cNvPr id="21" name="">
             <a:extLst>
               <a:ext uri="{FF2B5EF4-FFF2-40B4-BE49-F238E27FC236}">
-                <ns2:creationId id="{2E8CC914-8F44-4C6C-ACCB-507F25A7D86E}"/>
+                <ns2:creationId id="{5AD4B58F-C306-4911-9FC4-9A5629EAA9F7}"/>
               </a:ext>
             </a:extLst>
           </p:cNvPr>
@@ -4892,7 +4963,7 @@
           <p:cNvPr id="22" name="">
             <a:extLst>
               <a:ext uri="{FF2B5EF4-FFF2-40B4-BE49-F238E27FC236}">
-                <ns2:creationId id="{D7D4F82B-59C4-4F9F-B6D6-0AD846D20A0B}"/>
+                <ns2:creationId id="{BA85FBB9-DF86-4167-BB84-D2EF2292495B}"/>
               </a:ext>
             </a:extLst>
           </p:cNvPr>
@@ -4953,7 +5024,7 @@
           <p:cNvPr id="23" name="">
             <a:extLst>
               <a:ext uri="{FF2B5EF4-FFF2-40B4-BE49-F238E27FC236}">
-                <ns2:creationId id="{FF383B18-84A5-4B92-B7F9-E9A12649103F}"/>
+                <ns2:creationId id="{CF33F010-AF27-45B9-B50D-E7D056A23288}"/>
               </a:ext>
             </a:extLst>
           </p:cNvPr>
@@ -5014,7 +5085,7 @@
           <p:cNvPr id="24" name="">
             <a:extLst>
               <a:ext uri="{FF2B5EF4-FFF2-40B4-BE49-F238E27FC236}">
-                <ns2:creationId id="{25E7378C-C867-4F75-AC64-63E3CBF8E250}"/>
+                <ns2:creationId id="{B8CC6B02-98C1-4C81-865C-BE752FD3A4F7}"/>
               </a:ext>
             </a:extLst>
           </p:cNvPr>
@@ -5049,7 +5120,7 @@
           <p:cNvPr id="25" name="">
             <a:extLst>
               <a:ext uri="{FF2B5EF4-FFF2-40B4-BE49-F238E27FC236}">
-                <ns2:creationId id="{6E43EB6E-8127-4C7D-8BBC-C8EA5B752D37}"/>
+                <ns2:creationId id="{833A36E8-C839-4975-B608-0EF838F986A1}"/>
               </a:ext>
             </a:extLst>
           </p:cNvPr>
@@ -5079,7 +5150,7 @@
           <p:cNvPr id="26" name="">
             <a:extLst>
               <a:ext uri="{FF2B5EF4-FFF2-40B4-BE49-F238E27FC236}">
-                <ns2:creationId id="{CFC6493F-AC5C-4E28-9644-5A89D1974F99}"/>
+                <ns2:creationId id="{934EC664-C017-4BBE-9D07-FD360C1FD8C6}"/>
               </a:ext>
             </a:extLst>
           </p:cNvPr>
@@ -5140,7 +5211,7 @@
           <p:cNvPr id="27" name="">
             <a:extLst>
               <a:ext uri="{FF2B5EF4-FFF2-40B4-BE49-F238E27FC236}">
-                <ns2:creationId id="{1475C2E3-B802-4D4F-83D2-E3086F321EC4}"/>
+                <ns2:creationId id="{17C1F0D3-E90C-49AE-81BB-0646E178CCB7}"/>
               </a:ext>
             </a:extLst>
           </p:cNvPr>
@@ -5201,7 +5272,7 @@
           <p:cNvPr id="28" name="">
             <a:extLst>
               <a:ext uri="{FF2B5EF4-FFF2-40B4-BE49-F238E27FC236}">
-                <ns2:creationId id="{791E436A-4532-4C44-8BCE-D7288CE5D412}"/>
+                <ns2:creationId id="{36D422CA-7DBF-4459-9B34-E802B0E9B349}"/>
               </a:ext>
             </a:extLst>
           </p:cNvPr>
@@ -5262,7 +5333,7 @@
           <p:cNvPr id="29" name="">
             <a:extLst>
               <a:ext uri="{FF2B5EF4-FFF2-40B4-BE49-F238E27FC236}">
-                <ns2:creationId id="{7CB18981-931F-4CAC-A4A2-245B1B76D777}"/>
+                <ns2:creationId id="{9CFC54E3-D746-4556-ABF1-C535E2D45EB0}"/>
               </a:ext>
             </a:extLst>
           </p:cNvPr>
@@ -5297,7 +5368,7 @@
           <p:cNvPr id="30" name="">
             <a:extLst>
               <a:ext uri="{FF2B5EF4-FFF2-40B4-BE49-F238E27FC236}">
-                <ns2:creationId id="{1CEC8A94-68B2-4609-87AD-DBDB01350460}"/>
+                <ns2:creationId id="{E47DECFA-D5E4-4719-AF1A-B00683B49EDD}"/>
               </a:ext>
             </a:extLst>
           </p:cNvPr>
@@ -5327,7 +5398,7 @@
           <p:cNvPr id="31" name="">
             <a:extLst>
               <a:ext uri="{FF2B5EF4-FFF2-40B4-BE49-F238E27FC236}">
-                <ns2:creationId id="{DC758C5C-924C-4A08-9D78-758898B0D612}"/>
+                <ns2:creationId id="{F6DF9CB7-2748-4302-866C-5190D598E0F7}"/>
               </a:ext>
             </a:extLst>
           </p:cNvPr>
@@ -5388,7 +5459,7 @@
           <p:cNvPr id="32" name="">
             <a:extLst>
               <a:ext uri="{FF2B5EF4-FFF2-40B4-BE49-F238E27FC236}">
-                <ns2:creationId id="{AC4D1F4D-7D8D-41EA-A3BC-CB83ADB4A71B}"/>
+                <ns2:creationId id="{77B50AF4-62E4-4691-8A24-7FC4E624D862}"/>
               </a:ext>
             </a:extLst>
           </p:cNvPr>
@@ -5449,7 +5520,7 @@
           <p:cNvPr id="33" name="">
             <a:extLst>
               <a:ext uri="{FF2B5EF4-FFF2-40B4-BE49-F238E27FC236}">
-                <ns2:creationId id="{10C8EF6B-DB2F-4516-9391-90A9A0CE7B99}"/>
+                <ns2:creationId id="{4A891E1E-4114-4522-8323-EE841DE0D52C}"/>
               </a:ext>
             </a:extLst>
           </p:cNvPr>
@@ -5510,7 +5581,7 @@
           <p:cNvPr id="34" name="">
             <a:extLst>
               <a:ext uri="{FF2B5EF4-FFF2-40B4-BE49-F238E27FC236}">
-                <ns2:creationId id="{5B23C8ED-6889-4870-9499-89F4D7B2F6DD}"/>
+                <ns2:creationId id="{71AC7BBB-8247-45F3-8EFD-2D7322CDD904}"/>
               </a:ext>
             </a:extLst>
           </p:cNvPr>
@@ -5571,7 +5642,7 @@
           <p:cNvPr id="35" name="">
             <a:extLst>
               <a:ext uri="{FF2B5EF4-FFF2-40B4-BE49-F238E27FC236}">
-                <ns2:creationId id="{84A7A326-6E78-4464-AAB6-CF85428DB9F6}"/>
+                <ns2:creationId id="{2D6A0C3F-5E10-4BBF-8FCB-43C27225F4BC}"/>
               </a:ext>
             </a:extLst>
           </p:cNvPr>
@@ -5632,7 +5703,7 @@
           <p:cNvPr id="36" name="">
             <a:extLst>
               <a:ext uri="{FF2B5EF4-FFF2-40B4-BE49-F238E27FC236}">
-                <ns2:creationId id="{B3AED400-53EC-4F16-AEFE-E36AF5CEBE22}"/>
+                <ns2:creationId id="{0769DA82-16F0-4253-A45C-B2F1857C724E}"/>
               </a:ext>
             </a:extLst>
           </p:cNvPr>
@@ -5693,7 +5764,7 @@
           <p:cNvPr id="37" name="">
             <a:extLst>
               <a:ext uri="{FF2B5EF4-FFF2-40B4-BE49-F238E27FC236}">
-                <ns2:creationId id="{305A5C05-A2F7-45E3-BF07-56806425BE07}"/>
+                <ns2:creationId id="{FF07C2D4-46B1-4694-994C-9A56247DF9EE}"/>
               </a:ext>
             </a:extLst>
           </p:cNvPr>
@@ -5754,7 +5825,7 @@
           <p:cNvPr id="38" name="">
             <a:extLst>
               <a:ext uri="{FF2B5EF4-FFF2-40B4-BE49-F238E27FC236}">
-                <ns2:creationId id="{2D5395E5-5003-4D09-A289-63CD97F30E5A}"/>
+                <ns2:creationId id="{900787C8-1437-4060-90E4-DC38AF00F796}"/>
               </a:ext>
             </a:extLst>
           </p:cNvPr>
@@ -5815,7 +5886,7 @@
           <p:cNvPr id="39" name="">
             <a:extLst>
               <a:ext uri="{FF2B5EF4-FFF2-40B4-BE49-F238E27FC236}">
-                <ns2:creationId id="{0FA8CD88-6EA6-4C4B-8F79-C0FDA513C479}"/>
+                <ns2:creationId id="{15B71851-18BA-4CB8-94CE-83A67ACBE422}"/>
               </a:ext>
             </a:extLst>
           </p:cNvPr>
@@ -5876,7 +5947,7 @@
           <p:cNvPr id="40" name="">
             <a:extLst>
               <a:ext uri="{FF2B5EF4-FFF2-40B4-BE49-F238E27FC236}">
-                <ns2:creationId id="{63C28DD2-C5C8-4664-809D-3CA591951D5D}"/>
+                <ns2:creationId id="{F7FB6201-8D82-4E0A-962B-482A002A3C7E}"/>
               </a:ext>
             </a:extLst>
           </p:cNvPr>
@@ -5937,7 +6008,7 @@
           <p:cNvPr id="41" name="">
             <a:extLst>
               <a:ext uri="{FF2B5EF4-FFF2-40B4-BE49-F238E27FC236}">
-                <ns2:creationId id="{78B74AA7-C72A-45D1-85D5-57911A640B42}"/>
+                <ns2:creationId id="{1DDD0454-9AC1-4EDF-868F-492D2161E460}"/>
               </a:ext>
             </a:extLst>
           </p:cNvPr>
@@ -5998,7 +6069,7 @@
           <p:cNvPr id="42" name="">
             <a:extLst>
               <a:ext uri="{FF2B5EF4-FFF2-40B4-BE49-F238E27FC236}">
-                <ns2:creationId id="{1AC21064-E85E-4957-8661-C42BB9D01B47}"/>
+                <ns2:creationId id="{620AB405-F4A4-40F0-9B52-37E6D7D12D91}"/>
               </a:ext>
             </a:extLst>
           </p:cNvPr>
@@ -6057,7 +6128,7 @@
     </p:spTree>
     <p:extLst>
       <p:ext uri="{BB962C8B-B14F-4D97-AF65-F5344CB8AC3E}">
-        <ns3:creationId val="342720980"/>
+        <ns3:creationId val="1732686409"/>
       </p:ext>
     </p:extLst>
   </p:cSld>
@@ -6091,7 +6162,7 @@
           <p:cNvPr id="41" name="">
             <a:extLst>
               <a:ext uri="{FF2B5EF4-FFF2-40B4-BE49-F238E27FC236}">
-                <ns2:creationId id="{237F5122-8E3A-4A5B-99AD-118E77D4F442}"/>
+                <ns2:creationId id="{A901EFCB-D495-47E6-9F86-A3FAD94D428D}"/>
               </a:ext>
             </a:extLst>
           </p:cNvPr>
@@ -6152,7 +6223,7 @@
           <p:cNvPr id="2" name="">
             <a:extLst>
               <a:ext uri="{FF2B5EF4-FFF2-40B4-BE49-F238E27FC236}">
-                <ns2:creationId id="{AA333C25-0F72-455F-B02E-234B32E9F6A3}"/>
+                <ns2:creationId id="{A4A38449-5C78-4D31-ADE9-D5012B025701}"/>
               </a:ext>
             </a:extLst>
           </p:cNvPr>
@@ -6213,7 +6284,7 @@
           <p:cNvPr id="3" name="">
             <a:extLst>
               <a:ext uri="{FF2B5EF4-FFF2-40B4-BE49-F238E27FC236}">
-                <ns2:creationId id="{2C88ED11-2AF4-41A3-BD07-D11D785BBD40}"/>
+                <ns2:creationId id="{B2D19CBF-8510-4E0D-9193-B09243614731}"/>
               </a:ext>
             </a:extLst>
           </p:cNvPr>
@@ -6243,7 +6314,7 @@
           <p:cNvPr id="4" name="">
             <a:extLst>
               <a:ext uri="{FF2B5EF4-FFF2-40B4-BE49-F238E27FC236}">
-                <ns2:creationId id="{6E8597A3-A257-4E42-9522-8B3A1D09C8FF}"/>
+                <ns2:creationId id="{8B9A45E4-A7F4-4499-989A-7A17A960E9D4}"/>
               </a:ext>
             </a:extLst>
           </p:cNvPr>
@@ -6276,7 +6347,7 @@
           <p:cNvPr id="5" name="">
             <a:extLst>
               <a:ext uri="{FF2B5EF4-FFF2-40B4-BE49-F238E27FC236}">
-                <ns2:creationId id="{164D841B-C9CC-4C44-99DC-A679EBACE382}"/>
+                <ns2:creationId id="{ACD15CAD-99E8-483A-A603-6D77F0ECD2AF}"/>
               </a:ext>
             </a:extLst>
           </p:cNvPr>
@@ -6309,7 +6380,7 @@
           <p:cNvPr id="6" name="">
             <a:extLst>
               <a:ext uri="{FF2B5EF4-FFF2-40B4-BE49-F238E27FC236}">
-                <ns2:creationId id="{B95AF570-C9DF-4BF3-A45B-A02E9B9EF86A}"/>
+                <ns2:creationId id="{473630BD-15D8-4AB1-AC4B-5E4125FF3550}"/>
               </a:ext>
             </a:extLst>
           </p:cNvPr>
@@ -6342,7 +6413,7 @@
           <p:cNvPr id="7" name="">
             <a:extLst>
               <a:ext uri="{FF2B5EF4-FFF2-40B4-BE49-F238E27FC236}">
-                <ns2:creationId id="{41F0DE16-9F50-442C-86DD-24C4E6F9A0D2}"/>
+                <ns2:creationId id="{7FC7264D-5CD6-4F83-8734-E2A0084B164A}"/>
               </a:ext>
             </a:extLst>
           </p:cNvPr>
@@ -6403,7 +6474,7 @@
           <p:cNvPr id="8" name="">
             <a:extLst>
               <a:ext uri="{FF2B5EF4-FFF2-40B4-BE49-F238E27FC236}">
-                <ns2:creationId id="{CE11665E-5F1F-46F3-942D-FDE153EDCDAE}"/>
+                <ns2:creationId id="{1B20D314-E90F-47DA-B5BA-6A0BC99FF9D0}"/>
               </a:ext>
             </a:extLst>
           </p:cNvPr>
@@ -6491,7 +6562,7 @@
           <p:cNvPr id="9" name="">
             <a:extLst>
               <a:ext uri="{FF2B5EF4-FFF2-40B4-BE49-F238E27FC236}">
-                <ns2:creationId id="{08A0FE59-0F4F-46CE-9BE0-D884B82AC125}"/>
+                <ns2:creationId id="{9070C5BF-1147-4CD1-8C92-F6DC641E0F30}"/>
               </a:ext>
             </a:extLst>
           </p:cNvPr>
@@ -6552,7 +6623,7 @@
           <p:cNvPr id="10" name="">
             <a:extLst>
               <a:ext uri="{FF2B5EF4-FFF2-40B4-BE49-F238E27FC236}">
-                <ns2:creationId id="{82E52D5B-023A-4344-B763-F50B76F2DB80}"/>
+                <ns2:creationId id="{E3C86D38-1ADC-4668-B714-C59D8C386170}"/>
               </a:ext>
             </a:extLst>
           </p:cNvPr>
@@ -6640,7 +6711,7 @@
           <p:cNvPr id="11" name="">
             <a:extLst>
               <a:ext uri="{FF2B5EF4-FFF2-40B4-BE49-F238E27FC236}">
-                <ns2:creationId id="{CF38F41F-C812-4BE6-B972-33218911B725}"/>
+                <ns2:creationId id="{30F342C5-36C4-4D06-9EE5-5D426E19BEB5}"/>
               </a:ext>
             </a:extLst>
           </p:cNvPr>
@@ -6701,7 +6772,7 @@
           <p:cNvPr id="12" name="">
             <a:extLst>
               <a:ext uri="{FF2B5EF4-FFF2-40B4-BE49-F238E27FC236}">
-                <ns2:creationId id="{C18DBA31-72DB-4EA3-898F-BE1337B1B56C}"/>
+                <ns2:creationId id="{4BC918F8-B706-45D3-A3E9-0D8E61742490}"/>
               </a:ext>
             </a:extLst>
           </p:cNvPr>
@@ -6789,7 +6860,7 @@
           <p:cNvPr id="13" name="">
             <a:extLst>
               <a:ext uri="{FF2B5EF4-FFF2-40B4-BE49-F238E27FC236}">
-                <ns2:creationId id="{60207DFC-745A-4B32-88C6-C8A7E1A23BB8}"/>
+                <ns2:creationId id="{CF6A05A2-1EE3-4C29-BA7C-042E3A8DFC5E}"/>
               </a:ext>
             </a:extLst>
           </p:cNvPr>
@@ -6850,7 +6921,7 @@
           <p:cNvPr id="14" name="">
             <a:extLst>
               <a:ext uri="{FF2B5EF4-FFF2-40B4-BE49-F238E27FC236}">
-                <ns2:creationId id="{474E2333-963B-4A27-BD92-F9784E1C011C}"/>
+                <ns2:creationId id="{7699C54D-0048-4805-913B-B778E87557DE}"/>
               </a:ext>
             </a:extLst>
           </p:cNvPr>
@@ -6911,7 +6982,7 @@
           <p:cNvPr id="15" name="">
             <a:extLst>
               <a:ext uri="{FF2B5EF4-FFF2-40B4-BE49-F238E27FC236}">
-                <ns2:creationId id="{057E17DF-1378-4359-90B5-4557F2EF3D59}"/>
+                <ns2:creationId id="{99A5F5A6-D09A-4382-8A8E-EC69953BFD76}"/>
               </a:ext>
             </a:extLst>
           </p:cNvPr>
@@ -6943,7 +7014,7 @@
           <p:cNvPr id="16" name="">
             <a:extLst>
               <a:ext uri="{FF2B5EF4-FFF2-40B4-BE49-F238E27FC236}">
-                <ns2:creationId id="{C458819F-7E16-4403-A173-392CDB14087E}"/>
+                <ns2:creationId id="{8BB74796-BA89-466F-BD2E-DB88F6D981BB}"/>
               </a:ext>
             </a:extLst>
           </p:cNvPr>
@@ -7004,7 +7075,7 @@
           <p:cNvPr id="17" name="">
             <a:extLst>
               <a:ext uri="{FF2B5EF4-FFF2-40B4-BE49-F238E27FC236}">
-                <ns2:creationId id="{B5A9E17F-89FA-482F-A754-7A5D4DB00F65}"/>
+                <ns2:creationId id="{5DDBBC7C-141D-4161-B903-820ED0E1189D}"/>
               </a:ext>
             </a:extLst>
           </p:cNvPr>
@@ -7034,7 +7105,7 @@
           <p:cNvPr id="18" name="">
             <a:extLst>
               <a:ext uri="{FF2B5EF4-FFF2-40B4-BE49-F238E27FC236}">
-                <ns2:creationId id="{1EF9263E-1A01-4A11-8587-7E5ECAC6F107}"/>
+                <ns2:creationId id="{DF9E9DE8-AFE2-455C-A4D9-B4F023C21034}"/>
               </a:ext>
             </a:extLst>
           </p:cNvPr>
@@ -7095,7 +7166,7 @@
           <p:cNvPr id="19" name="">
             <a:extLst>
               <a:ext uri="{FF2B5EF4-FFF2-40B4-BE49-F238E27FC236}">
-                <ns2:creationId id="{D81948D8-30B0-4117-B56B-6948C3415E9C}"/>
+                <ns2:creationId id="{94F128AD-6F13-44D8-9911-A00940ECA116}"/>
               </a:ext>
             </a:extLst>
           </p:cNvPr>
@@ -7156,7 +7227,7 @@
           <p:cNvPr id="20" name="">
             <a:extLst>
               <a:ext uri="{FF2B5EF4-FFF2-40B4-BE49-F238E27FC236}">
-                <ns2:creationId id="{598A1D03-20F6-46EF-A34E-7FDD5EA8EAC1}"/>
+                <ns2:creationId id="{EE94708A-64A4-4EC8-B817-E57AF1F3611B}"/>
               </a:ext>
             </a:extLst>
           </p:cNvPr>
@@ -7217,7 +7288,7 @@
           <p:cNvPr id="21" name="">
             <a:extLst>
               <a:ext uri="{FF2B5EF4-FFF2-40B4-BE49-F238E27FC236}">
-                <ns2:creationId id="{BF3247A6-B222-4822-B081-6FAE4B2D0E4B}"/>
+                <ns2:creationId id="{00DFC105-4954-49B4-BA68-5D2A16326CA9}"/>
               </a:ext>
             </a:extLst>
           </p:cNvPr>
@@ -7247,7 +7318,7 @@
           <p:cNvPr id="22" name="">
             <a:extLst>
               <a:ext uri="{FF2B5EF4-FFF2-40B4-BE49-F238E27FC236}">
-                <ns2:creationId id="{550E1C67-E392-43CF-8349-FACD78C3325F}"/>
+                <ns2:creationId id="{4092CC0C-36C9-4E5F-9EB7-08A18BE4842B}"/>
               </a:ext>
             </a:extLst>
           </p:cNvPr>
@@ -7308,7 +7379,7 @@
           <p:cNvPr id="23" name="">
             <a:extLst>
               <a:ext uri="{FF2B5EF4-FFF2-40B4-BE49-F238E27FC236}">
-                <ns2:creationId id="{CEC181BF-D010-43BA-A845-5466524FFDAF}"/>
+                <ns2:creationId id="{F87EECAD-F11C-4DC2-8A2B-73754A9E7423}"/>
               </a:ext>
             </a:extLst>
           </p:cNvPr>
@@ -7369,7 +7440,7 @@
           <p:cNvPr id="24" name="">
             <a:extLst>
               <a:ext uri="{FF2B5EF4-FFF2-40B4-BE49-F238E27FC236}">
-                <ns2:creationId id="{18E956D0-940C-488D-974B-88E8BB21BCF8}"/>
+                <ns2:creationId id="{70A0F160-0301-43DE-86E4-E33903769168}"/>
               </a:ext>
             </a:extLst>
           </p:cNvPr>
@@ -7430,7 +7501,7 @@
           <p:cNvPr id="25" name="">
             <a:extLst>
               <a:ext uri="{FF2B5EF4-FFF2-40B4-BE49-F238E27FC236}">
-                <ns2:creationId id="{2F621C16-40D8-495F-9BE2-9B834DBCC268}"/>
+                <ns2:creationId id="{FEE87F3C-EE92-4AA0-9435-1C23271EE81B}"/>
               </a:ext>
             </a:extLst>
           </p:cNvPr>
@@ -7460,7 +7531,7 @@
           <p:cNvPr id="26" name="">
             <a:extLst>
               <a:ext uri="{FF2B5EF4-FFF2-40B4-BE49-F238E27FC236}">
-                <ns2:creationId id="{A1196063-E0A2-4011-B3A3-607F095636BD}"/>
+                <ns2:creationId id="{9D98404B-3969-4A66-A0D5-17E540CEFA56}"/>
               </a:ext>
             </a:extLst>
           </p:cNvPr>
@@ -7521,7 +7592,7 @@
           <p:cNvPr id="27" name="">
             <a:extLst>
               <a:ext uri="{FF2B5EF4-FFF2-40B4-BE49-F238E27FC236}">
-                <ns2:creationId id="{38B47B2E-2611-430C-A772-987825D6FA7C}"/>
+                <ns2:creationId id="{55D0E3F6-E4C7-48CE-9F08-C13E6F39A686}"/>
               </a:ext>
             </a:extLst>
           </p:cNvPr>
@@ -7582,7 +7653,7 @@
           <p:cNvPr id="28" name="">
             <a:extLst>
               <a:ext uri="{FF2B5EF4-FFF2-40B4-BE49-F238E27FC236}">
-                <ns2:creationId id="{0317A232-EC57-419C-B136-C72D4F7C78C0}"/>
+                <ns2:creationId id="{AB207941-4E2D-456F-B64B-DA84923AEA3E}"/>
               </a:ext>
             </a:extLst>
           </p:cNvPr>
@@ -7643,7 +7714,7 @@
           <p:cNvPr id="29" name="">
             <a:extLst>
               <a:ext uri="{FF2B5EF4-FFF2-40B4-BE49-F238E27FC236}">
-                <ns2:creationId id="{75062561-7C90-41A1-A08A-B27C4065DA8B}"/>
+                <ns2:creationId id="{F5641A47-7FAB-42B4-AB24-3A06E0DAE273}"/>
               </a:ext>
             </a:extLst>
           </p:cNvPr>
@@ -7673,7 +7744,7 @@
           <p:cNvPr id="30" name="">
             <a:extLst>
               <a:ext uri="{FF2B5EF4-FFF2-40B4-BE49-F238E27FC236}">
-                <ns2:creationId id="{1AD4268A-F009-4031-9B8F-D46952516A31}"/>
+                <ns2:creationId id="{7BD42DDE-7770-4FCF-B6DB-BEE4C0F483BE}"/>
               </a:ext>
             </a:extLst>
           </p:cNvPr>
@@ -7734,7 +7805,7 @@
           <p:cNvPr id="31" name="">
             <a:extLst>
               <a:ext uri="{FF2B5EF4-FFF2-40B4-BE49-F238E27FC236}">
-                <ns2:creationId id="{66B067D0-AB76-4536-9D23-4877DFAC2860}"/>
+                <ns2:creationId id="{2C32C8AB-4A33-4934-87C9-7EB82E702391}"/>
               </a:ext>
             </a:extLst>
           </p:cNvPr>
@@ -7795,7 +7866,7 @@
           <p:cNvPr id="32" name="">
             <a:extLst>
               <a:ext uri="{FF2B5EF4-FFF2-40B4-BE49-F238E27FC236}">
-                <ns2:creationId id="{E0AB87D7-08D6-447D-94D6-8ACD99AC88C8}"/>
+                <ns2:creationId id="{445BC491-0D7E-46C4-9AD3-C64CA5D455C0}"/>
               </a:ext>
             </a:extLst>
           </p:cNvPr>
@@ -7856,7 +7927,7 @@
           <p:cNvPr id="33" name="">
             <a:extLst>
               <a:ext uri="{FF2B5EF4-FFF2-40B4-BE49-F238E27FC236}">
-                <ns2:creationId id="{E3D8A55B-9A06-4D49-9B5F-4328006A14DD}"/>
+                <ns2:creationId id="{9C5F3E9B-EB0E-4619-A1EE-0D1EC1C94C06}"/>
               </a:ext>
             </a:extLst>
           </p:cNvPr>
@@ -7886,7 +7957,7 @@
           <p:cNvPr id="34" name="">
             <a:extLst>
               <a:ext uri="{FF2B5EF4-FFF2-40B4-BE49-F238E27FC236}">
-                <ns2:creationId id="{9D2C3325-73C4-4CDE-8FD8-EBB0EB79F61B}"/>
+                <ns2:creationId id="{88C052E6-17FE-4EE6-8CD6-BD010F6FB935}"/>
               </a:ext>
             </a:extLst>
           </p:cNvPr>
@@ -7947,7 +8018,7 @@
           <p:cNvPr id="35" name="">
             <a:extLst>
               <a:ext uri="{FF2B5EF4-FFF2-40B4-BE49-F238E27FC236}">
-                <ns2:creationId id="{744F3F05-12C3-4AC1-9F3B-95DE721AA164}"/>
+                <ns2:creationId id="{BAC8B277-FC94-469D-BC86-C6B29933B660}"/>
               </a:ext>
             </a:extLst>
           </p:cNvPr>
@@ -8008,7 +8079,7 @@
           <p:cNvPr id="36" name="">
             <a:extLst>
               <a:ext uri="{FF2B5EF4-FFF2-40B4-BE49-F238E27FC236}">
-                <ns2:creationId id="{2BAF38AB-6880-4C46-A838-6CAE96A88D07}"/>
+                <ns2:creationId id="{04DFB2D0-959B-400E-9F7A-532214E0DE7C}"/>
               </a:ext>
             </a:extLst>
           </p:cNvPr>
@@ -8069,7 +8140,7 @@
           <p:cNvPr id="37" name="">
             <a:extLst>
               <a:ext uri="{FF2B5EF4-FFF2-40B4-BE49-F238E27FC236}">
-                <ns2:creationId id="{CCF90267-AB94-4696-8689-9876B8147F3C}"/>
+                <ns2:creationId id="{CB422BAB-CAF0-4D89-AC67-92E7B2C1B7BF}"/>
               </a:ext>
             </a:extLst>
           </p:cNvPr>
@@ -8130,7 +8201,7 @@
           <p:cNvPr id="38" name="">
             <a:extLst>
               <a:ext uri="{FF2B5EF4-FFF2-40B4-BE49-F238E27FC236}">
-                <ns2:creationId id="{BFA44291-4E79-4A2A-8609-EB610064A0F2}"/>
+                <ns2:creationId id="{74AB348E-1DC8-465A-8C66-0C03EF26305F}"/>
               </a:ext>
             </a:extLst>
           </p:cNvPr>
@@ -8191,7 +8262,7 @@
           <p:cNvPr id="39" name="">
             <a:extLst>
               <a:ext uri="{FF2B5EF4-FFF2-40B4-BE49-F238E27FC236}">
-                <ns2:creationId id="{59BACAFA-B14D-4286-847F-27D18B1E4D5E}"/>
+                <ns2:creationId id="{B6CEF611-7711-41DE-85DA-952B860316C8}"/>
               </a:ext>
             </a:extLst>
           </p:cNvPr>
@@ -8252,7 +8323,7 @@
           <p:cNvPr id="40" name="">
             <a:extLst>
               <a:ext uri="{FF2B5EF4-FFF2-40B4-BE49-F238E27FC236}">
-                <ns2:creationId id="{305C2320-15AE-493C-BFE2-EC91E920AD34}"/>
+                <ns2:creationId id="{B8109DAB-D607-4FBE-8AF2-5FED4DD30626}"/>
               </a:ext>
             </a:extLst>
           </p:cNvPr>
@@ -8311,7 +8382,7 @@
     </p:spTree>
     <p:extLst>
       <p:ext uri="{BB962C8B-B14F-4D97-AF65-F5344CB8AC3E}">
-        <ns3:creationId val="493655609"/>
+        <ns3:creationId val="973498084"/>
       </p:ext>
     </p:extLst>
   </p:cSld>
@@ -8345,7 +8416,7 @@
           <p:cNvPr id="18" name="">
             <a:extLst>
               <a:ext uri="{FF2B5EF4-FFF2-40B4-BE49-F238E27FC236}">
-                <ns2:creationId id="{EFD52110-1749-4B22-897C-50F129E4C93C}"/>
+                <ns2:creationId id="{EBEA033F-B51C-4A42-BD92-8F95D8DFF8D6}"/>
               </a:ext>
             </a:extLst>
           </p:cNvPr>
@@ -8406,7 +8477,7 @@
           <p:cNvPr id="2" name="">
             <a:extLst>
               <a:ext uri="{FF2B5EF4-FFF2-40B4-BE49-F238E27FC236}">
-                <ns2:creationId id="{0645EA86-3105-47EF-AEE0-D5224950F8E6}"/>
+                <ns2:creationId id="{20CB8627-FDE8-437F-A882-C9A138CB353C}"/>
               </a:ext>
             </a:extLst>
           </p:cNvPr>
@@ -8467,7 +8538,7 @@
           <p:cNvPr id="3" name="">
             <a:extLst>
               <a:ext uri="{FF2B5EF4-FFF2-40B4-BE49-F238E27FC236}">
-                <ns2:creationId id="{E457D6F9-F7A6-4E55-A7A7-9AFC5AE691CF}"/>
+                <ns2:creationId id="{81F1C627-B230-4141-AFEF-23ABD9CABFF7}"/>
               </a:ext>
             </a:extLst>
           </p:cNvPr>
@@ -8497,7 +8568,7 @@
           <p:cNvPr id="4" name="">
             <a:extLst>
               <a:ext uri="{FF2B5EF4-FFF2-40B4-BE49-F238E27FC236}">
-                <ns2:creationId id="{2AF911A6-34EF-4382-8BF7-B85B931B44A0}"/>
+                <ns2:creationId id="{E51370CC-CC39-4B2A-9988-16B46D80814D}"/>
               </a:ext>
             </a:extLst>
           </p:cNvPr>
@@ -8532,7 +8603,7 @@
           <p:cNvPr id="5" name="">
             <a:extLst>
               <a:ext uri="{FF2B5EF4-FFF2-40B4-BE49-F238E27FC236}">
-                <ns2:creationId id="{8C127637-7A32-44C0-98F6-E8FDE704D013}"/>
+                <ns2:creationId id="{D5E56EDE-A9A4-41FD-B7F4-637C9C87A493}"/>
               </a:ext>
             </a:extLst>
           </p:cNvPr>
@@ -8567,7 +8638,7 @@
           <p:cNvPr id="6" name="">
             <a:extLst>
               <a:ext uri="{FF2B5EF4-FFF2-40B4-BE49-F238E27FC236}">
-                <ns2:creationId id="{B72D9E9B-7B5C-4ACE-99C1-DBE097E85EEA}"/>
+                <ns2:creationId id="{06652A3C-B447-4479-82D9-351CB24FDD10}"/>
               </a:ext>
             </a:extLst>
           </p:cNvPr>
@@ -8628,7 +8699,7 @@
           <p:cNvPr id="7" name="">
             <a:extLst>
               <a:ext uri="{FF2B5EF4-FFF2-40B4-BE49-F238E27FC236}">
-                <ns2:creationId id="{6E1E1710-554A-484B-B02D-EE3E0F2399E2}"/>
+                <ns2:creationId id="{5FBEF1AB-B581-4230-A4E1-9885EA658F68}"/>
               </a:ext>
             </a:extLst>
           </p:cNvPr>
@@ -8689,7 +8760,7 @@
           <p:cNvPr id="8" name="">
             <a:extLst>
               <a:ext uri="{FF2B5EF4-FFF2-40B4-BE49-F238E27FC236}">
-                <ns2:creationId id="{DF32C0E1-AD76-4F3D-A6E9-6DAD83BC9836}"/>
+                <ns2:creationId id="{7FF7D088-6668-4556-B685-A9F95FA58718}"/>
               </a:ext>
             </a:extLst>
           </p:cNvPr>
@@ -8804,7 +8875,7 @@
           <p:cNvPr id="9" name="">
             <a:extLst>
               <a:ext uri="{FF2B5EF4-FFF2-40B4-BE49-F238E27FC236}">
-                <ns2:creationId id="{80E424DC-21F3-41C3-8015-3E15EE14604E}"/>
+                <ns2:creationId id="{31B92029-FD57-40D0-BE84-7BA5A28A8157}"/>
               </a:ext>
             </a:extLst>
           </p:cNvPr>
@@ -8865,7 +8936,7 @@
           <p:cNvPr id="10" name="">
             <a:extLst>
               <a:ext uri="{FF2B5EF4-FFF2-40B4-BE49-F238E27FC236}">
-                <ns2:creationId id="{B9C62C46-2888-42E3-B0AD-ED6C0AEB1DF0}"/>
+                <ns2:creationId id="{289D8CBD-8132-4140-B7AE-0FA7CA6A3A13}"/>
               </a:ext>
             </a:extLst>
           </p:cNvPr>
@@ -8926,7 +8997,7 @@
           <p:cNvPr id="11" name="">
             <a:extLst>
               <a:ext uri="{FF2B5EF4-FFF2-40B4-BE49-F238E27FC236}">
-                <ns2:creationId id="{B97882C0-8BF4-4658-808C-29D967B82B72}"/>
+                <ns2:creationId id="{E755EFEA-4739-4618-81DF-DE3B31514D05}"/>
               </a:ext>
             </a:extLst>
           </p:cNvPr>
@@ -9041,7 +9112,7 @@
           <p:cNvPr id="12" name="">
             <a:extLst>
               <a:ext uri="{FF2B5EF4-FFF2-40B4-BE49-F238E27FC236}">
-                <ns2:creationId id="{E087256C-FEFD-45AE-AD13-11B6448F12AC}"/>
+                <ns2:creationId id="{102A6503-94CC-4351-ABE1-96F2B8939D74}"/>
               </a:ext>
             </a:extLst>
           </p:cNvPr>
@@ -9102,7 +9173,7 @@
           <p:cNvPr id="13" name="">
             <a:extLst>
               <a:ext uri="{FF2B5EF4-FFF2-40B4-BE49-F238E27FC236}">
-                <ns2:creationId id="{0863743C-0840-4726-AE98-28B1912D939A}"/>
+                <ns2:creationId id="{514307C3-A8A3-40E8-BE42-79169850D47D}"/>
               </a:ext>
             </a:extLst>
           </p:cNvPr>
@@ -9163,7 +9234,7 @@
           <p:cNvPr id="14" name="">
             <a:extLst>
               <a:ext uri="{FF2B5EF4-FFF2-40B4-BE49-F238E27FC236}">
-                <ns2:creationId id="{90B7B5E7-AFF4-4C7C-A121-925057810BE0}"/>
+                <ns2:creationId id="{1AB3A372-1553-4D5D-B111-A450C9F9512A}"/>
               </a:ext>
             </a:extLst>
           </p:cNvPr>
@@ -9224,7 +9295,7 @@
           <p:cNvPr id="15" name="">
             <a:extLst>
               <a:ext uri="{FF2B5EF4-FFF2-40B4-BE49-F238E27FC236}">
-                <ns2:creationId id="{89D87A46-11C5-4945-A09F-D74FB0B18A3F}"/>
+                <ns2:creationId id="{BD30F1C1-3972-4117-BAA7-3067F6D9FDA0}"/>
               </a:ext>
             </a:extLst>
           </p:cNvPr>
@@ -9285,7 +9356,7 @@
           <p:cNvPr id="16" name="">
             <a:extLst>
               <a:ext uri="{FF2B5EF4-FFF2-40B4-BE49-F238E27FC236}">
-                <ns2:creationId id="{9D458F64-9F9D-483B-8A3B-8241B0DA15AE}"/>
+                <ns2:creationId id="{FE3EAA77-B397-44F1-BB0D-3049B9514DD7}"/>
               </a:ext>
             </a:extLst>
           </p:cNvPr>
@@ -9346,7 +9417,7 @@
           <p:cNvPr id="17" name="">
             <a:extLst>
               <a:ext uri="{FF2B5EF4-FFF2-40B4-BE49-F238E27FC236}">
-                <ns2:creationId id="{F49C27C0-0831-4620-A9AE-C38AE808B8F0}"/>
+                <ns2:creationId id="{981733F9-BFEE-4DAF-8EE9-C572732010B1}"/>
               </a:ext>
             </a:extLst>
           </p:cNvPr>
@@ -9405,7 +9476,7 @@
     </p:spTree>
     <p:extLst>
       <p:ext uri="{BB962C8B-B14F-4D97-AF65-F5344CB8AC3E}">
-        <ns3:creationId val="1735040732"/>
+        <ns3:creationId val="2132808003"/>
       </p:ext>
     </p:extLst>
   </p:cSld>
@@ -9416,6 +9487,1277 @@
 </file>
 
 <file path=ppt/slides/slide6.xml><?xml version="1.0" encoding="utf-8"?>
+<p:sld xmlns:a="http://schemas.openxmlformats.org/drawingml/2006/main" xmlns:ns2="http://schemas.microsoft.com/office/drawing/2014/main" xmlns:ns3="http://schemas.microsoft.com/office/powerpoint/2010/main" xmlns:p="http://schemas.openxmlformats.org/presentationml/2006/main">
+  <p:cSld>
+    <p:bg>
+      <p:bgPr>
+        <a:solidFill>
+          <a:srgbClr val="092642"/>
+        </a:solidFill>
+      </p:bgPr>
+    </p:bg>
+    <p:spTree>
+      <p:nvGrpSpPr>
+        <p:cNvPr id="1" name=""/>
+        <p:cNvGrpSpPr/>
+        <p:nvPr/>
+      </p:nvGrpSpPr>
+      <p:grpSpPr>
+        <a:xfrm/>
+      </p:grpSpPr>
+      <p:sp>
+        <p:nvSpPr>
+          <p:cNvPr id="24" name="">
+            <a:extLst>
+              <a:ext uri="{FF2B5EF4-FFF2-40B4-BE49-F238E27FC236}">
+                <ns2:creationId id="{C4127FC9-85F4-42D0-8B23-538043F0F2D5}"/>
+              </a:ext>
+            </a:extLst>
+          </p:cNvPr>
+          <p:cNvSpPr>
+            <a:spLocks noGrp="1"/>
+          </p:cNvSpPr>
+          <p:nvPr/>
+        </p:nvSpPr>
+        <p:spPr>
+          <a:xfrm>
+            <a:off x="590550" y="409575"/>
+            <a:ext cx="523875" cy="238125"/>
+          </a:xfrm>
+          <a:prstGeom prst="rect">
+            <a:avLst/>
+          </a:prstGeom>
+          <a:noFill/>
+          <a:ln w="0">
+            <a:noFill/>
+          </a:ln>
+        </p:spPr>
+        <p:txBody>
+          <a:bodyPr lIns="0" tIns="0" rIns="0" bIns="0" anchor="t">
+            <a:normAutofit fontScale="100000"/>
+          </a:bodyPr>
+          <a:lstStyle/>
+          <a:p>
+            <a:pPr algn="l">
+              <a:lnSpc>
+                <a:spcPct val="105000"/>
+              </a:lnSpc>
+              <a:buNone/>
+              <a:defRPr sz="975" b="1">
+                <a:solidFill>
+                  <a:srgbClr val="8FDCD1"/>
+                </a:solidFill>
+                <a:latin typeface="Arial"/>
+                <a:ea typeface="Arial"/>
+                <a:cs typeface="Arial"/>
+              </a:defRPr>
+            </a:pPr>
+            <a:r>
+              <a:rPr sz="975" b="1">
+                <a:solidFill>
+                  <a:srgbClr val="8FDCD1"/>
+                </a:solidFill>
+                <a:latin typeface="Arial"/>
+                <a:ea typeface="Arial"/>
+                <a:cs typeface="Arial"/>
+              </a:rPr>
+              <a:t>06</a:t>
+            </a:r>
+          </a:p>
+        </p:txBody>
+      </p:sp>
+      <p:sp>
+        <p:nvSpPr>
+          <p:cNvPr id="2" name="">
+            <a:extLst>
+              <a:ext uri="{FF2B5EF4-FFF2-40B4-BE49-F238E27FC236}">
+                <ns2:creationId id="{D361D015-D99B-4B91-AC20-40A167A95D2C}"/>
+              </a:ext>
+            </a:extLst>
+          </p:cNvPr>
+          <p:cNvSpPr>
+            <a:spLocks noGrp="1"/>
+          </p:cNvSpPr>
+          <p:nvPr/>
+        </p:nvSpPr>
+        <p:spPr>
+          <a:xfrm>
+            <a:off x="590550" y="723900"/>
+            <a:ext cx="10287000" cy="619125"/>
+          </a:xfrm>
+          <a:prstGeom prst="rect">
+            <a:avLst/>
+          </a:prstGeom>
+          <a:noFill/>
+          <a:ln w="0">
+            <a:noFill/>
+          </a:ln>
+        </p:spPr>
+        <p:txBody>
+          <a:bodyPr lIns="0" tIns="0" rIns="0" bIns="0" anchor="t">
+            <a:normAutofit fontScale="100000"/>
+          </a:bodyPr>
+          <a:lstStyle/>
+          <a:p>
+            <a:pPr algn="l">
+              <a:lnSpc>
+                <a:spcPct val="105000"/>
+              </a:lnSpc>
+              <a:buNone/>
+              <a:defRPr sz="2925" b="1">
+                <a:solidFill>
+                  <a:srgbClr val="FFFFFF"/>
+                </a:solidFill>
+                <a:latin typeface="Arial"/>
+                <a:ea typeface="Arial"/>
+                <a:cs typeface="Arial"/>
+              </a:defRPr>
+            </a:pPr>
+            <a:r>
+              <a:rPr sz="2925" b="1">
+                <a:solidFill>
+                  <a:srgbClr val="FFFFFF"/>
+                </a:solidFill>
+                <a:latin typeface="Arial"/>
+                <a:ea typeface="Arial"/>
+                <a:cs typeface="Arial"/>
+              </a:rPr>
+              <a:t>Business and operating trade-offs</a:t>
+            </a:r>
+          </a:p>
+        </p:txBody>
+      </p:sp>
+      <p:sp>
+        <p:nvSpPr>
+          <p:cNvPr id="3" name="">
+            <a:extLst>
+              <a:ext uri="{FF2B5EF4-FFF2-40B4-BE49-F238E27FC236}">
+                <ns2:creationId id="{D20640F6-97FB-4B4D-9706-2612DA554A31}"/>
+              </a:ext>
+            </a:extLst>
+          </p:cNvPr>
+          <p:cNvSpPr>
+            <a:spLocks noGrp="1"/>
+          </p:cNvSpPr>
+          <p:nvPr/>
+        </p:nvSpPr>
+        <p:spPr>
+          <a:xfrm>
+            <a:off x="590550" y="1381125"/>
+            <a:ext cx="647700" cy="47625"/>
+          </a:xfrm>
+          <a:prstGeom prst="rect">
+            <a:avLst/>
+          </a:prstGeom>
+          <a:solidFill>
+            <a:srgbClr val="52D8C7"/>
+          </a:solidFill>
+          <a:ln w="0">
+            <a:noFill/>
+          </a:ln>
+        </p:spPr>
+      </p:sp>
+      <p:sp>
+        <p:nvSpPr>
+          <p:cNvPr id="4" name="">
+            <a:extLst>
+              <a:ext uri="{FF2B5EF4-FFF2-40B4-BE49-F238E27FC236}">
+                <ns2:creationId id="{8CC5C817-D0C7-4969-8965-53808B25BC7D}"/>
+              </a:ext>
+            </a:extLst>
+          </p:cNvPr>
+          <p:cNvSpPr>
+            <a:spLocks noGrp="1"/>
+          </p:cNvSpPr>
+          <p:nvPr/>
+        </p:nvSpPr>
+        <p:spPr>
+          <a:xfrm>
+            <a:off x="666750" y="1809750"/>
+            <a:ext cx="5143500" cy="1428750"/>
+          </a:xfrm>
+          <a:prstGeom prst="roundRect">
+            <a:avLst>
+              <a:gd name="adj" fmla="val 12000"/>
+            </a:avLst>
+          </a:prstGeom>
+          <a:solidFill>
+            <a:srgbClr val="123E5C"/>
+          </a:solidFill>
+          <a:ln w="9525">
+            <a:solidFill>
+              <a:srgbClr val="285A78"/>
+            </a:solidFill>
+            <a:prstDash val="solid"/>
+          </a:ln>
+        </p:spPr>
+      </p:sp>
+      <p:sp>
+        <p:nvSpPr>
+          <p:cNvPr id="5" name="">
+            <a:extLst>
+              <a:ext uri="{FF2B5EF4-FFF2-40B4-BE49-F238E27FC236}">
+                <ns2:creationId id="{A468CB11-4B2B-4B26-9238-BFCAAC855B29}"/>
+              </a:ext>
+            </a:extLst>
+          </p:cNvPr>
+          <p:cNvSpPr>
+            <a:spLocks noGrp="1"/>
+          </p:cNvSpPr>
+          <p:nvPr/>
+        </p:nvSpPr>
+        <p:spPr>
+          <a:xfrm>
+            <a:off x="933450" y="2019300"/>
+            <a:ext cx="4572000" cy="304800"/>
+          </a:xfrm>
+          <a:prstGeom prst="rect">
+            <a:avLst/>
+          </a:prstGeom>
+          <a:noFill/>
+          <a:ln w="0">
+            <a:noFill/>
+          </a:ln>
+        </p:spPr>
+        <p:txBody>
+          <a:bodyPr lIns="0" tIns="0" rIns="0" bIns="0" anchor="t">
+            <a:normAutofit fontScale="100000"/>
+          </a:bodyPr>
+          <a:lstStyle/>
+          <a:p>
+            <a:pPr algn="l">
+              <a:lnSpc>
+                <a:spcPct val="105000"/>
+              </a:lnSpc>
+              <a:buNone/>
+              <a:defRPr sz="1500" b="1">
+                <a:solidFill>
+                  <a:srgbClr val="FFFFFF"/>
+                </a:solidFill>
+                <a:latin typeface="Arial"/>
+                <a:ea typeface="Arial"/>
+                <a:cs typeface="Arial"/>
+              </a:defRPr>
+            </a:pPr>
+            <a:r>
+              <a:rPr sz="1500" b="1">
+                <a:solidFill>
+                  <a:srgbClr val="FFFFFF"/>
+                </a:solidFill>
+                <a:latin typeface="Arial"/>
+                <a:ea typeface="Arial"/>
+                <a:cs typeface="Arial"/>
+              </a:rPr>
+              <a:t>Build workflow · rent capability</a:t>
+            </a:r>
+          </a:p>
+        </p:txBody>
+      </p:sp>
+      <p:sp>
+        <p:nvSpPr>
+          <p:cNvPr id="6" name="">
+            <a:extLst>
+              <a:ext uri="{FF2B5EF4-FFF2-40B4-BE49-F238E27FC236}">
+                <ns2:creationId id="{6F099A66-739A-4C95-9C0D-A74314C7B89F}"/>
+              </a:ext>
+            </a:extLst>
+          </p:cNvPr>
+          <p:cNvSpPr>
+            <a:spLocks noGrp="1"/>
+          </p:cNvSpPr>
+          <p:nvPr/>
+        </p:nvSpPr>
+        <p:spPr>
+          <a:xfrm>
+            <a:off x="933450" y="2438400"/>
+            <a:ext cx="4572000" cy="247650"/>
+          </a:xfrm>
+          <a:prstGeom prst="rect">
+            <a:avLst/>
+          </a:prstGeom>
+          <a:noFill/>
+          <a:ln w="0">
+            <a:noFill/>
+          </a:ln>
+        </p:spPr>
+        <p:txBody>
+          <a:bodyPr lIns="0" tIns="0" rIns="0" bIns="0" anchor="t">
+            <a:normAutofit fontScale="100000"/>
+          </a:bodyPr>
+          <a:lstStyle/>
+          <a:p>
+            <a:pPr algn="l">
+              <a:lnSpc>
+                <a:spcPct val="105000"/>
+              </a:lnSpc>
+              <a:buNone/>
+              <a:defRPr sz="1050" b="1">
+                <a:solidFill>
+                  <a:srgbClr val="8FDCD1"/>
+                </a:solidFill>
+                <a:latin typeface="Arial"/>
+                <a:ea typeface="Arial"/>
+                <a:cs typeface="Arial"/>
+              </a:defRPr>
+            </a:pPr>
+            <a:r>
+              <a:rPr sz="1050" b="1">
+                <a:solidFill>
+                  <a:srgbClr val="8FDCD1"/>
+                </a:solidFill>
+                <a:latin typeface="Arial"/>
+                <a:ea typeface="Arial"/>
+                <a:cs typeface="Arial"/>
+              </a:rPr>
+              <a:t>Own the merge, evaluation and safety logic</a:t>
+            </a:r>
+          </a:p>
+        </p:txBody>
+      </p:sp>
+      <p:sp>
+        <p:nvSpPr>
+          <p:cNvPr id="7" name="">
+            <a:extLst>
+              <a:ext uri="{FF2B5EF4-FFF2-40B4-BE49-F238E27FC236}">
+                <ns2:creationId id="{38C5623B-E7E3-49DB-A68A-DA899B6A4A71}"/>
+              </a:ext>
+            </a:extLst>
+          </p:cNvPr>
+          <p:cNvSpPr>
+            <a:spLocks noGrp="1"/>
+          </p:cNvSpPr>
+          <p:nvPr/>
+        </p:nvSpPr>
+        <p:spPr>
+          <a:xfrm>
+            <a:off x="933450" y="2790825"/>
+            <a:ext cx="4572000" cy="228600"/>
+          </a:xfrm>
+          <a:prstGeom prst="rect">
+            <a:avLst/>
+          </a:prstGeom>
+          <a:noFill/>
+          <a:ln w="0">
+            <a:noFill/>
+          </a:ln>
+        </p:spPr>
+        <p:txBody>
+          <a:bodyPr lIns="0" tIns="0" rIns="0" bIns="0" anchor="t">
+            <a:normAutofit fontScale="100000"/>
+          </a:bodyPr>
+          <a:lstStyle/>
+          <a:p>
+            <a:pPr algn="l">
+              <a:lnSpc>
+                <a:spcPct val="105000"/>
+              </a:lnSpc>
+              <a:buNone/>
+              <a:defRPr sz="975" b="0">
+                <a:solidFill>
+                  <a:srgbClr val="BDD1DF"/>
+                </a:solidFill>
+                <a:latin typeface="Arial"/>
+                <a:ea typeface="Arial"/>
+                <a:cs typeface="Arial"/>
+              </a:defRPr>
+            </a:pPr>
+            <a:r>
+              <a:rPr sz="975" b="0">
+                <a:solidFill>
+                  <a:srgbClr val="BDD1DF"/>
+                </a:solidFill>
+                <a:latin typeface="Arial"/>
+                <a:ea typeface="Arial"/>
+                <a:cs typeface="Arial"/>
+              </a:rPr>
+              <a:t>Provider cost and dependency</a:t>
+            </a:r>
+          </a:p>
+        </p:txBody>
+      </p:sp>
+      <p:sp>
+        <p:nvSpPr>
+          <p:cNvPr id="8" name="">
+            <a:extLst>
+              <a:ext uri="{FF2B5EF4-FFF2-40B4-BE49-F238E27FC236}">
+                <ns2:creationId id="{1A7990A9-7578-4340-A631-6C00BB922B47}"/>
+              </a:ext>
+            </a:extLst>
+          </p:cNvPr>
+          <p:cNvSpPr>
+            <a:spLocks noGrp="1"/>
+          </p:cNvSpPr>
+          <p:nvPr/>
+        </p:nvSpPr>
+        <p:spPr>
+          <a:xfrm>
+            <a:off x="6191250" y="1809750"/>
+            <a:ext cx="5143500" cy="1428750"/>
+          </a:xfrm>
+          <a:prstGeom prst="roundRect">
+            <a:avLst>
+              <a:gd name="adj" fmla="val 12000"/>
+            </a:avLst>
+          </a:prstGeom>
+          <a:solidFill>
+            <a:srgbClr val="123E5C"/>
+          </a:solidFill>
+          <a:ln w="9525">
+            <a:solidFill>
+              <a:srgbClr val="285A78"/>
+            </a:solidFill>
+            <a:prstDash val="solid"/>
+          </a:ln>
+        </p:spPr>
+      </p:sp>
+      <p:sp>
+        <p:nvSpPr>
+          <p:cNvPr id="9" name="">
+            <a:extLst>
+              <a:ext uri="{FF2B5EF4-FFF2-40B4-BE49-F238E27FC236}">
+                <ns2:creationId id="{5C3C3753-550C-497E-BA50-71591668B89E}"/>
+              </a:ext>
+            </a:extLst>
+          </p:cNvPr>
+          <p:cNvSpPr>
+            <a:spLocks noGrp="1"/>
+          </p:cNvSpPr>
+          <p:nvPr/>
+        </p:nvSpPr>
+        <p:spPr>
+          <a:xfrm>
+            <a:off x="6457950" y="2019300"/>
+            <a:ext cx="4572000" cy="304800"/>
+          </a:xfrm>
+          <a:prstGeom prst="rect">
+            <a:avLst/>
+          </a:prstGeom>
+          <a:noFill/>
+          <a:ln w="0">
+            <a:noFill/>
+          </a:ln>
+        </p:spPr>
+        <p:txBody>
+          <a:bodyPr lIns="0" tIns="0" rIns="0" bIns="0" anchor="t">
+            <a:normAutofit fontScale="100000"/>
+          </a:bodyPr>
+          <a:lstStyle/>
+          <a:p>
+            <a:pPr algn="l">
+              <a:lnSpc>
+                <a:spcPct val="105000"/>
+              </a:lnSpc>
+              <a:buNone/>
+              <a:defRPr sz="1500" b="1">
+                <a:solidFill>
+                  <a:srgbClr val="FFFFFF"/>
+                </a:solidFill>
+                <a:latin typeface="Arial"/>
+                <a:ea typeface="Arial"/>
+                <a:cs typeface="Arial"/>
+              </a:defRPr>
+            </a:pPr>
+            <a:r>
+              <a:rPr sz="1500" b="1">
+                <a:solidFill>
+                  <a:srgbClr val="FFFFFF"/>
+                </a:solidFill>
+                <a:latin typeface="Arial"/>
+                <a:ea typeface="Arial"/>
+                <a:cs typeface="Arial"/>
+              </a:rPr>
+              <a:t>Narrow OAuth connectors</a:t>
+            </a:r>
+          </a:p>
+        </p:txBody>
+      </p:sp>
+      <p:sp>
+        <p:nvSpPr>
+          <p:cNvPr id="10" name="">
+            <a:extLst>
+              <a:ext uri="{FF2B5EF4-FFF2-40B4-BE49-F238E27FC236}">
+                <ns2:creationId id="{0099850A-6C51-4B63-A406-983EC9C14ACF}"/>
+              </a:ext>
+            </a:extLst>
+          </p:cNvPr>
+          <p:cNvSpPr>
+            <a:spLocks noGrp="1"/>
+          </p:cNvSpPr>
+          <p:nvPr/>
+        </p:nvSpPr>
+        <p:spPr>
+          <a:xfrm>
+            <a:off x="6457950" y="2438400"/>
+            <a:ext cx="4572000" cy="247650"/>
+          </a:xfrm>
+          <a:prstGeom prst="rect">
+            <a:avLst/>
+          </a:prstGeom>
+          <a:noFill/>
+          <a:ln w="0">
+            <a:noFill/>
+          </a:ln>
+        </p:spPr>
+        <p:txBody>
+          <a:bodyPr lIns="0" tIns="0" rIns="0" bIns="0" anchor="t">
+            <a:normAutofit fontScale="100000"/>
+          </a:bodyPr>
+          <a:lstStyle/>
+          <a:p>
+            <a:pPr algn="l">
+              <a:lnSpc>
+                <a:spcPct val="105000"/>
+              </a:lnSpc>
+              <a:buNone/>
+              <a:defRPr sz="1050" b="1">
+                <a:solidFill>
+                  <a:srgbClr val="8FDCD1"/>
+                </a:solidFill>
+                <a:latin typeface="Arial"/>
+                <a:ea typeface="Arial"/>
+                <a:cs typeface="Arial"/>
+              </a:defRPr>
+            </a:pPr>
+            <a:r>
+              <a:rPr sz="1050" b="1">
+                <a:solidFill>
+                  <a:srgbClr val="8FDCD1"/>
+                </a:solidFill>
+                <a:latin typeface="Arial"/>
+                <a:ea typeface="Arial"/>
+                <a:cs typeface="Arial"/>
+              </a:rPr>
+              <a:t>No manual email copy-paste</a:t>
+            </a:r>
+          </a:p>
+        </p:txBody>
+      </p:sp>
+      <p:sp>
+        <p:nvSpPr>
+          <p:cNvPr id="11" name="">
+            <a:extLst>
+              <a:ext uri="{FF2B5EF4-FFF2-40B4-BE49-F238E27FC236}">
+                <ns2:creationId id="{5BFC2125-79C9-4D3D-8166-1834D8B1F1D7}"/>
+              </a:ext>
+            </a:extLst>
+          </p:cNvPr>
+          <p:cNvSpPr>
+            <a:spLocks noGrp="1"/>
+          </p:cNvSpPr>
+          <p:nvPr/>
+        </p:nvSpPr>
+        <p:spPr>
+          <a:xfrm>
+            <a:off x="6457950" y="2790825"/>
+            <a:ext cx="4572000" cy="228600"/>
+          </a:xfrm>
+          <a:prstGeom prst="rect">
+            <a:avLst/>
+          </a:prstGeom>
+          <a:noFill/>
+          <a:ln w="0">
+            <a:noFill/>
+          </a:ln>
+        </p:spPr>
+        <p:txBody>
+          <a:bodyPr lIns="0" tIns="0" rIns="0" bIns="0" anchor="t">
+            <a:normAutofit fontScale="100000"/>
+          </a:bodyPr>
+          <a:lstStyle/>
+          <a:p>
+            <a:pPr algn="l">
+              <a:lnSpc>
+                <a:spcPct val="105000"/>
+              </a:lnSpc>
+              <a:buNone/>
+              <a:defRPr sz="975" b="0">
+                <a:solidFill>
+                  <a:srgbClr val="BDD1DF"/>
+                </a:solidFill>
+                <a:latin typeface="Arial"/>
+                <a:ea typeface="Arial"/>
+                <a:cs typeface="Arial"/>
+              </a:defRPr>
+            </a:pPr>
+            <a:r>
+              <a:rPr sz="975" b="0">
+                <a:solidFill>
+                  <a:srgbClr val="BDD1DF"/>
+                </a:solidFill>
+                <a:latin typeface="Arial"/>
+                <a:ea typeface="Arial"/>
+                <a:cs typeface="Arial"/>
+              </a:rPr>
+              <a:t>Tenant policy can block access</a:t>
+            </a:r>
+          </a:p>
+        </p:txBody>
+      </p:sp>
+      <p:sp>
+        <p:nvSpPr>
+          <p:cNvPr id="12" name="">
+            <a:extLst>
+              <a:ext uri="{FF2B5EF4-FFF2-40B4-BE49-F238E27FC236}">
+                <ns2:creationId id="{411574F2-B5C2-4734-94A6-EAA255C5F5D4}"/>
+              </a:ext>
+            </a:extLst>
+          </p:cNvPr>
+          <p:cNvSpPr>
+            <a:spLocks noGrp="1"/>
+          </p:cNvSpPr>
+          <p:nvPr/>
+        </p:nvSpPr>
+        <p:spPr>
+          <a:xfrm>
+            <a:off x="666750" y="3619500"/>
+            <a:ext cx="5143500" cy="1428750"/>
+          </a:xfrm>
+          <a:prstGeom prst="roundRect">
+            <a:avLst>
+              <a:gd name="adj" fmla="val 12000"/>
+            </a:avLst>
+          </a:prstGeom>
+          <a:solidFill>
+            <a:srgbClr val="123E5C"/>
+          </a:solidFill>
+          <a:ln w="9525">
+            <a:solidFill>
+              <a:srgbClr val="285A78"/>
+            </a:solidFill>
+            <a:prstDash val="solid"/>
+          </a:ln>
+        </p:spPr>
+      </p:sp>
+      <p:sp>
+        <p:nvSpPr>
+          <p:cNvPr id="13" name="">
+            <a:extLst>
+              <a:ext uri="{FF2B5EF4-FFF2-40B4-BE49-F238E27FC236}">
+                <ns2:creationId id="{27011410-7693-43D9-863A-312F5D6E0827}"/>
+              </a:ext>
+            </a:extLst>
+          </p:cNvPr>
+          <p:cNvSpPr>
+            <a:spLocks noGrp="1"/>
+          </p:cNvSpPr>
+          <p:nvPr/>
+        </p:nvSpPr>
+        <p:spPr>
+          <a:xfrm>
+            <a:off x="933450" y="3829050"/>
+            <a:ext cx="4572000" cy="304800"/>
+          </a:xfrm>
+          <a:prstGeom prst="rect">
+            <a:avLst/>
+          </a:prstGeom>
+          <a:noFill/>
+          <a:ln w="0">
+            <a:noFill/>
+          </a:ln>
+        </p:spPr>
+        <p:txBody>
+          <a:bodyPr lIns="0" tIns="0" rIns="0" bIns="0" anchor="t">
+            <a:normAutofit fontScale="100000"/>
+          </a:bodyPr>
+          <a:lstStyle/>
+          <a:p>
+            <a:pPr algn="l">
+              <a:lnSpc>
+                <a:spcPct val="105000"/>
+              </a:lnSpc>
+              <a:buNone/>
+              <a:defRPr sz="1500" b="1">
+                <a:solidFill>
+                  <a:srgbClr val="FFFFFF"/>
+                </a:solidFill>
+                <a:latin typeface="Arial"/>
+                <a:ea typeface="Arial"/>
+                <a:cs typeface="Arial"/>
+              </a:defRPr>
+            </a:pPr>
+            <a:r>
+              <a:rPr sz="1500" b="1">
+                <a:solidFill>
+                  <a:srgbClr val="FFFFFF"/>
+                </a:solidFill>
+                <a:latin typeface="Arial"/>
+                <a:ea typeface="Arial"/>
+                <a:cs typeface="Arial"/>
+              </a:rPr>
+              <a:t>Metadata first</a:t>
+            </a:r>
+          </a:p>
+        </p:txBody>
+      </p:sp>
+      <p:sp>
+        <p:nvSpPr>
+          <p:cNvPr id="14" name="">
+            <a:extLst>
+              <a:ext uri="{FF2B5EF4-FFF2-40B4-BE49-F238E27FC236}">
+                <ns2:creationId id="{063746D9-4300-4284-9446-833980DDA04D}"/>
+              </a:ext>
+            </a:extLst>
+          </p:cNvPr>
+          <p:cNvSpPr>
+            <a:spLocks noGrp="1"/>
+          </p:cNvSpPr>
+          <p:nvPr/>
+        </p:nvSpPr>
+        <p:spPr>
+          <a:xfrm>
+            <a:off x="933450" y="4248150"/>
+            <a:ext cx="4572000" cy="247650"/>
+          </a:xfrm>
+          <a:prstGeom prst="rect">
+            <a:avLst/>
+          </a:prstGeom>
+          <a:noFill/>
+          <a:ln w="0">
+            <a:noFill/>
+          </a:ln>
+        </p:spPr>
+        <p:txBody>
+          <a:bodyPr lIns="0" tIns="0" rIns="0" bIns="0" anchor="t">
+            <a:normAutofit fontScale="100000"/>
+          </a:bodyPr>
+          <a:lstStyle/>
+          <a:p>
+            <a:pPr algn="l">
+              <a:lnSpc>
+                <a:spcPct val="105000"/>
+              </a:lnSpc>
+              <a:buNone/>
+              <a:defRPr sz="1050" b="1">
+                <a:solidFill>
+                  <a:srgbClr val="8FDCD1"/>
+                </a:solidFill>
+                <a:latin typeface="Arial"/>
+                <a:ea typeface="Arial"/>
+                <a:cs typeface="Arial"/>
+              </a:defRPr>
+            </a:pPr>
+            <a:r>
+              <a:rPr sz="1050" b="1">
+                <a:solidFill>
+                  <a:srgbClr val="8FDCD1"/>
+                </a:solidFill>
+                <a:latin typeface="Arial"/>
+                <a:ea typeface="Arial"/>
+                <a:cs typeface="Arial"/>
+              </a:rPr>
+              <a:t>Model runs only for new or changed mail</a:t>
+            </a:r>
+          </a:p>
+        </p:txBody>
+      </p:sp>
+      <p:sp>
+        <p:nvSpPr>
+          <p:cNvPr id="15" name="">
+            <a:extLst>
+              <a:ext uri="{FF2B5EF4-FFF2-40B4-BE49-F238E27FC236}">
+                <ns2:creationId id="{461216CC-BC60-4B06-B0A6-160B6899D158}"/>
+              </a:ext>
+            </a:extLst>
+          </p:cNvPr>
+          <p:cNvSpPr>
+            <a:spLocks noGrp="1"/>
+          </p:cNvSpPr>
+          <p:nvPr/>
+        </p:nvSpPr>
+        <p:spPr>
+          <a:xfrm>
+            <a:off x="933450" y="4600575"/>
+            <a:ext cx="4572000" cy="228600"/>
+          </a:xfrm>
+          <a:prstGeom prst="rect">
+            <a:avLst/>
+          </a:prstGeom>
+          <a:noFill/>
+          <a:ln w="0">
+            <a:noFill/>
+          </a:ln>
+        </p:spPr>
+        <p:txBody>
+          <a:bodyPr lIns="0" tIns="0" rIns="0" bIns="0" anchor="t">
+            <a:normAutofit fontScale="100000"/>
+          </a:bodyPr>
+          <a:lstStyle/>
+          <a:p>
+            <a:pPr algn="l">
+              <a:lnSpc>
+                <a:spcPct val="105000"/>
+              </a:lnSpc>
+              <a:buNone/>
+              <a:defRPr sz="975" b="0">
+                <a:solidFill>
+                  <a:srgbClr val="BDD1DF"/>
+                </a:solidFill>
+                <a:latin typeface="Arial"/>
+                <a:ea typeface="Arial"/>
+                <a:cs typeface="Arial"/>
+              </a:defRPr>
+            </a:pPr>
+            <a:r>
+              <a:rPr sz="975" b="0">
+                <a:solidFill>
+                  <a:srgbClr val="BDD1DF"/>
+                </a:solidFill>
+                <a:latin typeface="Arial"/>
+                <a:ea typeface="Arial"/>
+                <a:cs typeface="Arial"/>
+              </a:rPr>
+              <a:t>Requires message-state tracking</a:t>
+            </a:r>
+          </a:p>
+        </p:txBody>
+      </p:sp>
+      <p:sp>
+        <p:nvSpPr>
+          <p:cNvPr id="16" name="">
+            <a:extLst>
+              <a:ext uri="{FF2B5EF4-FFF2-40B4-BE49-F238E27FC236}">
+                <ns2:creationId id="{B166382E-B510-47F4-86CF-1319AD52963C}"/>
+              </a:ext>
+            </a:extLst>
+          </p:cNvPr>
+          <p:cNvSpPr>
+            <a:spLocks noGrp="1"/>
+          </p:cNvSpPr>
+          <p:nvPr/>
+        </p:nvSpPr>
+        <p:spPr>
+          <a:xfrm>
+            <a:off x="6191250" y="3619500"/>
+            <a:ext cx="5143500" cy="1428750"/>
+          </a:xfrm>
+          <a:prstGeom prst="roundRect">
+            <a:avLst>
+              <a:gd name="adj" fmla="val 12000"/>
+            </a:avLst>
+          </a:prstGeom>
+          <a:solidFill>
+            <a:srgbClr val="E1F7F2"/>
+          </a:solidFill>
+          <a:ln w="9525">
+            <a:solidFill>
+              <a:srgbClr val="77D5C8"/>
+            </a:solidFill>
+            <a:prstDash val="solid"/>
+          </a:ln>
+        </p:spPr>
+      </p:sp>
+      <p:sp>
+        <p:nvSpPr>
+          <p:cNvPr id="17" name="">
+            <a:extLst>
+              <a:ext uri="{FF2B5EF4-FFF2-40B4-BE49-F238E27FC236}">
+                <ns2:creationId id="{CD4225E1-3333-431E-81DB-6216F842764B}"/>
+              </a:ext>
+            </a:extLst>
+          </p:cNvPr>
+          <p:cNvSpPr>
+            <a:spLocks noGrp="1"/>
+          </p:cNvSpPr>
+          <p:nvPr/>
+        </p:nvSpPr>
+        <p:spPr>
+          <a:xfrm>
+            <a:off x="6457950" y="3829050"/>
+            <a:ext cx="4572000" cy="304800"/>
+          </a:xfrm>
+          <a:prstGeom prst="rect">
+            <a:avLst/>
+          </a:prstGeom>
+          <a:noFill/>
+          <a:ln w="0">
+            <a:noFill/>
+          </a:ln>
+        </p:spPr>
+        <p:txBody>
+          <a:bodyPr lIns="0" tIns="0" rIns="0" bIns="0" anchor="t">
+            <a:normAutofit fontScale="100000"/>
+          </a:bodyPr>
+          <a:lstStyle/>
+          <a:p>
+            <a:pPr algn="l">
+              <a:lnSpc>
+                <a:spcPct val="105000"/>
+              </a:lnSpc>
+              <a:buNone/>
+              <a:defRPr sz="1500" b="1">
+                <a:solidFill>
+                  <a:srgbClr val="1C8C6B"/>
+                </a:solidFill>
+                <a:latin typeface="Arial"/>
+                <a:ea typeface="Arial"/>
+                <a:cs typeface="Arial"/>
+              </a:defRPr>
+            </a:pPr>
+            <a:r>
+              <a:rPr sz="1500" b="1">
+                <a:solidFill>
+                  <a:srgbClr val="1C8C6B"/>
+                </a:solidFill>
+                <a:latin typeface="Arial"/>
+                <a:ea typeface="Arial"/>
+                <a:cs typeface="Arial"/>
+              </a:rPr>
+              <a:t>Preview then approve</a:t>
+            </a:r>
+          </a:p>
+        </p:txBody>
+      </p:sp>
+      <p:sp>
+        <p:nvSpPr>
+          <p:cNvPr id="18" name="">
+            <a:extLst>
+              <a:ext uri="{FF2B5EF4-FFF2-40B4-BE49-F238E27FC236}">
+                <ns2:creationId id="{64153555-FEA3-43C1-A153-2E4AB859712E}"/>
+              </a:ext>
+            </a:extLst>
+          </p:cNvPr>
+          <p:cNvSpPr>
+            <a:spLocks noGrp="1"/>
+          </p:cNvSpPr>
+          <p:nvPr/>
+        </p:nvSpPr>
+        <p:spPr>
+          <a:xfrm>
+            <a:off x="6457950" y="4248150"/>
+            <a:ext cx="4572000" cy="247650"/>
+          </a:xfrm>
+          <a:prstGeom prst="rect">
+            <a:avLst/>
+          </a:prstGeom>
+          <a:noFill/>
+          <a:ln w="0">
+            <a:noFill/>
+          </a:ln>
+        </p:spPr>
+        <p:txBody>
+          <a:bodyPr lIns="0" tIns="0" rIns="0" bIns="0" anchor="t">
+            <a:normAutofit fontScale="100000"/>
+          </a:bodyPr>
+          <a:lstStyle/>
+          <a:p>
+            <a:pPr algn="l">
+              <a:lnSpc>
+                <a:spcPct val="105000"/>
+              </a:lnSpc>
+              <a:buNone/>
+              <a:defRPr sz="1050" b="1">
+                <a:solidFill>
+                  <a:srgbClr val="132B45"/>
+                </a:solidFill>
+                <a:latin typeface="Arial"/>
+                <a:ea typeface="Arial"/>
+                <a:cs typeface="Arial"/>
+              </a:defRPr>
+            </a:pPr>
+            <a:r>
+              <a:rPr sz="1050" b="1">
+                <a:solidFill>
+                  <a:srgbClr val="132B45"/>
+                </a:solidFill>
+                <a:latin typeface="Arial"/>
+                <a:ea typeface="Arial"/>
+                <a:cs typeface="Arial"/>
+              </a:rPr>
+              <a:t>Zero silent calendar writes</a:t>
+            </a:r>
+          </a:p>
+        </p:txBody>
+      </p:sp>
+      <p:sp>
+        <p:nvSpPr>
+          <p:cNvPr id="19" name="">
+            <a:extLst>
+              <a:ext uri="{FF2B5EF4-FFF2-40B4-BE49-F238E27FC236}">
+                <ns2:creationId id="{7362AB40-5BE8-41E6-994A-A6F30B74CAF2}"/>
+              </a:ext>
+            </a:extLst>
+          </p:cNvPr>
+          <p:cNvSpPr>
+            <a:spLocks noGrp="1"/>
+          </p:cNvSpPr>
+          <p:nvPr/>
+        </p:nvSpPr>
+        <p:spPr>
+          <a:xfrm>
+            <a:off x="6457950" y="4600575"/>
+            <a:ext cx="4572000" cy="228600"/>
+          </a:xfrm>
+          <a:prstGeom prst="rect">
+            <a:avLst/>
+          </a:prstGeom>
+          <a:noFill/>
+          <a:ln w="0">
+            <a:noFill/>
+          </a:ln>
+        </p:spPr>
+        <p:txBody>
+          <a:bodyPr lIns="0" tIns="0" rIns="0" bIns="0" anchor="t">
+            <a:normAutofit fontScale="100000"/>
+          </a:bodyPr>
+          <a:lstStyle/>
+          <a:p>
+            <a:pPr algn="l">
+              <a:lnSpc>
+                <a:spcPct val="105000"/>
+              </a:lnSpc>
+              <a:buNone/>
+              <a:defRPr sz="975" b="0">
+                <a:solidFill>
+                  <a:srgbClr val="66788D"/>
+                </a:solidFill>
+                <a:latin typeface="Arial"/>
+                <a:ea typeface="Arial"/>
+                <a:cs typeface="Arial"/>
+              </a:defRPr>
+            </a:pPr>
+            <a:r>
+              <a:rPr sz="975" b="0">
+                <a:solidFill>
+                  <a:srgbClr val="66788D"/>
+                </a:solidFill>
+                <a:latin typeface="Arial"/>
+                <a:ea typeface="Arial"/>
+                <a:cs typeface="Arial"/>
+              </a:rPr>
+              <a:t>One extra user step</a:t>
+            </a:r>
+          </a:p>
+        </p:txBody>
+      </p:sp>
+      <p:sp>
+        <p:nvSpPr>
+          <p:cNvPr id="20" name="">
+            <a:extLst>
+              <a:ext uri="{FF2B5EF4-FFF2-40B4-BE49-F238E27FC236}">
+                <ns2:creationId id="{2631B2C8-3575-442E-846D-14BB7627BE35}"/>
+              </a:ext>
+            </a:extLst>
+          </p:cNvPr>
+          <p:cNvSpPr>
+            <a:spLocks noGrp="1"/>
+          </p:cNvSpPr>
+          <p:nvPr/>
+        </p:nvSpPr>
+        <p:spPr>
+          <a:xfrm>
+            <a:off x="2333625" y="5638800"/>
+            <a:ext cx="7524750" cy="514350"/>
+          </a:xfrm>
+          <a:prstGeom prst="roundRect">
+            <a:avLst>
+              <a:gd name="adj" fmla="val 29630"/>
+            </a:avLst>
+          </a:prstGeom>
+          <a:solidFill>
+            <a:srgbClr val="0E887F"/>
+          </a:solidFill>
+          <a:ln w="0">
+            <a:noFill/>
+          </a:ln>
+        </p:spPr>
+      </p:sp>
+      <p:sp>
+        <p:nvSpPr>
+          <p:cNvPr id="21" name="">
+            <a:extLst>
+              <a:ext uri="{FF2B5EF4-FFF2-40B4-BE49-F238E27FC236}">
+                <ns2:creationId id="{A57C71EF-0846-4266-8A2F-0F245383A579}"/>
+              </a:ext>
+            </a:extLst>
+          </p:cNvPr>
+          <p:cNvSpPr>
+            <a:spLocks noGrp="1"/>
+          </p:cNvSpPr>
+          <p:nvPr/>
+        </p:nvSpPr>
+        <p:spPr>
+          <a:xfrm>
+            <a:off x="2571750" y="5781675"/>
+            <a:ext cx="7048500" cy="238125"/>
+          </a:xfrm>
+          <a:prstGeom prst="rect">
+            <a:avLst/>
+          </a:prstGeom>
+          <a:noFill/>
+          <a:ln w="0">
+            <a:noFill/>
+          </a:ln>
+        </p:spPr>
+        <p:txBody>
+          <a:bodyPr lIns="0" tIns="0" rIns="0" bIns="0" anchor="t">
+            <a:normAutofit fontScale="100000"/>
+          </a:bodyPr>
+          <a:lstStyle/>
+          <a:p>
+            <a:pPr algn="ctr">
+              <a:lnSpc>
+                <a:spcPct val="105000"/>
+              </a:lnSpc>
+              <a:buNone/>
+              <a:defRPr sz="1200" b="1">
+                <a:solidFill>
+                  <a:srgbClr val="FFFFFF"/>
+                </a:solidFill>
+                <a:latin typeface="Arial"/>
+                <a:ea typeface="Arial"/>
+                <a:cs typeface="Arial"/>
+              </a:defRPr>
+            </a:pPr>
+            <a:r>
+              <a:rPr sz="1200" b="1">
+                <a:solidFill>
+                  <a:srgbClr val="FFFFFF"/>
+                </a:solidFill>
+                <a:latin typeface="Arial"/>
+                <a:ea typeface="Arial"/>
+                <a:cs typeface="Arial"/>
+              </a:rPr>
+              <a:t>Measured live cost · 6 cases = US$0.01074 · about US$0.00179 per case</a:t>
+            </a:r>
+          </a:p>
+        </p:txBody>
+      </p:sp>
+      <p:sp>
+        <p:nvSpPr>
+          <p:cNvPr id="22" name="">
+            <a:extLst>
+              <a:ext uri="{FF2B5EF4-FFF2-40B4-BE49-F238E27FC236}">
+                <ns2:creationId id="{86E890A6-0ED6-4B74-85E7-7DEB64CDA7DF}"/>
+              </a:ext>
+            </a:extLst>
+          </p:cNvPr>
+          <p:cNvSpPr>
+            <a:spLocks noGrp="1"/>
+          </p:cNvSpPr>
+          <p:nvPr/>
+        </p:nvSpPr>
+        <p:spPr>
+          <a:xfrm>
+            <a:off x="590550" y="6515100"/>
+            <a:ext cx="4000500" cy="190500"/>
+          </a:xfrm>
+          <a:prstGeom prst="rect">
+            <a:avLst/>
+          </a:prstGeom>
+          <a:noFill/>
+          <a:ln w="0">
+            <a:noFill/>
+          </a:ln>
+        </p:spPr>
+        <p:txBody>
+          <a:bodyPr lIns="0" tIns="0" rIns="0" bIns="0" anchor="t">
+            <a:normAutofit fontScale="100000"/>
+          </a:bodyPr>
+          <a:lstStyle/>
+          <a:p>
+            <a:pPr algn="l">
+              <a:lnSpc>
+                <a:spcPct val="105000"/>
+              </a:lnSpc>
+              <a:buNone/>
+              <a:defRPr sz="825" b="0">
+                <a:solidFill>
+                  <a:srgbClr val="AFC5D5"/>
+                </a:solidFill>
+                <a:latin typeface="Arial"/>
+                <a:ea typeface="Arial"/>
+                <a:cs typeface="Arial"/>
+              </a:defRPr>
+            </a:pPr>
+            <a:r>
+              <a:rPr sz="825" b="0">
+                <a:solidFill>
+                  <a:srgbClr val="AFC5D5"/>
+                </a:solidFill>
+                <a:latin typeface="Arial"/>
+                <a:ea typeface="Arial"/>
+                <a:cs typeface="Arial"/>
+              </a:rPr>
+              <a:t>PE6201 Course Project · AI Scroll</a:t>
+            </a:r>
+          </a:p>
+        </p:txBody>
+      </p:sp>
+      <p:sp>
+        <p:nvSpPr>
+          <p:cNvPr id="23" name="">
+            <a:extLst>
+              <a:ext uri="{FF2B5EF4-FFF2-40B4-BE49-F238E27FC236}">
+                <ns2:creationId id="{E5E227F7-82E7-4E0F-8E99-851C8715230D}"/>
+              </a:ext>
+            </a:extLst>
+          </p:cNvPr>
+          <p:cNvSpPr>
+            <a:spLocks noGrp="1"/>
+          </p:cNvSpPr>
+          <p:nvPr/>
+        </p:nvSpPr>
+        <p:spPr>
+          <a:xfrm>
+            <a:off x="11287125" y="6515100"/>
+            <a:ext cx="285750" cy="190500"/>
+          </a:xfrm>
+          <a:prstGeom prst="rect">
+            <a:avLst/>
+          </a:prstGeom>
+          <a:noFill/>
+          <a:ln w="0">
+            <a:noFill/>
+          </a:ln>
+        </p:spPr>
+        <p:txBody>
+          <a:bodyPr lIns="0" tIns="0" rIns="0" bIns="0" anchor="t">
+            <a:normAutofit fontScale="100000"/>
+          </a:bodyPr>
+          <a:lstStyle/>
+          <a:p>
+            <a:pPr algn="r">
+              <a:lnSpc>
+                <a:spcPct val="105000"/>
+              </a:lnSpc>
+              <a:buNone/>
+              <a:defRPr sz="825" b="1">
+                <a:solidFill>
+                  <a:srgbClr val="AFC5D5"/>
+                </a:solidFill>
+                <a:latin typeface="Arial"/>
+                <a:ea typeface="Arial"/>
+                <a:cs typeface="Arial"/>
+              </a:defRPr>
+            </a:pPr>
+            <a:r>
+              <a:rPr sz="825" b="1">
+                <a:solidFill>
+                  <a:srgbClr val="AFC5D5"/>
+                </a:solidFill>
+                <a:latin typeface="Arial"/>
+                <a:ea typeface="Arial"/>
+                <a:cs typeface="Arial"/>
+              </a:rPr>
+              <a:t>6</a:t>
+            </a:r>
+          </a:p>
+        </p:txBody>
+      </p:sp>
+    </p:spTree>
+    <p:extLst>
+      <p:ext uri="{BB962C8B-B14F-4D97-AF65-F5344CB8AC3E}">
+        <ns3:creationId val="1024098287"/>
+      </p:ext>
+    </p:extLst>
+  </p:cSld>
+  <p:transition spd="slow" advClick="1">
+    <p:fade/>
+  </p:transition>
+</p:sld>
+</file>
+
+<file path=ppt/slides/slide7.xml><?xml version="1.0" encoding="utf-8"?>
 <p:sld xmlns:a="http://schemas.openxmlformats.org/drawingml/2006/main" xmlns:ns2="http://schemas.microsoft.com/office/drawing/2014/main" xmlns:ns4="http://schemas.microsoft.com/office/powerpoint/2010/main" xmlns:p="http://schemas.openxmlformats.org/presentationml/2006/main" xmlns:r="http://schemas.openxmlformats.org/officeDocument/2006/relationships">
   <p:cSld>
     <p:bg>
@@ -9439,7 +10781,7 @@
           <p:cNvPr id="11" name="">
             <a:extLst>
               <a:ext uri="{FF2B5EF4-FFF2-40B4-BE49-F238E27FC236}">
-                <ns2:creationId id="{5328E4E4-2BA4-442E-81A5-010DB8C3B1B9}"/>
+                <ns2:creationId id="{BBF1028D-6AD6-48CF-986A-D1AA536ED15D}"/>
               </a:ext>
             </a:extLst>
           </p:cNvPr>
@@ -9490,7 +10832,7 @@
                 <a:ea typeface="Arial"/>
                 <a:cs typeface="Arial"/>
               </a:rPr>
-              <a:t>06</a:t>
+              <a:t>07</a:t>
             </a:r>
           </a:p>
         </p:txBody>
@@ -9500,7 +10842,7 @@
           <p:cNvPr id="2" name="">
             <a:extLst>
               <a:ext uri="{FF2B5EF4-FFF2-40B4-BE49-F238E27FC236}">
-                <ns2:creationId id="{A1A529EC-2BCE-43FA-BB37-32DB33870D2D}"/>
+                <ns2:creationId id="{C7FB4C79-7F97-4869-B0C5-896B0EEFFE34}"/>
               </a:ext>
             </a:extLst>
           </p:cNvPr>
@@ -9561,7 +10903,7 @@
           <p:cNvPr id="3" name="">
             <a:extLst>
               <a:ext uri="{FF2B5EF4-FFF2-40B4-BE49-F238E27FC236}">
-                <ns2:creationId id="{F4F2C2F5-25D3-45E6-B681-BCA457686A89}"/>
+                <ns2:creationId id="{70E4FEBF-B5FF-4E99-AA75-79EA76F8FADB}"/>
               </a:ext>
             </a:extLst>
           </p:cNvPr>
@@ -9595,7 +10937,7 @@
           <p:nvPr/>
         </p:nvPicPr>
         <p:blipFill>
-          <a:blip r:embed="R7cb44073b2874f6f"/>
+          <a:blip r:embed="Rc5023013c3fc4b81"/>
           <a:stretch/>
         </p:blipFill>
         <p:spPr>
@@ -9615,7 +10957,7 @@
           <p:cNvPr id="5" name="">
             <a:extLst>
               <a:ext uri="{FF2B5EF4-FFF2-40B4-BE49-F238E27FC236}">
-                <ns2:creationId id="{FD5D79FF-6641-4D5C-A7B9-11CEFA5FFAD8}"/>
+                <ns2:creationId id="{74F72BE9-CD35-41BA-A139-9C55A9232D80}"/>
               </a:ext>
             </a:extLst>
           </p:cNvPr>
@@ -9647,7 +10989,7 @@
           <p:cNvPr id="6" name="">
             <a:extLst>
               <a:ext uri="{FF2B5EF4-FFF2-40B4-BE49-F238E27FC236}">
-                <ns2:creationId id="{663727A6-527D-4319-9313-319F3891F218}"/>
+                <ns2:creationId id="{08EE5162-BE99-4C64-8108-6A06E2431824}"/>
               </a:ext>
             </a:extLst>
           </p:cNvPr>
@@ -9708,7 +11050,7 @@
           <p:cNvPr id="7" name="">
             <a:extLst>
               <a:ext uri="{FF2B5EF4-FFF2-40B4-BE49-F238E27FC236}">
-                <ns2:creationId id="{A62C0153-D17F-4321-A475-1E9CC7893A20}"/>
+                <ns2:creationId id="{BAA8D6CE-7356-4B20-B574-182C7B0F8B2E}"/>
               </a:ext>
             </a:extLst>
           </p:cNvPr>
@@ -9740,7 +11082,7 @@
           <p:cNvPr id="8" name="">
             <a:extLst>
               <a:ext uri="{FF2B5EF4-FFF2-40B4-BE49-F238E27FC236}">
-                <ns2:creationId id="{49AC09D1-85BE-47FF-9932-C3817FD91001}"/>
+                <ns2:creationId id="{969C913A-7AF4-4BC9-A3A9-7AD5CB7F3935}"/>
               </a:ext>
             </a:extLst>
           </p:cNvPr>
@@ -9801,7 +11143,7 @@
           <p:cNvPr id="9" name="">
             <a:extLst>
               <a:ext uri="{FF2B5EF4-FFF2-40B4-BE49-F238E27FC236}">
-                <ns2:creationId id="{8A705258-2AF9-461F-9DEB-B53B17481339}"/>
+                <ns2:creationId id="{3E5A1E11-14DE-4E88-9D48-3A7AF6EB2235}"/>
               </a:ext>
             </a:extLst>
           </p:cNvPr>
@@ -9862,7 +11204,7 @@
           <p:cNvPr id="10" name="">
             <a:extLst>
               <a:ext uri="{FF2B5EF4-FFF2-40B4-BE49-F238E27FC236}">
-                <ns2:creationId id="{3D6072FE-6FA2-49A1-9F7D-8650C960D6E5}"/>
+                <ns2:creationId id="{205F4854-8BD9-4DAE-B346-AA97A336182C}"/>
               </a:ext>
             </a:extLst>
           </p:cNvPr>
@@ -9913,7 +11255,7 @@
                 <a:ea typeface="Arial"/>
                 <a:cs typeface="Arial"/>
               </a:rPr>
-              <a:t>6</a:t>
+              <a:t>7</a:t>
             </a:r>
           </a:p>
         </p:txBody>
@@ -9921,7 +11263,7 @@
     </p:spTree>
     <p:extLst>
       <p:ext uri="{BB962C8B-B14F-4D97-AF65-F5344CB8AC3E}">
-        <ns4:creationId val="2006565658"/>
+        <ns4:creationId val="2046798454"/>
       </p:ext>
     </p:extLst>
   </p:cSld>
@@ -9931,7 +11273,7 @@
 </p:sld>
 </file>
 
-<file path=ppt/slides/slide7.xml><?xml version="1.0" encoding="utf-8"?>
+<file path=ppt/slides/slide8.xml><?xml version="1.0" encoding="utf-8"?>
 <p:sld xmlns:a="http://schemas.openxmlformats.org/drawingml/2006/main" xmlns:ns2="http://schemas.microsoft.com/office/drawing/2014/main" xmlns:ns3="http://schemas.openxmlformats.org/drawingml/2006/chart" xmlns:ns5="http://schemas.microsoft.com/office/powerpoint/2010/main" xmlns:p="http://schemas.openxmlformats.org/presentationml/2006/main" xmlns:r="http://schemas.openxmlformats.org/officeDocument/2006/relationships">
   <p:cSld>
     <p:bg>
@@ -9955,7 +11297,7 @@
           <p:cNvPr id="18" name="">
             <a:extLst>
               <a:ext uri="{FF2B5EF4-FFF2-40B4-BE49-F238E27FC236}">
-                <ns2:creationId id="{B3E1D981-EBFD-4780-A70B-689FEE978104}"/>
+                <ns2:creationId id="{C8D33EA0-1777-4887-A521-80C2EC0D057F}"/>
               </a:ext>
             </a:extLst>
           </p:cNvPr>
@@ -10006,7 +11348,7 @@
                 <a:ea typeface="Arial"/>
                 <a:cs typeface="Arial"/>
               </a:rPr>
-              <a:t>07</a:t>
+              <a:t>08</a:t>
             </a:r>
           </a:p>
         </p:txBody>
@@ -10016,7 +11358,7 @@
           <p:cNvPr id="2" name="">
             <a:extLst>
               <a:ext uri="{FF2B5EF4-FFF2-40B4-BE49-F238E27FC236}">
-                <ns2:creationId id="{06417BA9-9E5A-4264-927E-C7C8AC8BF616}"/>
+                <ns2:creationId id="{C8DE8E1D-6783-491D-8AFC-136A3F3FFDE4}"/>
               </a:ext>
             </a:extLst>
           </p:cNvPr>
@@ -10067,7 +11409,7 @@
                 <a:ea typeface="Arial"/>
                 <a:cs typeface="Arial"/>
               </a:rPr>
-              <a:t>Current evidence and next steps</a:t>
+              <a:t>Evidence, controls and next steps</a:t>
             </a:r>
           </a:p>
         </p:txBody>
@@ -10077,7 +11419,7 @@
           <p:cNvPr id="3" name="">
             <a:extLst>
               <a:ext uri="{FF2B5EF4-FFF2-40B4-BE49-F238E27FC236}">
-                <ns2:creationId id="{9A015E98-83F6-4154-97D5-D81B07C59E4D}"/>
+                <ns2:creationId id="{7554284F-584C-4BEC-967E-E30F50BA952A}"/>
               </a:ext>
             </a:extLst>
           </p:cNvPr>
@@ -10114,7 +11456,7 @@
         </p:xfrm>
         <a:graphic>
           <a:graphicData uri="http://schemas.openxmlformats.org/drawingml/2006/chart">
-            <ns3:chart r:id="Rc7531b210907487f"/>
+            <ns3:chart r:id="R77d7fdcb0cea4c14"/>
           </a:graphicData>
         </a:graphic>
       </p:graphicFrame>
@@ -10123,7 +11465,7 @@
           <p:cNvPr id="5" name="">
             <a:extLst>
               <a:ext uri="{FF2B5EF4-FFF2-40B4-BE49-F238E27FC236}">
-                <ns2:creationId id="{5FE8E3B3-1127-4C2E-8432-BA447DE46BBD}"/>
+                <ns2:creationId id="{B746D3DF-C36E-458D-BD35-CEC238AA6C7A}"/>
               </a:ext>
             </a:extLst>
           </p:cNvPr>
@@ -10158,7 +11500,7 @@
           <p:cNvPr id="6" name="">
             <a:extLst>
               <a:ext uri="{FF2B5EF4-FFF2-40B4-BE49-F238E27FC236}">
-                <ns2:creationId id="{28E31766-4A3C-4623-B449-560406214042}"/>
+                <ns2:creationId id="{4D4E3459-7BC7-4A97-84C6-A16F313709CE}"/>
               </a:ext>
             </a:extLst>
           </p:cNvPr>
@@ -10219,7 +11561,7 @@
           <p:cNvPr id="7" name="">
             <a:extLst>
               <a:ext uri="{FF2B5EF4-FFF2-40B4-BE49-F238E27FC236}">
-                <ns2:creationId id="{E9FEFC75-22E1-4968-AA28-74F448A86FE7}"/>
+                <ns2:creationId id="{A736E3BD-FB99-45F2-B5FE-4A0AC402168F}"/>
               </a:ext>
             </a:extLst>
           </p:cNvPr>
@@ -10280,7 +11622,7 @@
           <p:cNvPr id="8" name="">
             <a:extLst>
               <a:ext uri="{FF2B5EF4-FFF2-40B4-BE49-F238E27FC236}">
-                <ns2:creationId id="{F643C2CD-DC68-471A-84E3-C94262622BFC}"/>
+                <ns2:creationId id="{1DC9020A-D0DF-4E22-81FA-766C36BA29EB}"/>
               </a:ext>
             </a:extLst>
           </p:cNvPr>
@@ -10315,7 +11657,7 @@
           <p:cNvPr id="9" name="">
             <a:extLst>
               <a:ext uri="{FF2B5EF4-FFF2-40B4-BE49-F238E27FC236}">
-                <ns2:creationId id="{38A536EA-6956-4CBD-ABD2-97E690D235DA}"/>
+                <ns2:creationId id="{C5B03AED-644D-4D05-ACAF-64FBD38E4B3F}"/>
               </a:ext>
             </a:extLst>
           </p:cNvPr>
@@ -10376,7 +11718,7 @@
           <p:cNvPr id="10" name="">
             <a:extLst>
               <a:ext uri="{FF2B5EF4-FFF2-40B4-BE49-F238E27FC236}">
-                <ns2:creationId id="{7F3C321C-B2B0-4D59-A2CA-8D989C335206}"/>
+                <ns2:creationId id="{6F1CFB84-3BE7-4AC8-B5BD-E8971137215A}"/>
               </a:ext>
             </a:extLst>
           </p:cNvPr>
@@ -10437,7 +11779,7 @@
           <p:cNvPr id="11" name="">
             <a:extLst>
               <a:ext uri="{FF2B5EF4-FFF2-40B4-BE49-F238E27FC236}">
-                <ns2:creationId id="{A2771677-A167-48E5-B7B4-A0D8625C0609}"/>
+                <ns2:creationId id="{BA3BE919-F8B4-4F37-83F3-ABEBABD03DAF}"/>
               </a:ext>
             </a:extLst>
           </p:cNvPr>
@@ -10472,7 +11814,7 @@
           <p:cNvPr id="12" name="">
             <a:extLst>
               <a:ext uri="{FF2B5EF4-FFF2-40B4-BE49-F238E27FC236}">
-                <ns2:creationId id="{7D4FC1D0-5D3F-49CE-92A6-B25676614C17}"/>
+                <ns2:creationId id="{D7BF1684-5274-4F8B-971F-23BD4B555877}"/>
               </a:ext>
             </a:extLst>
           </p:cNvPr>
@@ -10533,7 +11875,7 @@
           <p:cNvPr id="13" name="">
             <a:extLst>
               <a:ext uri="{FF2B5EF4-FFF2-40B4-BE49-F238E27FC236}">
-                <ns2:creationId id="{AC294677-211E-4A56-9F16-6678656F61FB}"/>
+                <ns2:creationId id="{368488BB-78F6-4E51-A22C-AB056CE13B82}"/>
               </a:ext>
             </a:extLst>
           </p:cNvPr>
@@ -10594,19 +11936,19 @@
           <p:cNvPr id="14" name="">
             <a:extLst>
               <a:ext uri="{FF2B5EF4-FFF2-40B4-BE49-F238E27FC236}">
-                <ns2:creationId id="{603C178E-AF1C-4C9B-8239-1F1002AA7FDE}"/>
-              </a:ext>
-            </a:extLst>
-          </p:cNvPr>
-          <p:cNvSpPr>
-            <a:spLocks noGrp="1"/>
-          </p:cNvSpPr>
-          <p:nvPr/>
-        </p:nvSpPr>
-        <p:spPr>
-          <a:xfrm>
-            <a:off x="8143875" y="5334000"/>
-            <a:ext cx="3238500" cy="552450"/>
+                <ns2:creationId id="{DB05A6E1-64EE-48B0-8D64-1193FD3E5554}"/>
+              </a:ext>
+            </a:extLst>
+          </p:cNvPr>
+          <p:cNvSpPr>
+            <a:spLocks noGrp="1"/>
+          </p:cNvSpPr>
+          <p:nvPr/>
+        </p:nvSpPr>
+        <p:spPr>
+          <a:xfrm>
+            <a:off x="8143875" y="5219700"/>
+            <a:ext cx="3238500" cy="590550"/>
           </a:xfrm>
           <a:prstGeom prst="rect">
             <a:avLst/>
@@ -10627,7 +11969,7 @@
                 <a:spcPct val="118000"/>
               </a:lnSpc>
               <a:buNone/>
-              <a:defRPr sz="1275" b="1">
+              <a:defRPr sz="1200" b="1">
                 <a:solidFill>
                   <a:srgbClr val="132B45"/>
                 </a:solidFill>
@@ -10637,7 +11979,7 @@
               </a:defRPr>
             </a:pPr>
             <a:r>
-              <a:rPr sz="1275" b="1">
+              <a:rPr sz="1200" b="1">
                 <a:solidFill>
                   <a:srgbClr val="132B45"/>
                 </a:solidFill>
@@ -10645,7 +11987,7 @@
                 <a:ea typeface="Arial"/>
                 <a:cs typeface="Arial"/>
               </a:rPr>
-              <a:t>Next: freeze the 50 human labels, run the final evaluation and record the live demo.</a:t>
+              <a:t>Controls: exact evidence · merge history · deduplication · human approval</a:t>
             </a:r>
           </a:p>
         </p:txBody>
@@ -10655,7 +11997,7 @@
           <p:cNvPr id="15" name="">
             <a:extLst>
               <a:ext uri="{FF2B5EF4-FFF2-40B4-BE49-F238E27FC236}">
-                <ns2:creationId id="{053A32B0-5DD1-41D1-A2ED-07E2875C263A}"/>
+                <ns2:creationId id="{A66F8B37-3A94-4435-9EB3-5484D1343AF3}"/>
               </a:ext>
             </a:extLst>
           </p:cNvPr>
@@ -10716,7 +12058,7 @@
           <p:cNvPr id="16" name="">
             <a:extLst>
               <a:ext uri="{FF2B5EF4-FFF2-40B4-BE49-F238E27FC236}">
-                <ns2:creationId id="{D1801D21-83CD-416E-B82E-08CA80F26F4D}"/>
+                <ns2:creationId id="{5D2ADA97-93EC-482C-9C22-C0A2F327145D}"/>
               </a:ext>
             </a:extLst>
           </p:cNvPr>
@@ -10777,7 +12119,7 @@
           <p:cNvPr id="17" name="">
             <a:extLst>
               <a:ext uri="{FF2B5EF4-FFF2-40B4-BE49-F238E27FC236}">
-                <ns2:creationId id="{CDCB9C36-5F6C-4C1E-B808-C0B6BB6AA9D0}"/>
+                <ns2:creationId id="{56426ED4-AC88-4A5F-B4C8-7FABEFDE78C3}"/>
               </a:ext>
             </a:extLst>
           </p:cNvPr>
@@ -10828,7 +12170,7 @@
                 <a:ea typeface="Arial"/>
                 <a:cs typeface="Arial"/>
               </a:rPr>
-              <a:t>7</a:t>
+              <a:t>8</a:t>
             </a:r>
           </a:p>
         </p:txBody>
@@ -10836,7 +12178,7 @@
     </p:spTree>
     <p:extLst>
       <p:ext uri="{BB962C8B-B14F-4D97-AF65-F5344CB8AC3E}">
-        <ns5:creationId val="759193211"/>
+        <ns5:creationId val="2117309812"/>
       </p:ext>
     </p:extLst>
   </p:cSld>

</xml_diff>